<commit_message>
docs: optimize PPTX and HTML slideshow layout and layout aesthetics
</commit_message>
<xml_diff>
--- a/presentation.pptx
+++ b/presentation.pptx
@@ -2242,8 +2242,8 @@
         </p:nvSpPr>
         <p:spPr>
           <a:xfrm>
-            <a:off x="548640" y="1645920"/>
-            <a:ext cx="5212080" cy="4389120"/>
+            <a:off x="548640" y="1463040"/>
+            <a:ext cx="5303520" cy="4663440"/>
           </a:xfrm>
           <a:prstGeom prst="roundRect">
             <a:avLst/>
@@ -2262,8 +2262,8 @@
         </p:nvSpPr>
         <p:spPr>
           <a:xfrm>
-            <a:off x="822960" y="1828800"/>
-            <a:ext cx="4663440" cy="365760"/>
+            <a:off x="822960" y="1645920"/>
+            <a:ext cx="4754880" cy="4297680"/>
           </a:xfrm>
           <a:prstGeom prst="rect">
             <a:avLst/>
@@ -2276,6 +2276,9 @@
           <a:lstStyle/>
           <a:p>
             <a:pPr indent="0" marL="0">
+              <a:lnSpc>
+                <a:spcPts val="2000"/>
+              </a:lnSpc>
               <a:buNone/>
             </a:pPr>
             <a:r>
@@ -2287,41 +2290,17 @@
                 <a:ea typeface="Microsoft YaHei" pitchFamily="34" charset="-122"/>
                 <a:cs typeface="Microsoft YaHei" pitchFamily="34" charset="-120"/>
               </a:rPr>
-              <a:t>💡 传统云原生运维与工程痛点</a:t>
-            </a:r>
-            <a:endParaRPr lang="en-US" sz="1800" dirty="0"/>
-          </a:p>
-        </p:txBody>
-      </p:sp>
-      <p:sp>
-        <p:nvSpPr>
-          <p:cNvPr id="9" name="Text 7"/>
-          <p:cNvSpPr/>
-          <p:nvPr/>
-        </p:nvSpPr>
-        <p:spPr>
-          <a:xfrm>
-            <a:off x="822960" y="2377440"/>
-            <a:ext cx="4663440" cy="3474720"/>
-          </a:xfrm>
-          <a:prstGeom prst="rect">
-            <a:avLst/>
-          </a:prstGeom>
-          <a:noFill/>
-          <a:ln/>
-        </p:spPr>
-        <p:txBody>
-          <a:bodyPr wrap="square" rtlCol="0" anchor="ctr"/>
-          <a:lstStyle/>
-          <a:p>
-            <a:pPr indent="0" marL="0">
-              <a:lnSpc>
-                <a:spcPts val="2200"/>
-              </a:lnSpc>
-              <a:buNone/>
-            </a:pPr>
-            <a:r>
-              <a:rPr lang="en-US" sz="1400" dirty="0">
+              <a:t>💡 传统云原生运维与实验痛点
+</a:t>
+            </a:r>
+            <a:pPr indent="0" marL="0">
+              <a:lnSpc>
+                <a:spcPts val="2000"/>
+              </a:lnSpc>
+              <a:buNone/>
+            </a:pPr>
+            <a:r>
+              <a:rPr lang="en-US" sz="1350" b="1" dirty="0">
                 <a:solidFill>
                   <a:srgbClr val="F8FAFC"/>
                 </a:solidFill>
@@ -2329,28 +2308,34 @@
                 <a:ea typeface="Microsoft YaHei" pitchFamily="34" charset="-122"/>
                 <a:cs typeface="Microsoft YaHei" pitchFamily="34" charset="-120"/>
               </a:rPr>
-              <a:t>• 纸上谈兵无实感：传统微服务实验多局限于静态配置与常规搭建，学生缺乏面对高并发下突发雪崩、网络抖动的真实演练体验。</a:t>
-            </a:r>
-            <a:endParaRPr lang="en-US" sz="1400" dirty="0"/>
-          </a:p>
-          <a:p>
-            <a:pPr indent="0" marL="0">
-              <a:lnSpc>
-                <a:spcPts val="2200"/>
-              </a:lnSpc>
-              <a:buNone/>
-            </a:pPr>
-            <a:endParaRPr lang="en-US" sz="1400" dirty="0"/>
-          </a:p>
-          <a:p>
-            <a:pPr indent="0" marL="0">
-              <a:lnSpc>
-                <a:spcPts val="2200"/>
-              </a:lnSpc>
-              <a:buNone/>
-            </a:pPr>
-            <a:r>
-              <a:rPr lang="en-US" sz="1400" dirty="0">
+              <a:t>• 纸上谈兵无实感：</a:t>
+            </a:r>
+            <a:pPr indent="0" marL="0">
+              <a:lnSpc>
+                <a:spcPts val="2000"/>
+              </a:lnSpc>
+              <a:buNone/>
+            </a:pPr>
+            <a:r>
+              <a:rPr lang="en-US" sz="1350" dirty="0">
+                <a:solidFill>
+                  <a:srgbClr val="94A3B8"/>
+                </a:solidFill>
+                <a:latin typeface="Microsoft YaHei" pitchFamily="34" charset="0"/>
+                <a:ea typeface="Microsoft YaHei" pitchFamily="34" charset="-122"/>
+                <a:cs typeface="Microsoft YaHei" pitchFamily="34" charset="-120"/>
+              </a:rPr>
+              <a:t>传统微服务实验多局限于静态配置与常规搭建，学生缺乏面对高并发下突发雪崩、网络抖动的真实演练体验。
+</a:t>
+            </a:r>
+            <a:pPr indent="0" marL="0">
+              <a:lnSpc>
+                <a:spcPts val="2000"/>
+              </a:lnSpc>
+              <a:buNone/>
+            </a:pPr>
+            <a:r>
+              <a:rPr lang="en-US" sz="1350" b="1" dirty="0">
                 <a:solidFill>
                   <a:srgbClr val="F8FAFC"/>
                 </a:solidFill>
@@ -2358,28 +2343,34 @@
                 <a:ea typeface="Microsoft YaHei" pitchFamily="34" charset="-122"/>
                 <a:cs typeface="Microsoft YaHei" pitchFamily="34" charset="-120"/>
               </a:rPr>
-              <a:t>• 可观测性门槛高：监控日志与底层资源排查错综复杂，缺乏高效且统一的时效和成本量化对比系统。</a:t>
-            </a:r>
-            <a:endParaRPr lang="en-US" sz="1400" dirty="0"/>
-          </a:p>
-          <a:p>
-            <a:pPr indent="0" marL="0">
-              <a:lnSpc>
-                <a:spcPts val="2200"/>
-              </a:lnSpc>
-              <a:buNone/>
-            </a:pPr>
-            <a:endParaRPr lang="en-US" sz="1400" dirty="0"/>
-          </a:p>
-          <a:p>
-            <a:pPr indent="0" marL="0">
-              <a:lnSpc>
-                <a:spcPts val="2200"/>
-              </a:lnSpc>
-              <a:buNone/>
-            </a:pPr>
-            <a:r>
-              <a:rPr lang="en-US" sz="1400" dirty="0">
+              <a:t>• 可观测性门槛高：</a:t>
+            </a:r>
+            <a:pPr indent="0" marL="0">
+              <a:lnSpc>
+                <a:spcPts val="2000"/>
+              </a:lnSpc>
+              <a:buNone/>
+            </a:pPr>
+            <a:r>
+              <a:rPr lang="en-US" sz="1350" dirty="0">
+                <a:solidFill>
+                  <a:srgbClr val="94A3B8"/>
+                </a:solidFill>
+                <a:latin typeface="Microsoft YaHei" pitchFamily="34" charset="0"/>
+                <a:ea typeface="Microsoft YaHei" pitchFamily="34" charset="-122"/>
+                <a:cs typeface="Microsoft YaHei" pitchFamily="34" charset="-120"/>
+              </a:rPr>
+              <a:t>监控日志与底层资源排查错综复杂，缺乏高效且统一的时效和成本量化对比系统。
+</a:t>
+            </a:r>
+            <a:pPr indent="0" marL="0">
+              <a:lnSpc>
+                <a:spcPts val="2000"/>
+              </a:lnSpc>
+              <a:buNone/>
+            </a:pPr>
+            <a:r>
+              <a:rPr lang="en-US" sz="1350" b="1" dirty="0">
                 <a:solidFill>
                   <a:srgbClr val="F8FAFC"/>
                 </a:solidFill>
@@ -2387,22 +2378,39 @@
                 <a:ea typeface="Microsoft YaHei" pitchFamily="34" charset="-122"/>
                 <a:cs typeface="Microsoft YaHei" pitchFamily="34" charset="-120"/>
               </a:rPr>
-              <a:t>• AI 结合流于表面：多停留在静态代码生成辅助，鲜有将 LLM 深入引入云原生动态观测、智能自愈等生产级场景。</a:t>
-            </a:r>
-            <a:endParaRPr lang="en-US" sz="1400" dirty="0"/>
-          </a:p>
-        </p:txBody>
-      </p:sp>
-      <p:sp>
-        <p:nvSpPr>
-          <p:cNvPr id="10" name="Shape 8"/>
-          <p:cNvSpPr/>
-          <p:nvPr/>
-        </p:nvSpPr>
-        <p:spPr>
-          <a:xfrm>
-            <a:off x="6400800" y="1645920"/>
-            <a:ext cx="5212080" cy="4389120"/>
+              <a:t>• AI 结合流于表面：</a:t>
+            </a:r>
+            <a:pPr indent="0" marL="0">
+              <a:lnSpc>
+                <a:spcPts val="2000"/>
+              </a:lnSpc>
+              <a:buNone/>
+            </a:pPr>
+            <a:r>
+              <a:rPr lang="en-US" sz="1350" dirty="0">
+                <a:solidFill>
+                  <a:srgbClr val="94A3B8"/>
+                </a:solidFill>
+                <a:latin typeface="Microsoft YaHei" pitchFamily="34" charset="0"/>
+                <a:ea typeface="Microsoft YaHei" pitchFamily="34" charset="-122"/>
+                <a:cs typeface="Microsoft YaHei" pitchFamily="34" charset="-120"/>
+              </a:rPr>
+              <a:t>多停留在静态代码生成辅助，鲜有将 LLM 深入引入云原生动态观测、智能自愈等生产级场景。</a:t>
+            </a:r>
+            <a:endParaRPr lang="en-US" sz="1350" dirty="0"/>
+          </a:p>
+        </p:txBody>
+      </p:sp>
+      <p:sp>
+        <p:nvSpPr>
+          <p:cNvPr id="9" name="Shape 7"/>
+          <p:cNvSpPr/>
+          <p:nvPr/>
+        </p:nvSpPr>
+        <p:spPr>
+          <a:xfrm>
+            <a:off x="6309360" y="1463040"/>
+            <a:ext cx="5303520" cy="4663440"/>
           </a:xfrm>
           <a:prstGeom prst="roundRect">
             <a:avLst/>
@@ -2415,14 +2423,14 @@
       </p:sp>
       <p:sp>
         <p:nvSpPr>
-          <p:cNvPr id="11" name="Text 9"/>
-          <p:cNvSpPr/>
-          <p:nvPr/>
-        </p:nvSpPr>
-        <p:spPr>
-          <a:xfrm>
-            <a:off x="6675120" y="1828800"/>
-            <a:ext cx="4663440" cy="365760"/>
+          <p:cNvPr id="10" name="Text 8"/>
+          <p:cNvSpPr/>
+          <p:nvPr/>
+        </p:nvSpPr>
+        <p:spPr>
+          <a:xfrm>
+            <a:off x="6583680" y="1645920"/>
+            <a:ext cx="4754880" cy="4297680"/>
           </a:xfrm>
           <a:prstGeom prst="rect">
             <a:avLst/>
@@ -2435,6 +2443,9 @@
           <a:lstStyle/>
           <a:p>
             <a:pPr indent="0" marL="0">
+              <a:lnSpc>
+                <a:spcPts val="2000"/>
+              </a:lnSpc>
               <a:buNone/>
             </a:pPr>
             <a:r>
@@ -2446,41 +2457,17 @@
                 <a:ea typeface="Microsoft YaHei" pitchFamily="34" charset="-122"/>
                 <a:cs typeface="Microsoft YaHei" pitchFamily="34" charset="-120"/>
               </a:rPr>
-              <a:t>🚒 Chaos Fire Drill 核心设计</a:t>
-            </a:r>
-            <a:endParaRPr lang="en-US" sz="1800" dirty="0"/>
-          </a:p>
-        </p:txBody>
-      </p:sp>
-      <p:sp>
-        <p:nvSpPr>
-          <p:cNvPr id="12" name="Text 10"/>
-          <p:cNvSpPr/>
-          <p:nvPr/>
-        </p:nvSpPr>
-        <p:spPr>
-          <a:xfrm>
-            <a:off x="6675120" y="2377440"/>
-            <a:ext cx="4663440" cy="3474720"/>
-          </a:xfrm>
-          <a:prstGeom prst="rect">
-            <a:avLst/>
-          </a:prstGeom>
-          <a:noFill/>
-          <a:ln/>
-        </p:spPr>
-        <p:txBody>
-          <a:bodyPr wrap="square" rtlCol="0" anchor="ctr"/>
-          <a:lstStyle/>
-          <a:p>
-            <a:pPr indent="0" marL="0">
-              <a:lnSpc>
-                <a:spcPts val="2200"/>
-              </a:lnSpc>
-              <a:buNone/>
-            </a:pPr>
-            <a:r>
-              <a:rPr lang="en-US" sz="1400" dirty="0">
+              <a:t>🚒 Chaos Fire Drill 核心设计
+</a:t>
+            </a:r>
+            <a:pPr indent="0" marL="0">
+              <a:lnSpc>
+                <a:spcPts val="2000"/>
+              </a:lnSpc>
+              <a:buNone/>
+            </a:pPr>
+            <a:r>
+              <a:rPr lang="en-US" sz="1350" b="1" dirty="0">
                 <a:solidFill>
                   <a:srgbClr val="F8FAFC"/>
                 </a:solidFill>
@@ -2488,28 +2475,34 @@
                 <a:ea typeface="Microsoft YaHei" pitchFamily="34" charset="-122"/>
                 <a:cs typeface="Microsoft YaHei" pitchFamily="34" charset="-120"/>
               </a:rPr>
-              <a:t>• 混沌工程游戏化 (消防演习)：将事故定位恢复等同于“灭火竞速”，把枯燥的微服务排障包装为富有趣味性与时间压力的竞技游戏。</a:t>
-            </a:r>
-            <a:endParaRPr lang="en-US" sz="1400" dirty="0"/>
-          </a:p>
-          <a:p>
-            <a:pPr indent="0" marL="0">
-              <a:lnSpc>
-                <a:spcPts val="2200"/>
-              </a:lnSpc>
-              <a:buNone/>
-            </a:pPr>
-            <a:endParaRPr lang="en-US" sz="1400" dirty="0"/>
-          </a:p>
-          <a:p>
-            <a:pPr indent="0" marL="0">
-              <a:lnSpc>
-                <a:spcPts val="2200"/>
-              </a:lnSpc>
-              <a:buNone/>
-            </a:pPr>
-            <a:r>
-              <a:rPr lang="en-US" sz="1400" dirty="0">
+              <a:t>• 混沌工程游戏化 (消防演习)：</a:t>
+            </a:r>
+            <a:pPr indent="0" marL="0">
+              <a:lnSpc>
+                <a:spcPts val="2000"/>
+              </a:lnSpc>
+              <a:buNone/>
+            </a:pPr>
+            <a:r>
+              <a:rPr lang="en-US" sz="1350" dirty="0">
+                <a:solidFill>
+                  <a:srgbClr val="94A3B8"/>
+                </a:solidFill>
+                <a:latin typeface="Microsoft YaHei" pitchFamily="34" charset="0"/>
+                <a:ea typeface="Microsoft YaHei" pitchFamily="34" charset="-122"/>
+                <a:cs typeface="Microsoft YaHei" pitchFamily="34" charset="-120"/>
+              </a:rPr>
+              <a:t>将事故定位恢复等同于“灭火竞速”，把枯燥的微服务排障包装为富有趣味性与时间压力的竞技游戏。
+</a:t>
+            </a:r>
+            <a:pPr indent="0" marL="0">
+              <a:lnSpc>
+                <a:spcPts val="2000"/>
+              </a:lnSpc>
+              <a:buNone/>
+            </a:pPr>
+            <a:r>
+              <a:rPr lang="en-US" sz="1350" b="1" dirty="0">
                 <a:solidFill>
                   <a:srgbClr val="F8FAFC"/>
                 </a:solidFill>
@@ -2517,28 +2510,34 @@
                 <a:ea typeface="Microsoft YaHei" pitchFamily="34" charset="-122"/>
                 <a:cs typeface="Microsoft YaHei" pitchFamily="34" charset="-120"/>
               </a:rPr>
-              <a:t>• 人机协同竞技 (人 vs AI Agent)：引入基于大模型的自愈智能体与人类选手同台竞速，直观评测 AI 与人类的运维决策差异。</a:t>
-            </a:r>
-            <a:endParaRPr lang="en-US" sz="1400" dirty="0"/>
-          </a:p>
-          <a:p>
-            <a:pPr indent="0" marL="0">
-              <a:lnSpc>
-                <a:spcPts val="2200"/>
-              </a:lnSpc>
-              <a:buNone/>
-            </a:pPr>
-            <a:endParaRPr lang="en-US" sz="1400" dirty="0"/>
-          </a:p>
-          <a:p>
-            <a:pPr indent="0" marL="0">
-              <a:lnSpc>
-                <a:spcPts val="2200"/>
-              </a:lnSpc>
-              <a:buNone/>
-            </a:pPr>
-            <a:r>
-              <a:rPr lang="en-US" sz="1400" dirty="0">
+              <a:t>• 人机协同竞技 (人 vs AI Agent)：</a:t>
+            </a:r>
+            <a:pPr indent="0" marL="0">
+              <a:lnSpc>
+                <a:spcPts val="2000"/>
+              </a:lnSpc>
+              <a:buNone/>
+            </a:pPr>
+            <a:r>
+              <a:rPr lang="en-US" sz="1350" dirty="0">
+                <a:solidFill>
+                  <a:srgbClr val="94A3B8"/>
+                </a:solidFill>
+                <a:latin typeface="Microsoft YaHei" pitchFamily="34" charset="0"/>
+                <a:ea typeface="Microsoft YaHei" pitchFamily="34" charset="-122"/>
+                <a:cs typeface="Microsoft YaHei" pitchFamily="34" charset="-120"/>
+              </a:rPr>
+              <a:t>引入基于大模型的自愈智能体与人类选手同台竞速，直观评测 AI 与人类的运维决策差异。
+</a:t>
+            </a:r>
+            <a:pPr indent="0" marL="0">
+              <a:lnSpc>
+                <a:spcPts val="2000"/>
+              </a:lnSpc>
+              <a:buNone/>
+            </a:pPr>
+            <a:r>
+              <a:rPr lang="en-US" sz="1350" b="1" dirty="0">
                 <a:solidFill>
                   <a:srgbClr val="F8FAFC"/>
                 </a:solidFill>
@@ -2546,9 +2545,26 @@
                 <a:ea typeface="Microsoft YaHei" pitchFamily="34" charset="-122"/>
                 <a:cs typeface="Microsoft YaHei" pitchFamily="34" charset="-120"/>
               </a:rPr>
-              <a:t>• 生产级纯生沙箱 (Live K8s Sandbox)：彻底抛弃伪模拟，所有的命令解析和注入彻底穿透、运行于真实的本地宿主集群。</a:t>
-            </a:r>
-            <a:endParaRPr lang="en-US" sz="1400" dirty="0"/>
+              <a:t>• 生产级纯生沙箱 (Live K8s Sandbox)：</a:t>
+            </a:r>
+            <a:pPr indent="0" marL="0">
+              <a:lnSpc>
+                <a:spcPts val="2000"/>
+              </a:lnSpc>
+              <a:buNone/>
+            </a:pPr>
+            <a:r>
+              <a:rPr lang="en-US" sz="1350" dirty="0">
+                <a:solidFill>
+                  <a:srgbClr val="94A3B8"/>
+                </a:solidFill>
+                <a:latin typeface="Microsoft YaHei" pitchFamily="34" charset="0"/>
+                <a:ea typeface="Microsoft YaHei" pitchFamily="34" charset="-122"/>
+                <a:cs typeface="Microsoft YaHei" pitchFamily="34" charset="-120"/>
+              </a:rPr>
+              <a:t>彻底抛弃伪模拟，所有的命令解析和注入彻底穿透、运行于真实的本地宿主集群。</a:t>
+            </a:r>
+            <a:endParaRPr lang="en-US" sz="1350" dirty="0"/>
           </a:p>
         </p:txBody>
       </p:sp>
@@ -2749,8 +2765,8 @@
         </p:nvSpPr>
         <p:spPr>
           <a:xfrm>
-            <a:off x="548640" y="1371600"/>
-            <a:ext cx="10972800" cy="365760"/>
+            <a:off x="548640" y="1280160"/>
+            <a:ext cx="10972800" cy="274320"/>
           </a:xfrm>
           <a:prstGeom prst="rect">
             <a:avLst/>
@@ -2788,8 +2804,8 @@
         </p:nvSpPr>
         <p:spPr>
           <a:xfrm>
-            <a:off x="548640" y="1920240"/>
-            <a:ext cx="2560320" cy="4023360"/>
+            <a:off x="548640" y="1737360"/>
+            <a:ext cx="2560320" cy="4389120"/>
           </a:xfrm>
           <a:prstGeom prst="roundRect">
             <a:avLst/>
@@ -2808,8 +2824,8 @@
         </p:nvSpPr>
         <p:spPr>
           <a:xfrm>
-            <a:off x="731520" y="2103120"/>
-            <a:ext cx="2194560" cy="548640"/>
+            <a:off x="731520" y="1920240"/>
+            <a:ext cx="2194560" cy="4023360"/>
           </a:xfrm>
           <a:prstGeom prst="rect">
             <a:avLst/>
@@ -2822,6 +2838,9 @@
           <a:lstStyle/>
           <a:p>
             <a:pPr indent="0" marL="0">
+              <a:lnSpc>
+                <a:spcPts val="1800"/>
+              </a:lnSpc>
               <a:buNone/>
             </a:pPr>
             <a:r>
@@ -2833,33 +2852,10 @@
                 <a:ea typeface="Microsoft YaHei" pitchFamily="34" charset="-122"/>
                 <a:cs typeface="Microsoft YaHei" pitchFamily="34" charset="-120"/>
               </a:rPr>
-              <a:t>📦 实验一：Docker 容器化</a:t>
-            </a:r>
-            <a:endParaRPr lang="en-US" sz="1600" dirty="0"/>
-          </a:p>
-        </p:txBody>
-      </p:sp>
-      <p:sp>
-        <p:nvSpPr>
-          <p:cNvPr id="10" name="Text 8"/>
-          <p:cNvSpPr/>
-          <p:nvPr/>
-        </p:nvSpPr>
-        <p:spPr>
-          <a:xfrm>
-            <a:off x="731520" y="2743200"/>
-            <a:ext cx="2194560" cy="3017520"/>
-          </a:xfrm>
-          <a:prstGeom prst="rect">
-            <a:avLst/>
-          </a:prstGeom>
-          <a:noFill/>
-          <a:ln/>
-        </p:spPr>
-        <p:txBody>
-          <a:bodyPr wrap="square" rtlCol="0" anchor="ctr"/>
-          <a:lstStyle/>
-          <a:p>
+              <a:t>📦 实验一
+Docker 容器化
+</a:t>
+            </a:r>
             <a:pPr indent="0" marL="0">
               <a:lnSpc>
                 <a:spcPts val="1800"/>
@@ -2867,19 +2863,17 @@
               <a:buNone/>
             </a:pPr>
             <a:r>
-              <a:rPr lang="en-US" sz="1300" dirty="0">
-                <a:solidFill>
-                  <a:srgbClr val="F8FAFC"/>
-                </a:solidFill>
-                <a:latin typeface="Microsoft YaHei" pitchFamily="34" charset="0"/>
-                <a:ea typeface="Microsoft YaHei" pitchFamily="34" charset="-122"/>
-                <a:cs typeface="Microsoft YaHei" pitchFamily="34" charset="-120"/>
-              </a:rPr>
-              <a:t>• 隔离基石</a:t>
-            </a:r>
-            <a:endParaRPr lang="en-US" sz="1300" dirty="0"/>
-          </a:p>
-          <a:p>
+              <a:rPr lang="en-US" sz="1250" dirty="0">
+                <a:solidFill>
+                  <a:srgbClr val="94A3B8"/>
+                </a:solidFill>
+                <a:latin typeface="Microsoft YaHei" pitchFamily="34" charset="0"/>
+                <a:ea typeface="Microsoft YaHei" pitchFamily="34" charset="-122"/>
+                <a:cs typeface="Microsoft YaHei" pitchFamily="34" charset="-120"/>
+              </a:rPr>
+              <a:t>• 物理资源底座
+</a:t>
+            </a:r>
             <a:pPr indent="0" marL="0">
               <a:lnSpc>
                 <a:spcPts val="1800"/>
@@ -2887,19 +2881,17 @@
               <a:buNone/>
             </a:pPr>
             <a:r>
-              <a:rPr lang="en-US" sz="1300" dirty="0">
-                <a:solidFill>
-                  <a:srgbClr val="F8FAFC"/>
-                </a:solidFill>
-                <a:latin typeface="Microsoft YaHei" pitchFamily="34" charset="0"/>
-                <a:ea typeface="Microsoft YaHei" pitchFamily="34" charset="-122"/>
-                <a:cs typeface="Microsoft YaHei" pitchFamily="34" charset="-120"/>
-              </a:rPr>
-              <a:t>• 镜像打包</a:t>
-            </a:r>
-            <a:endParaRPr lang="en-US" sz="1300" dirty="0"/>
-          </a:p>
-          <a:p>
+              <a:rPr lang="en-US" sz="1250" dirty="0">
+                <a:solidFill>
+                  <a:srgbClr val="94A3B8"/>
+                </a:solidFill>
+                <a:latin typeface="Microsoft YaHei" pitchFamily="34" charset="0"/>
+                <a:ea typeface="Microsoft YaHei" pitchFamily="34" charset="-122"/>
+                <a:cs typeface="Microsoft YaHei" pitchFamily="34" charset="-120"/>
+              </a:rPr>
+              <a:t>• 微服务镜像打包
+</a:t>
+            </a:r>
             <a:pPr indent="0" marL="0">
               <a:lnSpc>
                 <a:spcPts val="1800"/>
@@ -2907,30 +2899,48 @@
               <a:buNone/>
             </a:pPr>
             <a:r>
-              <a:rPr lang="en-US" sz="1300" dirty="0">
-                <a:solidFill>
-                  <a:srgbClr val="F8FAFC"/>
-                </a:solidFill>
-                <a:latin typeface="Microsoft YaHei" pitchFamily="34" charset="0"/>
-                <a:ea typeface="Microsoft YaHei" pitchFamily="34" charset="-122"/>
-                <a:cs typeface="Microsoft YaHei" pitchFamily="34" charset="-120"/>
-              </a:rPr>
-              <a:t>• 微服务组件打包发布，为后续沙箱环境奠定最小容器实体。</a:t>
-            </a:r>
-            <a:endParaRPr lang="en-US" sz="1300" dirty="0"/>
-          </a:p>
-        </p:txBody>
-      </p:sp>
-      <p:sp>
-        <p:nvSpPr>
-          <p:cNvPr id="11" name="Shape 9"/>
-          <p:cNvSpPr/>
-          <p:nvPr/>
-        </p:nvSpPr>
-        <p:spPr>
-          <a:xfrm>
-            <a:off x="3383280" y="1920240"/>
-            <a:ext cx="2560320" cy="4023360"/>
+              <a:rPr lang="en-US" sz="1250" dirty="0">
+                <a:solidFill>
+                  <a:srgbClr val="94A3B8"/>
+                </a:solidFill>
+                <a:latin typeface="Microsoft YaHei" pitchFamily="34" charset="0"/>
+                <a:ea typeface="Microsoft YaHei" pitchFamily="34" charset="-122"/>
+                <a:cs typeface="Microsoft YaHei" pitchFamily="34" charset="-120"/>
+              </a:rPr>
+              <a:t>• 容器物理资源分配
+</a:t>
+            </a:r>
+            <a:pPr indent="0" marL="0">
+              <a:lnSpc>
+                <a:spcPts val="1800"/>
+              </a:lnSpc>
+              <a:buNone/>
+            </a:pPr>
+            <a:r>
+              <a:rPr lang="en-US" sz="1250" dirty="0">
+                <a:solidFill>
+                  <a:srgbClr val="94A3B8"/>
+                </a:solidFill>
+                <a:latin typeface="Microsoft YaHei" pitchFamily="34" charset="0"/>
+                <a:ea typeface="Microsoft YaHei" pitchFamily="34" charset="-122"/>
+                <a:cs typeface="Microsoft YaHei" pitchFamily="34" charset="-120"/>
+              </a:rPr>
+              <a:t>为混沌注入器的环境污染与单节点 CPU 拉爆提供了基础隔离隔离手段。</a:t>
+            </a:r>
+            <a:endParaRPr lang="en-US" sz="1250" dirty="0"/>
+          </a:p>
+        </p:txBody>
+      </p:sp>
+      <p:sp>
+        <p:nvSpPr>
+          <p:cNvPr id="10" name="Shape 8"/>
+          <p:cNvSpPr/>
+          <p:nvPr/>
+        </p:nvSpPr>
+        <p:spPr>
+          <a:xfrm>
+            <a:off x="3383280" y="1737360"/>
+            <a:ext cx="2560320" cy="4389120"/>
           </a:xfrm>
           <a:prstGeom prst="roundRect">
             <a:avLst/>
@@ -2943,14 +2953,14 @@
       </p:sp>
       <p:sp>
         <p:nvSpPr>
-          <p:cNvPr id="12" name="Text 10"/>
-          <p:cNvSpPr/>
-          <p:nvPr/>
-        </p:nvSpPr>
-        <p:spPr>
-          <a:xfrm>
-            <a:off x="3566160" y="2103120"/>
-            <a:ext cx="2194560" cy="548640"/>
+          <p:cNvPr id="11" name="Text 9"/>
+          <p:cNvSpPr/>
+          <p:nvPr/>
+        </p:nvSpPr>
+        <p:spPr>
+          <a:xfrm>
+            <a:off x="3566160" y="1920240"/>
+            <a:ext cx="2194560" cy="4023360"/>
           </a:xfrm>
           <a:prstGeom prst="rect">
             <a:avLst/>
@@ -2963,6 +2973,9 @@
           <a:lstStyle/>
           <a:p>
             <a:pPr indent="0" marL="0">
+              <a:lnSpc>
+                <a:spcPts val="1800"/>
+              </a:lnSpc>
               <a:buNone/>
             </a:pPr>
             <a:r>
@@ -2974,33 +2987,10 @@
                 <a:ea typeface="Microsoft YaHei" pitchFamily="34" charset="-122"/>
                 <a:cs typeface="Microsoft YaHei" pitchFamily="34" charset="-120"/>
               </a:rPr>
-              <a:t>☸️ 实验二：K8s 容器编排</a:t>
-            </a:r>
-            <a:endParaRPr lang="en-US" sz="1600" dirty="0"/>
-          </a:p>
-        </p:txBody>
-      </p:sp>
-      <p:sp>
-        <p:nvSpPr>
-          <p:cNvPr id="13" name="Text 11"/>
-          <p:cNvSpPr/>
-          <p:nvPr/>
-        </p:nvSpPr>
-        <p:spPr>
-          <a:xfrm>
-            <a:off x="3566160" y="2743200"/>
-            <a:ext cx="2194560" cy="3017520"/>
-          </a:xfrm>
-          <a:prstGeom prst="rect">
-            <a:avLst/>
-          </a:prstGeom>
-          <a:noFill/>
-          <a:ln/>
-        </p:spPr>
-        <p:txBody>
-          <a:bodyPr wrap="square" rtlCol="0" anchor="ctr"/>
-          <a:lstStyle/>
-          <a:p>
+              <a:t>☸️ 实验二
+K8s 容器编排
+</a:t>
+            </a:r>
             <a:pPr indent="0" marL="0">
               <a:lnSpc>
                 <a:spcPts val="1800"/>
@@ -3008,19 +2998,17 @@
               <a:buNone/>
             </a:pPr>
             <a:r>
-              <a:rPr lang="en-US" sz="1300" dirty="0">
-                <a:solidFill>
-                  <a:srgbClr val="F8FAFC"/>
-                </a:solidFill>
-                <a:latin typeface="Microsoft YaHei" pitchFamily="34" charset="0"/>
-                <a:ea typeface="Microsoft YaHei" pitchFamily="34" charset="-122"/>
-                <a:cs typeface="Microsoft YaHei" pitchFamily="34" charset="-120"/>
-              </a:rPr>
-              <a:t>• 权限隔离 (RBAC)</a:t>
-            </a:r>
-            <a:endParaRPr lang="en-US" sz="1300" dirty="0"/>
-          </a:p>
-          <a:p>
+              <a:rPr lang="en-US" sz="1250" dirty="0">
+                <a:solidFill>
+                  <a:srgbClr val="94A3B8"/>
+                </a:solidFill>
+                <a:latin typeface="Microsoft YaHei" pitchFamily="34" charset="0"/>
+                <a:ea typeface="Microsoft YaHei" pitchFamily="34" charset="-122"/>
+                <a:cs typeface="Microsoft YaHei" pitchFamily="34" charset="-120"/>
+              </a:rPr>
+              <a:t>• 权限隔离 (RBAC)
+</a:t>
+            </a:r>
             <a:pPr indent="0" marL="0">
               <a:lnSpc>
                 <a:spcPts val="1800"/>
@@ -3028,19 +3016,17 @@
               <a:buNone/>
             </a:pPr>
             <a:r>
-              <a:rPr lang="en-US" sz="1300" dirty="0">
-                <a:solidFill>
-                  <a:srgbClr val="F8FAFC"/>
-                </a:solidFill>
-                <a:latin typeface="Microsoft YaHei" pitchFamily="34" charset="0"/>
-                <a:ea typeface="Microsoft YaHei" pitchFamily="34" charset="-122"/>
-                <a:cs typeface="Microsoft YaHei" pitchFamily="34" charset="-120"/>
-              </a:rPr>
-              <a:t>• ServiceAccount</a:t>
-            </a:r>
-            <a:endParaRPr lang="en-US" sz="1300" dirty="0"/>
-          </a:p>
-          <a:p>
+              <a:rPr lang="en-US" sz="1250" dirty="0">
+                <a:solidFill>
+                  <a:srgbClr val="94A3B8"/>
+                </a:solidFill>
+                <a:latin typeface="Microsoft YaHei" pitchFamily="34" charset="0"/>
+                <a:ea typeface="Microsoft YaHei" pitchFamily="34" charset="-122"/>
+                <a:cs typeface="Microsoft YaHei" pitchFamily="34" charset="-120"/>
+              </a:rPr>
+              <a:t>• ServiceAccount
+</a:t>
+            </a:r>
             <a:pPr indent="0" marL="0">
               <a:lnSpc>
                 <a:spcPts val="1800"/>
@@ -3048,19 +3034,17 @@
               <a:buNone/>
             </a:pPr>
             <a:r>
-              <a:rPr lang="en-US" sz="1300" dirty="0">
-                <a:solidFill>
-                  <a:srgbClr val="F8FAFC"/>
-                </a:solidFill>
-                <a:latin typeface="Microsoft YaHei" pitchFamily="34" charset="0"/>
-                <a:ea typeface="Microsoft YaHei" pitchFamily="34" charset="-122"/>
-                <a:cs typeface="Microsoft YaHei" pitchFamily="34" charset="-120"/>
-              </a:rPr>
-              <a:t>• 命名空间划分</a:t>
-            </a:r>
-            <a:endParaRPr lang="en-US" sz="1300" dirty="0"/>
-          </a:p>
-          <a:p>
+              <a:rPr lang="en-US" sz="1250" dirty="0">
+                <a:solidFill>
+                  <a:srgbClr val="94A3B8"/>
+                </a:solidFill>
+                <a:latin typeface="Microsoft YaHei" pitchFamily="34" charset="0"/>
+                <a:ea typeface="Microsoft YaHei" pitchFamily="34" charset="-122"/>
+                <a:cs typeface="Microsoft YaHei" pitchFamily="34" charset="-120"/>
+              </a:rPr>
+              <a:t>• 副本控制机制
+</a:t>
+            </a:r>
             <a:pPr indent="0" marL="0">
               <a:lnSpc>
                 <a:spcPts val="1800"/>
@@ -3068,30 +3052,30 @@
               <a:buNone/>
             </a:pPr>
             <a:r>
-              <a:rPr lang="en-US" sz="1300" dirty="0">
-                <a:solidFill>
-                  <a:srgbClr val="F8FAFC"/>
-                </a:solidFill>
-                <a:latin typeface="Microsoft YaHei" pitchFamily="34" charset="0"/>
-                <a:ea typeface="Microsoft YaHei" pitchFamily="34" charset="-122"/>
-                <a:cs typeface="Microsoft YaHei" pitchFamily="34" charset="-120"/>
-              </a:rPr>
-              <a:t>• 本地 K8s 沙箱交互，通过 ServiceAccount 安全执行运维指令。</a:t>
-            </a:r>
-            <a:endParaRPr lang="en-US" sz="1300" dirty="0"/>
-          </a:p>
-        </p:txBody>
-      </p:sp>
-      <p:sp>
-        <p:nvSpPr>
-          <p:cNvPr id="14" name="Shape 12"/>
-          <p:cNvSpPr/>
-          <p:nvPr/>
-        </p:nvSpPr>
-        <p:spPr>
-          <a:xfrm>
-            <a:off x="6217920" y="1920240"/>
-            <a:ext cx="2560320" cy="4023360"/>
+              <a:rPr lang="en-US" sz="1250" dirty="0">
+                <a:solidFill>
+                  <a:srgbClr val="94A3B8"/>
+                </a:solidFill>
+                <a:latin typeface="Microsoft YaHei" pitchFamily="34" charset="0"/>
+                <a:ea typeface="Microsoft YaHei" pitchFamily="34" charset="-122"/>
+                <a:cs typeface="Microsoft YaHei" pitchFamily="34" charset="-120"/>
+              </a:rPr>
+              <a:t>提供合法受控的终端代理。利用物理沙箱环境在 live 集群上安全执行各种自愈指令。</a:t>
+            </a:r>
+            <a:endParaRPr lang="en-US" sz="1250" dirty="0"/>
+          </a:p>
+        </p:txBody>
+      </p:sp>
+      <p:sp>
+        <p:nvSpPr>
+          <p:cNvPr id="12" name="Shape 10"/>
+          <p:cNvSpPr/>
+          <p:nvPr/>
+        </p:nvSpPr>
+        <p:spPr>
+          <a:xfrm>
+            <a:off x="6217920" y="1737360"/>
+            <a:ext cx="2560320" cy="4389120"/>
           </a:xfrm>
           <a:prstGeom prst="roundRect">
             <a:avLst/>
@@ -3104,14 +3088,14 @@
       </p:sp>
       <p:sp>
         <p:nvSpPr>
-          <p:cNvPr id="15" name="Text 13"/>
-          <p:cNvSpPr/>
-          <p:nvPr/>
-        </p:nvSpPr>
-        <p:spPr>
-          <a:xfrm>
-            <a:off x="6400800" y="2103120"/>
-            <a:ext cx="2194560" cy="548640"/>
+          <p:cNvPr id="13" name="Text 11"/>
+          <p:cNvSpPr/>
+          <p:nvPr/>
+        </p:nvSpPr>
+        <p:spPr>
+          <a:xfrm>
+            <a:off x="6400800" y="1920240"/>
+            <a:ext cx="2194560" cy="4023360"/>
           </a:xfrm>
           <a:prstGeom prst="rect">
             <a:avLst/>
@@ -3124,6 +3108,9 @@
           <a:lstStyle/>
           <a:p>
             <a:pPr indent="0" marL="0">
+              <a:lnSpc>
+                <a:spcPts val="1800"/>
+              </a:lnSpc>
               <a:buNone/>
             </a:pPr>
             <a:r>
@@ -3135,33 +3122,10 @@
                 <a:ea typeface="Microsoft YaHei" pitchFamily="34" charset="-122"/>
                 <a:cs typeface="Microsoft YaHei" pitchFamily="34" charset="-120"/>
               </a:rPr>
-              <a:t>🕸️ 实验三：微服务架构</a:t>
-            </a:r>
-            <a:endParaRPr lang="en-US" sz="1600" dirty="0"/>
-          </a:p>
-        </p:txBody>
-      </p:sp>
-      <p:sp>
-        <p:nvSpPr>
-          <p:cNvPr id="16" name="Text 14"/>
-          <p:cNvSpPr/>
-          <p:nvPr/>
-        </p:nvSpPr>
-        <p:spPr>
-          <a:xfrm>
-            <a:off x="6400800" y="2743200"/>
-            <a:ext cx="2194560" cy="3017520"/>
-          </a:xfrm>
-          <a:prstGeom prst="rect">
-            <a:avLst/>
-          </a:prstGeom>
-          <a:noFill/>
-          <a:ln/>
-        </p:spPr>
-        <p:txBody>
-          <a:bodyPr wrap="square" rtlCol="0" anchor="ctr"/>
-          <a:lstStyle/>
-          <a:p>
+              <a:t>🕸️ 实验三
+微服务架构
+</a:t>
+            </a:r>
             <a:pPr indent="0" marL="0">
               <a:lnSpc>
                 <a:spcPts val="1800"/>
@@ -3169,19 +3133,17 @@
               <a:buNone/>
             </a:pPr>
             <a:r>
-              <a:rPr lang="en-US" sz="1300" dirty="0">
-                <a:solidFill>
-                  <a:srgbClr val="F8FAFC"/>
-                </a:solidFill>
-                <a:latin typeface="Microsoft YaHei" pitchFamily="34" charset="0"/>
-                <a:ea typeface="Microsoft YaHei" pitchFamily="34" charset="-122"/>
-                <a:cs typeface="Microsoft YaHei" pitchFamily="34" charset="-120"/>
-              </a:rPr>
-              <a:t>• 多级链路调用</a:t>
-            </a:r>
-            <a:endParaRPr lang="en-US" sz="1300" dirty="0"/>
-          </a:p>
-          <a:p>
+              <a:rPr lang="en-US" sz="1250" dirty="0">
+                <a:solidFill>
+                  <a:srgbClr val="94A3B8"/>
+                </a:solidFill>
+                <a:latin typeface="Microsoft YaHei" pitchFamily="34" charset="0"/>
+                <a:ea typeface="Microsoft YaHei" pitchFamily="34" charset="-122"/>
+                <a:cs typeface="Microsoft YaHei" pitchFamily="34" charset="-120"/>
+              </a:rPr>
+              <a:t>• 多层服务链路
+</a:t>
+            </a:r>
             <a:pPr indent="0" marL="0">
               <a:lnSpc>
                 <a:spcPts val="1800"/>
@@ -3189,19 +3151,17 @@
               <a:buNone/>
             </a:pPr>
             <a:r>
-              <a:rPr lang="en-US" sz="1300" dirty="0">
-                <a:solidFill>
-                  <a:srgbClr val="F8FAFC"/>
-                </a:solidFill>
-                <a:latin typeface="Microsoft YaHei" pitchFamily="34" charset="0"/>
-                <a:ea typeface="Microsoft YaHei" pitchFamily="34" charset="-122"/>
-                <a:cs typeface="Microsoft YaHei" pitchFamily="34" charset="-120"/>
-              </a:rPr>
-              <a:t>• 服务注册与发现</a:t>
-            </a:r>
-            <a:endParaRPr lang="en-US" sz="1300" dirty="0"/>
-          </a:p>
-          <a:p>
+              <a:rPr lang="en-US" sz="1250" dirty="0">
+                <a:solidFill>
+                  <a:srgbClr val="94A3B8"/>
+                </a:solidFill>
+                <a:latin typeface="Microsoft YaHei" pitchFamily="34" charset="0"/>
+                <a:ea typeface="Microsoft YaHei" pitchFamily="34" charset="-122"/>
+                <a:cs typeface="Microsoft YaHei" pitchFamily="34" charset="-120"/>
+              </a:rPr>
+              <a:t>• 服务调用依赖
+</a:t>
+            </a:r>
             <a:pPr indent="0" marL="0">
               <a:lnSpc>
                 <a:spcPts val="1800"/>
@@ -3209,19 +3169,17 @@
               <a:buNone/>
             </a:pPr>
             <a:r>
-              <a:rPr lang="en-US" sz="1300" dirty="0">
-                <a:solidFill>
-                  <a:srgbClr val="F8FAFC"/>
-                </a:solidFill>
-                <a:latin typeface="Microsoft YaHei" pitchFamily="34" charset="0"/>
-                <a:ea typeface="Microsoft YaHei" pitchFamily="34" charset="-122"/>
-                <a:cs typeface="Microsoft YaHei" pitchFamily="34" charset="-120"/>
-              </a:rPr>
-              <a:t>• 容错路由机制</a:t>
-            </a:r>
-            <a:endParaRPr lang="en-US" sz="1300" dirty="0"/>
-          </a:p>
-          <a:p>
+              <a:rPr lang="en-US" sz="1250" dirty="0">
+                <a:solidFill>
+                  <a:srgbClr val="94A3B8"/>
+                </a:solidFill>
+                <a:latin typeface="Microsoft YaHei" pitchFamily="34" charset="0"/>
+                <a:ea typeface="Microsoft YaHei" pitchFamily="34" charset="-122"/>
+                <a:cs typeface="Microsoft YaHei" pitchFamily="34" charset="-120"/>
+              </a:rPr>
+              <a:t>• API 网络流控制
+</a:t>
+            </a:r>
             <a:pPr indent="0" marL="0">
               <a:lnSpc>
                 <a:spcPts val="1800"/>
@@ -3229,30 +3187,30 @@
               <a:buNone/>
             </a:pPr>
             <a:r>
-              <a:rPr lang="en-US" sz="1300" dirty="0">
-                <a:solidFill>
-                  <a:srgbClr val="F8FAFC"/>
-                </a:solidFill>
-                <a:latin typeface="Microsoft YaHei" pitchFamily="34" charset="0"/>
-                <a:ea typeface="Microsoft YaHei" pitchFamily="34" charset="-122"/>
-                <a:cs typeface="Microsoft YaHei" pitchFamily="34" charset="-120"/>
-              </a:rPr>
-              <a:t>• 提取真实三层微服务 (order/product/frontend) 作为靶标系统。</a:t>
-            </a:r>
-            <a:endParaRPr lang="en-US" sz="1300" dirty="0"/>
-          </a:p>
-        </p:txBody>
-      </p:sp>
-      <p:sp>
-        <p:nvSpPr>
-          <p:cNvPr id="17" name="Shape 15"/>
-          <p:cNvSpPr/>
-          <p:nvPr/>
-        </p:nvSpPr>
-        <p:spPr>
-          <a:xfrm>
-            <a:off x="9052560" y="1920240"/>
-            <a:ext cx="2560320" cy="4023360"/>
+              <a:rPr lang="en-US" sz="1250" dirty="0">
+                <a:solidFill>
+                  <a:srgbClr val="94A3B8"/>
+                </a:solidFill>
+                <a:latin typeface="Microsoft YaHei" pitchFamily="34" charset="0"/>
+                <a:ea typeface="Microsoft YaHei" pitchFamily="34" charset="-122"/>
+                <a:cs typeface="Microsoft YaHei" pitchFamily="34" charset="-120"/>
+              </a:rPr>
+              <a:t>直接提取真实的微服务架构作为靶标系统。在延迟注入下完美呈现级联雪崩现象。</a:t>
+            </a:r>
+            <a:endParaRPr lang="en-US" sz="1250" dirty="0"/>
+          </a:p>
+        </p:txBody>
+      </p:sp>
+      <p:sp>
+        <p:nvSpPr>
+          <p:cNvPr id="14" name="Shape 12"/>
+          <p:cNvSpPr/>
+          <p:nvPr/>
+        </p:nvSpPr>
+        <p:spPr>
+          <a:xfrm>
+            <a:off x="9052560" y="1737360"/>
+            <a:ext cx="2560320" cy="4389120"/>
           </a:xfrm>
           <a:prstGeom prst="roundRect">
             <a:avLst/>
@@ -3265,14 +3223,14 @@
       </p:sp>
       <p:sp>
         <p:nvSpPr>
-          <p:cNvPr id="18" name="Text 16"/>
-          <p:cNvSpPr/>
-          <p:nvPr/>
-        </p:nvSpPr>
-        <p:spPr>
-          <a:xfrm>
-            <a:off x="9235440" y="2103120"/>
-            <a:ext cx="2194560" cy="548640"/>
+          <p:cNvPr id="15" name="Text 13"/>
+          <p:cNvSpPr/>
+          <p:nvPr/>
+        </p:nvSpPr>
+        <p:spPr>
+          <a:xfrm>
+            <a:off x="9235440" y="1920240"/>
+            <a:ext cx="2194560" cy="4023360"/>
           </a:xfrm>
           <a:prstGeom prst="rect">
             <a:avLst/>
@@ -3285,6 +3243,9 @@
           <a:lstStyle/>
           <a:p>
             <a:pPr indent="0" marL="0">
+              <a:lnSpc>
+                <a:spcPts val="1800"/>
+              </a:lnSpc>
               <a:buNone/>
             </a:pPr>
             <a:r>
@@ -3296,33 +3257,10 @@
                 <a:ea typeface="Microsoft YaHei" pitchFamily="34" charset="-122"/>
                 <a:cs typeface="Microsoft YaHei" pitchFamily="34" charset="-120"/>
               </a:rPr>
-              <a:t>🔥 实验四：混沌工程</a:t>
-            </a:r>
-            <a:endParaRPr lang="en-US" sz="1600" dirty="0"/>
-          </a:p>
-        </p:txBody>
-      </p:sp>
-      <p:sp>
-        <p:nvSpPr>
-          <p:cNvPr id="19" name="Text 17"/>
-          <p:cNvSpPr/>
-          <p:nvPr/>
-        </p:nvSpPr>
-        <p:spPr>
-          <a:xfrm>
-            <a:off x="9235440" y="2743200"/>
-            <a:ext cx="2194560" cy="3017520"/>
-          </a:xfrm>
-          <a:prstGeom prst="rect">
-            <a:avLst/>
-          </a:prstGeom>
-          <a:noFill/>
-          <a:ln/>
-        </p:spPr>
-        <p:txBody>
-          <a:bodyPr wrap="square" rtlCol="0" anchor="ctr"/>
-          <a:lstStyle/>
-          <a:p>
+              <a:t>🔥 实验四
+混沌工程理论
+</a:t>
+            </a:r>
             <a:pPr indent="0" marL="0">
               <a:lnSpc>
                 <a:spcPts val="1800"/>
@@ -3330,19 +3268,17 @@
               <a:buNone/>
             </a:pPr>
             <a:r>
-              <a:rPr lang="en-US" sz="1300" dirty="0">
-                <a:solidFill>
-                  <a:srgbClr val="F8FAFC"/>
-                </a:solidFill>
-                <a:latin typeface="Microsoft YaHei" pitchFamily="34" charset="0"/>
-                <a:ea typeface="Microsoft YaHei" pitchFamily="34" charset="-122"/>
-                <a:cs typeface="Microsoft YaHei" pitchFamily="34" charset="-120"/>
-              </a:rPr>
-              <a:t>• 故障模式提炼</a:t>
-            </a:r>
-            <a:endParaRPr lang="en-US" sz="1300" dirty="0"/>
-          </a:p>
-          <a:p>
+              <a:rPr lang="en-US" sz="1250" dirty="0">
+                <a:solidFill>
+                  <a:srgbClr val="94A3B8"/>
+                </a:solidFill>
+                <a:latin typeface="Microsoft YaHei" pitchFamily="34" charset="0"/>
+                <a:ea typeface="Microsoft YaHei" pitchFamily="34" charset="-122"/>
+                <a:cs typeface="Microsoft YaHei" pitchFamily="34" charset="-120"/>
+              </a:rPr>
+              <a:t>• 故障模型与发现
+</a:t>
+            </a:r>
             <a:pPr indent="0" marL="0">
               <a:lnSpc>
                 <a:spcPts val="1800"/>
@@ -3350,19 +3286,17 @@
               <a:buNone/>
             </a:pPr>
             <a:r>
-              <a:rPr lang="en-US" sz="1300" dirty="0">
-                <a:solidFill>
-                  <a:srgbClr val="F8FAFC"/>
-                </a:solidFill>
-                <a:latin typeface="Microsoft YaHei" pitchFamily="34" charset="0"/>
-                <a:ea typeface="Microsoft YaHei" pitchFamily="34" charset="-122"/>
-                <a:cs typeface="Microsoft YaHei" pitchFamily="34" charset="-120"/>
-              </a:rPr>
-              <a:t>• 主动破坏性演练</a:t>
-            </a:r>
-            <a:endParaRPr lang="en-US" sz="1300" dirty="0"/>
-          </a:p>
-          <a:p>
+              <a:rPr lang="en-US" sz="1250" dirty="0">
+                <a:solidFill>
+                  <a:srgbClr val="94A3B8"/>
+                </a:solidFill>
+                <a:latin typeface="Microsoft YaHei" pitchFamily="34" charset="0"/>
+                <a:ea typeface="Microsoft YaHei" pitchFamily="34" charset="-122"/>
+                <a:cs typeface="Microsoft YaHei" pitchFamily="34" charset="-120"/>
+              </a:rPr>
+              <a:t>• 主动高抗破坏性
+</a:t>
+            </a:r>
             <a:pPr indent="0" marL="0">
               <a:lnSpc>
                 <a:spcPts val="1800"/>
@@ -3370,19 +3304,17 @@
               <a:buNone/>
             </a:pPr>
             <a:r>
-              <a:rPr lang="en-US" sz="1300" dirty="0">
-                <a:solidFill>
-                  <a:srgbClr val="F8FAFC"/>
-                </a:solidFill>
-                <a:latin typeface="Microsoft YaHei" pitchFamily="34" charset="0"/>
-                <a:ea typeface="Microsoft YaHei" pitchFamily="34" charset="-122"/>
-                <a:cs typeface="Microsoft YaHei" pitchFamily="34" charset="-120"/>
-              </a:rPr>
-              <a:t>• 自愈恢复回路</a:t>
-            </a:r>
-            <a:endParaRPr lang="en-US" sz="1300" dirty="0"/>
-          </a:p>
-          <a:p>
+              <a:rPr lang="en-US" sz="1250" dirty="0">
+                <a:solidFill>
+                  <a:srgbClr val="94A3B8"/>
+                </a:solidFill>
+                <a:latin typeface="Microsoft YaHei" pitchFamily="34" charset="0"/>
+                <a:ea typeface="Microsoft YaHei" pitchFamily="34" charset="-122"/>
+                <a:cs typeface="Microsoft YaHei" pitchFamily="34" charset="-120"/>
+              </a:rPr>
+              <a:t>• 动态调协自愈
+</a:t>
+            </a:r>
             <a:pPr indent="0" marL="0">
               <a:lnSpc>
                 <a:spcPts val="1800"/>
@@ -3390,17 +3322,17 @@
               <a:buNone/>
             </a:pPr>
             <a:r>
-              <a:rPr lang="en-US" sz="1300" dirty="0">
-                <a:solidFill>
-                  <a:srgbClr val="F8FAFC"/>
-                </a:solidFill>
-                <a:latin typeface="Microsoft YaHei" pitchFamily="34" charset="0"/>
-                <a:ea typeface="Microsoft YaHei" pitchFamily="34" charset="-122"/>
-                <a:cs typeface="Microsoft YaHei" pitchFamily="34" charset="-120"/>
-              </a:rPr>
-              <a:t>• 构建完整的 Chaos 故障池与自愈回滚逻辑，承载整个游戏的核心玩法。</a:t>
-            </a:r>
-            <a:endParaRPr lang="en-US" sz="1300" dirty="0"/>
+              <a:rPr lang="en-US" sz="1250" dirty="0">
+                <a:solidFill>
+                  <a:srgbClr val="94A3B8"/>
+                </a:solidFill>
+                <a:latin typeface="Microsoft YaHei" pitchFamily="34" charset="0"/>
+                <a:ea typeface="Microsoft YaHei" pitchFamily="34" charset="-122"/>
+                <a:cs typeface="Microsoft YaHei" pitchFamily="34" charset="-120"/>
+              </a:rPr>
+              <a:t>理论落地为玩法！构建完整的混沌故障池与清理程序，在竞速机制中展现混沌核心工程学价值。</a:t>
+            </a:r>
+            <a:endParaRPr lang="en-US" sz="1250" dirty="0"/>
           </a:p>
         </p:txBody>
       </p:sp>
@@ -3601,8 +3533,8 @@
         </p:nvSpPr>
         <p:spPr>
           <a:xfrm>
-            <a:off x="548640" y="1645920"/>
-            <a:ext cx="5212080" cy="4389120"/>
+            <a:off x="548640" y="1463040"/>
+            <a:ext cx="5303520" cy="4663440"/>
           </a:xfrm>
           <a:prstGeom prst="roundRect">
             <a:avLst/>
@@ -3621,8 +3553,8 @@
         </p:nvSpPr>
         <p:spPr>
           <a:xfrm>
-            <a:off x="822960" y="1828800"/>
-            <a:ext cx="4663440" cy="365760"/>
+            <a:off x="822960" y="1645920"/>
+            <a:ext cx="4754880" cy="4297680"/>
           </a:xfrm>
           <a:prstGeom prst="rect">
             <a:avLst/>
@@ -3635,6 +3567,9 @@
           <a:lstStyle/>
           <a:p>
             <a:pPr indent="0" marL="0">
+              <a:lnSpc>
+                <a:spcPts val="1600"/>
+              </a:lnSpc>
               <a:buNone/>
             </a:pPr>
             <a:r>
@@ -3646,41 +3581,17 @@
                 <a:ea typeface="Microsoft YaHei" pitchFamily="34" charset="-122"/>
                 <a:cs typeface="Microsoft YaHei" pitchFamily="34" charset="-120"/>
               </a:rPr>
-              <a:t>🛠️ 模块化分层设计体系</a:t>
-            </a:r>
-            <a:endParaRPr lang="en-US" sz="1800" dirty="0"/>
-          </a:p>
-        </p:txBody>
-      </p:sp>
-      <p:sp>
-        <p:nvSpPr>
-          <p:cNvPr id="9" name="Text 7"/>
-          <p:cNvSpPr/>
-          <p:nvPr/>
-        </p:nvSpPr>
-        <p:spPr>
-          <a:xfrm>
-            <a:off x="822960" y="2286000"/>
-            <a:ext cx="4663440" cy="3566160"/>
-          </a:xfrm>
-          <a:prstGeom prst="rect">
-            <a:avLst/>
-          </a:prstGeom>
-          <a:noFill/>
-          <a:ln/>
-        </p:spPr>
-        <p:txBody>
-          <a:bodyPr wrap="square" rtlCol="0" anchor="ctr"/>
-          <a:lstStyle/>
-          <a:p>
-            <a:pPr indent="0" marL="0">
-              <a:lnSpc>
-                <a:spcPts val="2000"/>
-              </a:lnSpc>
-              <a:buNone/>
-            </a:pPr>
-            <a:r>
-              <a:rPr lang="en-US" sz="1250" dirty="0">
+              <a:t>🛠️ 模块化分层设计体系
+</a:t>
+            </a:r>
+            <a:pPr indent="0" marL="0">
+              <a:lnSpc>
+                <a:spcPts val="1600"/>
+              </a:lnSpc>
+              <a:buNone/>
+            </a:pPr>
+            <a:r>
+              <a:rPr lang="en-US" sz="1200" b="1" dirty="0">
                 <a:solidFill>
                   <a:srgbClr val="F8FAFC"/>
                 </a:solidFill>
@@ -3688,19 +3599,35 @@
                 <a:ea typeface="Microsoft YaHei" pitchFamily="34" charset="-122"/>
                 <a:cs typeface="Microsoft YaHei" pitchFamily="34" charset="-120"/>
               </a:rPr>
-              <a:t>1. 可观测与交互层 (Vite + Vue 3)</a:t>
-            </a:r>
-            <a:endParaRPr lang="en-US" sz="1250" dirty="0"/>
-          </a:p>
-          <a:p>
-            <a:pPr indent="0" marL="0">
-              <a:lnSpc>
-                <a:spcPts val="2000"/>
-              </a:lnSpc>
-              <a:buNone/>
-            </a:pPr>
-            <a:r>
-              <a:rPr lang="en-US" sz="1250" dirty="0">
+              <a:t>1. 可观测与交互层 (Vite + Vue 3)
+</a:t>
+            </a:r>
+            <a:pPr indent="0" marL="0">
+              <a:lnSpc>
+                <a:spcPts val="1600"/>
+              </a:lnSpc>
+              <a:buNone/>
+            </a:pPr>
+            <a:r>
+              <a:rPr lang="en-US" sz="1200" dirty="0">
+                <a:solidFill>
+                  <a:srgbClr val="94A3B8"/>
+                </a:solidFill>
+                <a:latin typeface="Microsoft YaHei" pitchFamily="34" charset="0"/>
+                <a:ea typeface="Microsoft YaHei" pitchFamily="34" charset="-122"/>
+                <a:cs typeface="Microsoft YaHei" pitchFamily="34" charset="-120"/>
+              </a:rPr>
+              <a:t>实时集群健康拓扑大屏与 xterm.js 沉浸式终端，提供完美的 Linux 运维交互。
+</a:t>
+            </a:r>
+            <a:pPr indent="0" marL="0">
+              <a:lnSpc>
+                <a:spcPts val="1600"/>
+              </a:lnSpc>
+              <a:buNone/>
+            </a:pPr>
+            <a:r>
+              <a:rPr lang="en-US" sz="1200" b="1" dirty="0">
                 <a:solidFill>
                   <a:srgbClr val="F8FAFC"/>
                 </a:solidFill>
@@ -3708,19 +3635,35 @@
                 <a:ea typeface="Microsoft YaHei" pitchFamily="34" charset="-122"/>
                 <a:cs typeface="Microsoft YaHei" pitchFamily="34" charset="-120"/>
               </a:rPr>
-              <a:t>   - 实时集群健康指标面板 (高频 Websocket 广播刷新)</a:t>
-            </a:r>
-            <a:endParaRPr lang="en-US" sz="1250" dirty="0"/>
-          </a:p>
-          <a:p>
-            <a:pPr indent="0" marL="0">
-              <a:lnSpc>
-                <a:spcPts val="2000"/>
-              </a:lnSpc>
-              <a:buNone/>
-            </a:pPr>
-            <a:r>
-              <a:rPr lang="en-US" sz="1250" dirty="0">
+              <a:t>2. 逻辑与控制层 (Node.js + ws)
+</a:t>
+            </a:r>
+            <a:pPr indent="0" marL="0">
+              <a:lnSpc>
+                <a:spcPts val="1600"/>
+              </a:lnSpc>
+              <a:buNone/>
+            </a:pPr>
+            <a:r>
+              <a:rPr lang="en-US" sz="1200" dirty="0">
+                <a:solidFill>
+                  <a:srgbClr val="94A3B8"/>
+                </a:solidFill>
+                <a:latin typeface="Microsoft YaHei" pitchFamily="34" charset="0"/>
+                <a:ea typeface="Microsoft YaHei" pitchFamily="34" charset="-122"/>
+                <a:cs typeface="Microsoft YaHei" pitchFamily="34" charset="-120"/>
+              </a:rPr>
+              <a:t>采用状态机引擎控制游戏生命周期；内置多维度 Scorer Engine 实现人机抢修评分。
+</a:t>
+            </a:r>
+            <a:pPr indent="0" marL="0">
+              <a:lnSpc>
+                <a:spcPts val="1600"/>
+              </a:lnSpc>
+              <a:buNone/>
+            </a:pPr>
+            <a:r>
+              <a:rPr lang="en-US" sz="1200" b="1" dirty="0">
                 <a:solidFill>
                   <a:srgbClr val="F8FAFC"/>
                 </a:solidFill>
@@ -3728,28 +3671,35 @@
                 <a:ea typeface="Microsoft YaHei" pitchFamily="34" charset="-122"/>
                 <a:cs typeface="Microsoft YaHei" pitchFamily="34" charset="-120"/>
               </a:rPr>
-              <a:t>   - xterm.js 仿真交互终端，提供完全沉浸式的 Linux 操作体验</a:t>
-            </a:r>
-            <a:endParaRPr lang="en-US" sz="1250" dirty="0"/>
-          </a:p>
-          <a:p>
-            <a:pPr indent="0" marL="0">
-              <a:lnSpc>
-                <a:spcPts val="2000"/>
-              </a:lnSpc>
-              <a:buNone/>
-            </a:pPr>
-            <a:endParaRPr lang="en-US" sz="1250" dirty="0"/>
-          </a:p>
-          <a:p>
-            <a:pPr indent="0" marL="0">
-              <a:lnSpc>
-                <a:spcPts val="2000"/>
-              </a:lnSpc>
-              <a:buNone/>
-            </a:pPr>
-            <a:r>
-              <a:rPr lang="en-US" sz="1250" dirty="0">
+              <a:t>3. 安全防护层 (Terminal Proxy)
+</a:t>
+            </a:r>
+            <a:pPr indent="0" marL="0">
+              <a:lnSpc>
+                <a:spcPts val="1600"/>
+              </a:lnSpc>
+              <a:buNone/>
+            </a:pPr>
+            <a:r>
+              <a:rPr lang="en-US" sz="1200" dirty="0">
+                <a:solidFill>
+                  <a:srgbClr val="94A3B8"/>
+                </a:solidFill>
+                <a:latin typeface="Microsoft YaHei" pitchFamily="34" charset="0"/>
+                <a:ea typeface="Microsoft YaHei" pitchFamily="34" charset="-122"/>
+                <a:cs typeface="Microsoft YaHei" pitchFamily="34" charset="-120"/>
+              </a:rPr>
+              <a:t>拦截危险字符输入并实现 Namespace 强制重写绑定，防范越权破坏。
+</a:t>
+            </a:r>
+            <a:pPr indent="0" marL="0">
+              <a:lnSpc>
+                <a:spcPts val="1600"/>
+              </a:lnSpc>
+              <a:buNone/>
+            </a:pPr>
+            <a:r>
+              <a:rPr lang="en-US" sz="1200" b="1" dirty="0">
                 <a:solidFill>
                   <a:srgbClr val="F8FAFC"/>
                 </a:solidFill>
@@ -3757,160 +3707,40 @@
                 <a:ea typeface="Microsoft YaHei" pitchFamily="34" charset="-122"/>
                 <a:cs typeface="Microsoft YaHei" pitchFamily="34" charset="-120"/>
               </a:rPr>
-              <a:t>2. 逻辑与引擎层 (Express + WS Server)</a:t>
-            </a:r>
-            <a:endParaRPr lang="en-US" sz="1250" dirty="0"/>
-          </a:p>
-          <a:p>
-            <a:pPr indent="0" marL="0">
-              <a:lnSpc>
-                <a:spcPts val="2000"/>
-              </a:lnSpc>
-              <a:buNone/>
-            </a:pPr>
-            <a:r>
-              <a:rPr lang="en-US" sz="1250" dirty="0">
-                <a:solidFill>
-                  <a:srgbClr val="F8FAFC"/>
-                </a:solidFill>
-                <a:latin typeface="Microsoft YaHei" pitchFamily="34" charset="0"/>
-                <a:ea typeface="Microsoft YaHei" pitchFamily="34" charset="-122"/>
-                <a:cs typeface="Microsoft YaHei" pitchFamily="34" charset="-120"/>
-              </a:rPr>
-              <a:t>   - 状态机内核驱动游戏全周期 (Idle -&gt; Inject -&gt; Diagn -&gt; Score)</a:t>
-            </a:r>
-            <a:endParaRPr lang="en-US" sz="1250" dirty="0"/>
-          </a:p>
-          <a:p>
-            <a:pPr indent="0" marL="0">
-              <a:lnSpc>
-                <a:spcPts val="2000"/>
-              </a:lnSpc>
-              <a:buNone/>
-            </a:pPr>
-            <a:r>
-              <a:rPr lang="en-US" sz="1250" dirty="0">
-                <a:solidFill>
-                  <a:srgbClr val="F8FAFC"/>
-                </a:solidFill>
-                <a:latin typeface="Microsoft YaHei" pitchFamily="34" charset="0"/>
-                <a:ea typeface="Microsoft YaHei" pitchFamily="34" charset="-122"/>
-                <a:cs typeface="Microsoft YaHei" pitchFamily="34" charset="-120"/>
-              </a:rPr>
-              <a:t>   - Scorer Engine 实现多维度指标的定量计算及账单开销扣除</a:t>
-            </a:r>
-            <a:endParaRPr lang="en-US" sz="1250" dirty="0"/>
-          </a:p>
-          <a:p>
-            <a:pPr indent="0" marL="0">
-              <a:lnSpc>
-                <a:spcPts val="2000"/>
-              </a:lnSpc>
-              <a:buNone/>
-            </a:pPr>
-            <a:endParaRPr lang="en-US" sz="1250" dirty="0"/>
-          </a:p>
-          <a:p>
-            <a:pPr indent="0" marL="0">
-              <a:lnSpc>
-                <a:spcPts val="2000"/>
-              </a:lnSpc>
-              <a:buNone/>
-            </a:pPr>
-            <a:r>
-              <a:rPr lang="en-US" sz="1250" dirty="0">
-                <a:solidFill>
-                  <a:srgbClr val="F8FAFC"/>
-                </a:solidFill>
-                <a:latin typeface="Microsoft YaHei" pitchFamily="34" charset="0"/>
-                <a:ea typeface="Microsoft YaHei" pitchFamily="34" charset="-122"/>
-                <a:cs typeface="Microsoft YaHei" pitchFamily="34" charset="-120"/>
-              </a:rPr>
-              <a:t>3. 安全网关层 (Terminal Proxy)</a:t>
-            </a:r>
-            <a:endParaRPr lang="en-US" sz="1250" dirty="0"/>
-          </a:p>
-          <a:p>
-            <a:pPr indent="0" marL="0">
-              <a:lnSpc>
-                <a:spcPts val="2000"/>
-              </a:lnSpc>
-              <a:buNone/>
-            </a:pPr>
-            <a:r>
-              <a:rPr lang="en-US" sz="1250" dirty="0">
-                <a:solidFill>
-                  <a:srgbClr val="F8FAFC"/>
-                </a:solidFill>
-                <a:latin typeface="Microsoft YaHei" pitchFamily="34" charset="0"/>
-                <a:ea typeface="Microsoft YaHei" pitchFamily="34" charset="-122"/>
-                <a:cs typeface="Microsoft YaHei" pitchFamily="34" charset="-120"/>
-              </a:rPr>
-              <a:t>   - 危险输入与越权拦截；强制动态绑定 Namespace 保证环境安全</a:t>
-            </a:r>
-            <a:endParaRPr lang="en-US" sz="1250" dirty="0"/>
-          </a:p>
-          <a:p>
-            <a:pPr indent="0" marL="0">
-              <a:lnSpc>
-                <a:spcPts val="2000"/>
-              </a:lnSpc>
-              <a:buNone/>
-            </a:pPr>
-            <a:endParaRPr lang="en-US" sz="1250" dirty="0"/>
-          </a:p>
-          <a:p>
-            <a:pPr indent="0" marL="0">
-              <a:lnSpc>
-                <a:spcPts val="2000"/>
-              </a:lnSpc>
-              <a:buNone/>
-            </a:pPr>
-            <a:r>
-              <a:rPr lang="en-US" sz="1250" dirty="0">
-                <a:solidFill>
-                  <a:srgbClr val="F8FAFC"/>
-                </a:solidFill>
-                <a:latin typeface="Microsoft YaHei" pitchFamily="34" charset="0"/>
-                <a:ea typeface="Microsoft YaHei" pitchFamily="34" charset="-122"/>
-                <a:cs typeface="Microsoft YaHei" pitchFamily="34" charset="-120"/>
-              </a:rPr>
-              <a:t>4. 物理靶场层 (Kubernetes Cluster)</a:t>
-            </a:r>
-            <a:endParaRPr lang="en-US" sz="1250" dirty="0"/>
-          </a:p>
-          <a:p>
-            <a:pPr indent="0" marL="0">
-              <a:lnSpc>
-                <a:spcPts val="2000"/>
-              </a:lnSpc>
-              <a:buNone/>
-            </a:pPr>
-            <a:r>
-              <a:rPr lang="en-US" sz="1250" dirty="0">
-                <a:solidFill>
-                  <a:srgbClr val="F8FAFC"/>
-                </a:solidFill>
-                <a:latin typeface="Microsoft YaHei" pitchFamily="34" charset="0"/>
-                <a:ea typeface="Microsoft YaHei" pitchFamily="34" charset="-122"/>
-                <a:cs typeface="Microsoft YaHei" pitchFamily="34" charset="-120"/>
-              </a:rPr>
-              <a:t>   - 包含 chaos-game (人机对决靶场) 与 demo-micro 等真实命名空间</a:t>
-            </a:r>
-            <a:endParaRPr lang="en-US" sz="1250" dirty="0"/>
-          </a:p>
-        </p:txBody>
-      </p:sp>
-      <p:sp>
-        <p:nvSpPr>
-          <p:cNvPr id="10" name="Shape 8"/>
-          <p:cNvSpPr/>
-          <p:nvPr/>
-        </p:nvSpPr>
-        <p:spPr>
-          <a:xfrm>
-            <a:off x="6400800" y="1645920"/>
-            <a:ext cx="5212080" cy="4389120"/>
+              <a:t>4. 物理物理靶场层 (Kubernetes Cluster)
+</a:t>
+            </a:r>
+            <a:pPr indent="0" marL="0">
+              <a:lnSpc>
+                <a:spcPts val="1600"/>
+              </a:lnSpc>
+              <a:buNone/>
+            </a:pPr>
+            <a:r>
+              <a:rPr lang="en-US" sz="1200" dirty="0">
+                <a:solidFill>
+                  <a:srgbClr val="94A3B8"/>
+                </a:solidFill>
+                <a:latin typeface="Microsoft YaHei" pitchFamily="34" charset="0"/>
+                <a:ea typeface="Microsoft YaHei" pitchFamily="34" charset="-122"/>
+                <a:cs typeface="Microsoft YaHei" pitchFamily="34" charset="-120"/>
+              </a:rPr>
+              <a:t>物理环境，支持包括 chaos-game 与 demo-micro 等命名空间故障。</a:t>
+            </a:r>
+            <a:endParaRPr lang="en-US" sz="1200" dirty="0"/>
+          </a:p>
+        </p:txBody>
+      </p:sp>
+      <p:sp>
+        <p:nvSpPr>
+          <p:cNvPr id="9" name="Shape 7"/>
+          <p:cNvSpPr/>
+          <p:nvPr/>
+        </p:nvSpPr>
+        <p:spPr>
+          <a:xfrm>
+            <a:off x="6309360" y="1463040"/>
+            <a:ext cx="5303520" cy="4663440"/>
           </a:xfrm>
           <a:prstGeom prst="roundRect">
             <a:avLst/>
@@ -3923,14 +3753,14 @@
       </p:sp>
       <p:sp>
         <p:nvSpPr>
-          <p:cNvPr id="11" name="Text 9"/>
-          <p:cNvSpPr/>
-          <p:nvPr/>
-        </p:nvSpPr>
-        <p:spPr>
-          <a:xfrm>
-            <a:off x="6675120" y="1828800"/>
-            <a:ext cx="4663440" cy="365760"/>
+          <p:cNvPr id="10" name="Text 8"/>
+          <p:cNvSpPr/>
+          <p:nvPr/>
+        </p:nvSpPr>
+        <p:spPr>
+          <a:xfrm>
+            <a:off x="6583680" y="1645920"/>
+            <a:ext cx="4754880" cy="365760"/>
           </a:xfrm>
           <a:prstGeom prst="rect">
             <a:avLst/>
@@ -3962,14 +3792,14 @@
       </p:sp>
       <p:sp>
         <p:nvSpPr>
-          <p:cNvPr id="12" name="Shape 10"/>
-          <p:cNvSpPr/>
-          <p:nvPr/>
-        </p:nvSpPr>
-        <p:spPr>
-          <a:xfrm>
-            <a:off x="7589520" y="2286000"/>
-            <a:ext cx="2834640" cy="548640"/>
+          <p:cNvPr id="11" name="Shape 9"/>
+          <p:cNvSpPr/>
+          <p:nvPr/>
+        </p:nvSpPr>
+        <p:spPr>
+          <a:xfrm>
+            <a:off x="7315200" y="2194560"/>
+            <a:ext cx="3291840" cy="548640"/>
           </a:xfrm>
           <a:prstGeom prst="roundRect">
             <a:avLst/>
@@ -3987,14 +3817,14 @@
       </p:sp>
       <p:sp>
         <p:nvSpPr>
-          <p:cNvPr id="13" name="Text 11"/>
-          <p:cNvSpPr/>
-          <p:nvPr/>
-        </p:nvSpPr>
-        <p:spPr>
-          <a:xfrm>
-            <a:off x="7589520" y="2286000"/>
-            <a:ext cx="2834640" cy="548640"/>
+          <p:cNvPr id="12" name="Text 10"/>
+          <p:cNvSpPr/>
+          <p:nvPr/>
+        </p:nvSpPr>
+        <p:spPr>
+          <a:xfrm>
+            <a:off x="7315200" y="2194560"/>
+            <a:ext cx="3291840" cy="548640"/>
           </a:xfrm>
           <a:prstGeom prst="rect">
             <a:avLst/>
@@ -4026,14 +3856,14 @@
       </p:sp>
       <p:sp>
         <p:nvSpPr>
-          <p:cNvPr id="14" name="Shape 12"/>
-          <p:cNvSpPr/>
-          <p:nvPr/>
-        </p:nvSpPr>
-        <p:spPr>
-          <a:xfrm>
-            <a:off x="7589520" y="3108960"/>
-            <a:ext cx="2834640" cy="548640"/>
+          <p:cNvPr id="13" name="Shape 11"/>
+          <p:cNvSpPr/>
+          <p:nvPr/>
+        </p:nvSpPr>
+        <p:spPr>
+          <a:xfrm>
+            <a:off x="7315200" y="3017520"/>
+            <a:ext cx="3291840" cy="548640"/>
           </a:xfrm>
           <a:prstGeom prst="roundRect">
             <a:avLst/>
@@ -4051,14 +3881,14 @@
       </p:sp>
       <p:sp>
         <p:nvSpPr>
-          <p:cNvPr id="15" name="Text 13"/>
-          <p:cNvSpPr/>
-          <p:nvPr/>
-        </p:nvSpPr>
-        <p:spPr>
-          <a:xfrm>
-            <a:off x="7589520" y="3108960"/>
-            <a:ext cx="2834640" cy="548640"/>
+          <p:cNvPr id="14" name="Text 12"/>
+          <p:cNvSpPr/>
+          <p:nvPr/>
+        </p:nvSpPr>
+        <p:spPr>
+          <a:xfrm>
+            <a:off x="7315200" y="3017520"/>
+            <a:ext cx="3291840" cy="548640"/>
           </a:xfrm>
           <a:prstGeom prst="rect">
             <a:avLst/>
@@ -4090,14 +3920,14 @@
       </p:sp>
       <p:sp>
         <p:nvSpPr>
-          <p:cNvPr id="16" name="Shape 14"/>
-          <p:cNvSpPr/>
-          <p:nvPr/>
-        </p:nvSpPr>
-        <p:spPr>
-          <a:xfrm>
-            <a:off x="7589520" y="3931920"/>
-            <a:ext cx="2834640" cy="548640"/>
+          <p:cNvPr id="15" name="Shape 13"/>
+          <p:cNvSpPr/>
+          <p:nvPr/>
+        </p:nvSpPr>
+        <p:spPr>
+          <a:xfrm>
+            <a:off x="7315200" y="3840480"/>
+            <a:ext cx="3291840" cy="548640"/>
           </a:xfrm>
           <a:prstGeom prst="roundRect">
             <a:avLst/>
@@ -4115,14 +3945,14 @@
       </p:sp>
       <p:sp>
         <p:nvSpPr>
-          <p:cNvPr id="17" name="Text 15"/>
-          <p:cNvSpPr/>
-          <p:nvPr/>
-        </p:nvSpPr>
-        <p:spPr>
-          <a:xfrm>
-            <a:off x="7589520" y="3931920"/>
-            <a:ext cx="2834640" cy="548640"/>
+          <p:cNvPr id="16" name="Text 14"/>
+          <p:cNvSpPr/>
+          <p:nvPr/>
+        </p:nvSpPr>
+        <p:spPr>
+          <a:xfrm>
+            <a:off x="7315200" y="3840480"/>
+            <a:ext cx="3291840" cy="548640"/>
           </a:xfrm>
           <a:prstGeom prst="rect">
             <a:avLst/>
@@ -4154,14 +3984,14 @@
       </p:sp>
       <p:sp>
         <p:nvSpPr>
-          <p:cNvPr id="18" name="Shape 16"/>
-          <p:cNvSpPr/>
-          <p:nvPr/>
-        </p:nvSpPr>
-        <p:spPr>
-          <a:xfrm>
-            <a:off x="7589520" y="4754880"/>
-            <a:ext cx="2834640" cy="548640"/>
+          <p:cNvPr id="17" name="Shape 15"/>
+          <p:cNvSpPr/>
+          <p:nvPr/>
+        </p:nvSpPr>
+        <p:spPr>
+          <a:xfrm>
+            <a:off x="7315200" y="4663440"/>
+            <a:ext cx="3291840" cy="548640"/>
           </a:xfrm>
           <a:prstGeom prst="roundRect">
             <a:avLst/>
@@ -4179,14 +4009,53 @@
       </p:sp>
       <p:sp>
         <p:nvSpPr>
+          <p:cNvPr id="18" name="Text 16"/>
+          <p:cNvSpPr/>
+          <p:nvPr/>
+        </p:nvSpPr>
+        <p:spPr>
+          <a:xfrm>
+            <a:off x="7315200" y="4663440"/>
+            <a:ext cx="3291840" cy="548640"/>
+          </a:xfrm>
+          <a:prstGeom prst="rect">
+            <a:avLst/>
+          </a:prstGeom>
+          <a:noFill/>
+          <a:ln/>
+        </p:spPr>
+        <p:txBody>
+          <a:bodyPr wrap="square" rtlCol="0" anchor="ctr"/>
+          <a:lstStyle/>
+          <a:p>
+            <a:pPr algn="ctr" indent="0" marL="0">
+              <a:buNone/>
+            </a:pPr>
+            <a:r>
+              <a:rPr lang="en-US" sz="1200" dirty="0">
+                <a:solidFill>
+                  <a:srgbClr val="34D399"/>
+                </a:solidFill>
+                <a:latin typeface="Microsoft YaHei" pitchFamily="34" charset="0"/>
+                <a:ea typeface="Microsoft YaHei" pitchFamily="34" charset="-122"/>
+                <a:cs typeface="Microsoft YaHei" pitchFamily="34" charset="-120"/>
+              </a:rPr>
+              <a:t>SCORING / TIMEOUT (自愈结算/回退)</a:t>
+            </a:r>
+            <a:endParaRPr lang="en-US" sz="1200" dirty="0"/>
+          </a:p>
+        </p:txBody>
+      </p:sp>
+      <p:sp>
+        <p:nvSpPr>
           <p:cNvPr id="19" name="Text 17"/>
           <p:cNvSpPr/>
           <p:nvPr/>
         </p:nvSpPr>
         <p:spPr>
           <a:xfrm>
-            <a:off x="7589520" y="4754880"/>
-            <a:ext cx="2834640" cy="548640"/>
+            <a:off x="6583680" y="5394960"/>
+            <a:ext cx="4754880" cy="548640"/>
           </a:xfrm>
           <a:prstGeom prst="rect">
             <a:avLst/>
@@ -4202,46 +4071,7 @@
               <a:buNone/>
             </a:pPr>
             <a:r>
-              <a:rPr lang="en-US" sz="1200" dirty="0">
-                <a:solidFill>
-                  <a:srgbClr val="34D399"/>
-                </a:solidFill>
-                <a:latin typeface="Microsoft YaHei" pitchFamily="34" charset="0"/>
-                <a:ea typeface="Microsoft YaHei" pitchFamily="34" charset="-122"/>
-                <a:cs typeface="Microsoft YaHei" pitchFamily="34" charset="-120"/>
-              </a:rPr>
-              <a:t>SCORING / TIMEOUT (自愈结算/回退)</a:t>
-            </a:r>
-            <a:endParaRPr lang="en-US" sz="1200" dirty="0"/>
-          </a:p>
-        </p:txBody>
-      </p:sp>
-      <p:sp>
-        <p:nvSpPr>
-          <p:cNvPr id="20" name="Text 18"/>
-          <p:cNvSpPr/>
-          <p:nvPr/>
-        </p:nvSpPr>
-        <p:spPr>
-          <a:xfrm>
-            <a:off x="6675120" y="5486400"/>
-            <a:ext cx="4663440" cy="457200"/>
-          </a:xfrm>
-          <a:prstGeom prst="rect">
-            <a:avLst/>
-          </a:prstGeom>
-          <a:noFill/>
-          <a:ln/>
-        </p:spPr>
-        <p:txBody>
-          <a:bodyPr wrap="square" rtlCol="0" anchor="ctr"/>
-          <a:lstStyle/>
-          <a:p>
-            <a:pPr algn="ctr" indent="0" marL="0">
-              <a:buNone/>
-            </a:pPr>
-            <a:r>
-              <a:rPr lang="en-US" sz="1100" dirty="0">
+              <a:rPr lang="en-US" sz="1150" dirty="0">
                 <a:solidFill>
                   <a:srgbClr val="94A3B8"/>
                 </a:solidFill>
@@ -4251,7 +4081,7 @@
               </a:rPr>
               <a:t>状态调谐：任意一方利用 kubectl 指令修复健康度至 100% 后，状态机实时捕捉，冻结并切入结算，极速清退临时资源，保证 0 资源泄露。</a:t>
             </a:r>
-            <a:endParaRPr lang="en-US" sz="1100" dirty="0"/>
+            <a:endParaRPr lang="en-US" sz="1150" dirty="0"/>
           </a:p>
         </p:txBody>
       </p:sp>
@@ -4452,8 +4282,8 @@
         </p:nvSpPr>
         <p:spPr>
           <a:xfrm>
-            <a:off x="548640" y="1645920"/>
-            <a:ext cx="5212080" cy="4389120"/>
+            <a:off x="548640" y="1463040"/>
+            <a:ext cx="5303520" cy="4663440"/>
           </a:xfrm>
           <a:prstGeom prst="roundRect">
             <a:avLst/>
@@ -4472,8 +4302,8 @@
         </p:nvSpPr>
         <p:spPr>
           <a:xfrm>
-            <a:off x="822960" y="1828800"/>
-            <a:ext cx="4663440" cy="365760"/>
+            <a:off x="822960" y="1645920"/>
+            <a:ext cx="4754880" cy="4297680"/>
           </a:xfrm>
           <a:prstGeom prst="rect">
             <a:avLst/>
@@ -4486,6 +4316,9 @@
           <a:lstStyle/>
           <a:p>
             <a:pPr indent="0" marL="0">
+              <a:lnSpc>
+                <a:spcPts val="1800"/>
+              </a:lnSpc>
               <a:buNone/>
             </a:pPr>
             <a:r>
@@ -4497,41 +4330,17 @@
                 <a:ea typeface="Microsoft YaHei" pitchFamily="34" charset="-122"/>
                 <a:cs typeface="Microsoft YaHei" pitchFamily="34" charset="-120"/>
               </a:rPr>
-              <a:t>☸️ Kubernetes-Native 真实集群穿透</a:t>
-            </a:r>
-            <a:endParaRPr lang="en-US" sz="1800" dirty="0"/>
-          </a:p>
-        </p:txBody>
-      </p:sp>
-      <p:sp>
-        <p:nvSpPr>
-          <p:cNvPr id="9" name="Text 7"/>
-          <p:cNvSpPr/>
-          <p:nvPr/>
-        </p:nvSpPr>
-        <p:spPr>
-          <a:xfrm>
-            <a:off x="822960" y="2286000"/>
-            <a:ext cx="4663440" cy="3566160"/>
-          </a:xfrm>
-          <a:prstGeom prst="rect">
-            <a:avLst/>
-          </a:prstGeom>
-          <a:noFill/>
-          <a:ln/>
-        </p:spPr>
-        <p:txBody>
-          <a:bodyPr wrap="square" rtlCol="0" anchor="ctr"/>
-          <a:lstStyle/>
-          <a:p>
-            <a:pPr indent="0" marL="0">
-              <a:lnSpc>
-                <a:spcPts val="2000"/>
-              </a:lnSpc>
-              <a:buNone/>
-            </a:pPr>
-            <a:r>
-              <a:rPr lang="en-US" sz="1300" dirty="0">
+              <a:t>☸️ Kubernetes-Native 真实集群穿透
+</a:t>
+            </a:r>
+            <a:pPr indent="0" marL="0">
+              <a:lnSpc>
+                <a:spcPts val="1800"/>
+              </a:lnSpc>
+              <a:buNone/>
+            </a:pPr>
+            <a:r>
+              <a:rPr lang="en-US" sz="1250" b="1" dirty="0">
                 <a:solidFill>
                   <a:srgbClr val="F8FAFC"/>
                 </a:solidFill>
@@ -4539,28 +4348,34 @@
                 <a:ea typeface="Microsoft YaHei" pitchFamily="34" charset="-122"/>
                 <a:cs typeface="Microsoft YaHei" pitchFamily="34" charset="-120"/>
               </a:rPr>
-              <a:t>• 彻底摒弃伪模拟 (Fake Mock)：绝非纸面逻辑模拟，每一次在大屏上观察到的指标振荡、Pod 死亡与重建，都是对真实容器状态的反射。</a:t>
-            </a:r>
-            <a:endParaRPr lang="en-US" sz="1300" dirty="0"/>
-          </a:p>
-          <a:p>
-            <a:pPr indent="0" marL="0">
-              <a:lnSpc>
-                <a:spcPts val="2000"/>
-              </a:lnSpc>
-              <a:buNone/>
-            </a:pPr>
-            <a:endParaRPr lang="en-US" sz="1300" dirty="0"/>
-          </a:p>
-          <a:p>
-            <a:pPr indent="0" marL="0">
-              <a:lnSpc>
-                <a:spcPts val="2000"/>
-              </a:lnSpc>
-              <a:buNone/>
-            </a:pPr>
-            <a:r>
-              <a:rPr lang="en-US" sz="1300" dirty="0">
+              <a:t>• 彻底摒弃伪模拟 (Fake Mock)：</a:t>
+            </a:r>
+            <a:pPr indent="0" marL="0">
+              <a:lnSpc>
+                <a:spcPts val="1800"/>
+              </a:lnSpc>
+              <a:buNone/>
+            </a:pPr>
+            <a:r>
+              <a:rPr lang="en-US" sz="1250" dirty="0">
+                <a:solidFill>
+                  <a:srgbClr val="94A3B8"/>
+                </a:solidFill>
+                <a:latin typeface="Microsoft YaHei" pitchFamily="34" charset="0"/>
+                <a:ea typeface="Microsoft YaHei" pitchFamily="34" charset="-122"/>
+                <a:cs typeface="Microsoft YaHei" pitchFamily="34" charset="-120"/>
+              </a:rPr>
+              <a:t>绝非纸面逻辑模拟，每一次在大屏上观察到的指标振荡、Pod 死亡与重建，都是对真实容器状态的反射。
+</a:t>
+            </a:r>
+            <a:pPr indent="0" marL="0">
+              <a:lnSpc>
+                <a:spcPts val="1800"/>
+              </a:lnSpc>
+              <a:buNone/>
+            </a:pPr>
+            <a:r>
+              <a:rPr lang="en-US" sz="1250" b="1" dirty="0">
                 <a:solidFill>
                   <a:srgbClr val="F8FAFC"/>
                 </a:solidFill>
@@ -4568,28 +4383,34 @@
                 <a:ea typeface="Microsoft YaHei" pitchFamily="34" charset="-122"/>
                 <a:cs typeface="Microsoft YaHei" pitchFamily="34" charset="-120"/>
               </a:rPr>
-              <a:t>• 轻量级原生故障注入：不引入重型混沌框架（如 Chaos Mesh），自主构建轻量化故障套件。使用 Linux 内置 TC Netem 制造高逼真网络抖动、使用 dd 读写模拟磁盘满仓。在微服务架构下直观展现经典“级联雪崩 (Cascading Failure)”效应。</a:t>
-            </a:r>
-            <a:endParaRPr lang="en-US" sz="1300" dirty="0"/>
-          </a:p>
-          <a:p>
-            <a:pPr indent="0" marL="0">
-              <a:lnSpc>
-                <a:spcPts val="2000"/>
-              </a:lnSpc>
-              <a:buNone/>
-            </a:pPr>
-            <a:endParaRPr lang="en-US" sz="1300" dirty="0"/>
-          </a:p>
-          <a:p>
-            <a:pPr indent="0" marL="0">
-              <a:lnSpc>
-                <a:spcPts val="2000"/>
-              </a:lnSpc>
-              <a:buNone/>
-            </a:pPr>
-            <a:r>
-              <a:rPr lang="en-US" sz="1300" dirty="0">
+              <a:t>• 轻量级原生故障注入：</a:t>
+            </a:r>
+            <a:pPr indent="0" marL="0">
+              <a:lnSpc>
+                <a:spcPts val="1800"/>
+              </a:lnSpc>
+              <a:buNone/>
+            </a:pPr>
+            <a:r>
+              <a:rPr lang="en-US" sz="1250" dirty="0">
+                <a:solidFill>
+                  <a:srgbClr val="94A3B8"/>
+                </a:solidFill>
+                <a:latin typeface="Microsoft YaHei" pitchFamily="34" charset="0"/>
+                <a:ea typeface="Microsoft YaHei" pitchFamily="34" charset="-122"/>
+                <a:cs typeface="Microsoft YaHei" pitchFamily="34" charset="-120"/>
+              </a:rPr>
+              <a:t>不引入重型混沌框架，使用内置 TC Netem 制造高逼真网络抖动、使用 dd 读写模拟磁盘满仓，直观再现级联雪崩。
+</a:t>
+            </a:r>
+            <a:pPr indent="0" marL="0">
+              <a:lnSpc>
+                <a:spcPts val="1800"/>
+              </a:lnSpc>
+              <a:buNone/>
+            </a:pPr>
+            <a:r>
+              <a:rPr lang="en-US" sz="1250" b="1" dirty="0">
                 <a:solidFill>
                   <a:srgbClr val="F8FAFC"/>
                 </a:solidFill>
@@ -4597,22 +4418,39 @@
                 <a:ea typeface="Microsoft YaHei" pitchFamily="34" charset="-122"/>
                 <a:cs typeface="Microsoft YaHei" pitchFamily="34" charset="-120"/>
               </a:rPr>
-              <a:t>• 自动资源规整与调谐回路：若游戏超时或异常退出，后端自愈协程秒级触发 restoreFn，全量回滚所有资源变动，维持集群原本健康度。</a:t>
-            </a:r>
-            <a:endParaRPr lang="en-US" sz="1300" dirty="0"/>
-          </a:p>
-        </p:txBody>
-      </p:sp>
-      <p:sp>
-        <p:nvSpPr>
-          <p:cNvPr id="10" name="Shape 8"/>
-          <p:cNvSpPr/>
-          <p:nvPr/>
-        </p:nvSpPr>
-        <p:spPr>
-          <a:xfrm>
-            <a:off x="6400800" y="1645920"/>
-            <a:ext cx="5212080" cy="4389120"/>
+              <a:t>• 自动调谐回滚：</a:t>
+            </a:r>
+            <a:pPr indent="0" marL="0">
+              <a:lnSpc>
+                <a:spcPts val="1800"/>
+              </a:lnSpc>
+              <a:buNone/>
+            </a:pPr>
+            <a:r>
+              <a:rPr lang="en-US" sz="1250" dirty="0">
+                <a:solidFill>
+                  <a:srgbClr val="94A3B8"/>
+                </a:solidFill>
+                <a:latin typeface="Microsoft YaHei" pitchFamily="34" charset="0"/>
+                <a:ea typeface="Microsoft YaHei" pitchFamily="34" charset="-122"/>
+                <a:cs typeface="Microsoft YaHei" pitchFamily="34" charset="-120"/>
+              </a:rPr>
+              <a:t>若演习超时或退赛，后端自愈协程秒级触发 restoreFn，全量清理所有注入故障，维持靶场无残留洁净状态。</a:t>
+            </a:r>
+            <a:endParaRPr lang="en-US" sz="1250" dirty="0"/>
+          </a:p>
+        </p:txBody>
+      </p:sp>
+      <p:sp>
+        <p:nvSpPr>
+          <p:cNvPr id="9" name="Shape 7"/>
+          <p:cNvSpPr/>
+          <p:nvPr/>
+        </p:nvSpPr>
+        <p:spPr>
+          <a:xfrm>
+            <a:off x="6309360" y="1463040"/>
+            <a:ext cx="5303520" cy="4663440"/>
           </a:xfrm>
           <a:prstGeom prst="roundRect">
             <a:avLst/>
@@ -4625,14 +4463,14 @@
       </p:sp>
       <p:sp>
         <p:nvSpPr>
-          <p:cNvPr id="11" name="Text 9"/>
-          <p:cNvSpPr/>
-          <p:nvPr/>
-        </p:nvSpPr>
-        <p:spPr>
-          <a:xfrm>
-            <a:off x="6675120" y="1828800"/>
-            <a:ext cx="4663440" cy="365760"/>
+          <p:cNvPr id="10" name="Text 8"/>
+          <p:cNvSpPr/>
+          <p:nvPr/>
+        </p:nvSpPr>
+        <p:spPr>
+          <a:xfrm>
+            <a:off x="6583680" y="1645920"/>
+            <a:ext cx="4754880" cy="4297680"/>
           </a:xfrm>
           <a:prstGeom prst="rect">
             <a:avLst/>
@@ -4645,6 +4483,9 @@
           <a:lstStyle/>
           <a:p>
             <a:pPr indent="0" marL="0">
+              <a:lnSpc>
+                <a:spcPts val="1800"/>
+              </a:lnSpc>
               <a:buNone/>
             </a:pPr>
             <a:r>
@@ -4656,41 +4497,17 @@
                 <a:ea typeface="Microsoft YaHei" pitchFamily="34" charset="-122"/>
                 <a:cs typeface="Microsoft YaHei" pitchFamily="34" charset="-120"/>
               </a:rPr>
-              <a:t>🔒 安全命令重写网关 (Terminal Proxy)</a:t>
-            </a:r>
-            <a:endParaRPr lang="en-US" sz="1800" dirty="0"/>
-          </a:p>
-        </p:txBody>
-      </p:sp>
-      <p:sp>
-        <p:nvSpPr>
-          <p:cNvPr id="12" name="Text 10"/>
-          <p:cNvSpPr/>
-          <p:nvPr/>
-        </p:nvSpPr>
-        <p:spPr>
-          <a:xfrm>
-            <a:off x="6675120" y="2286000"/>
-            <a:ext cx="4663440" cy="3566160"/>
-          </a:xfrm>
-          <a:prstGeom prst="rect">
-            <a:avLst/>
-          </a:prstGeom>
-          <a:noFill/>
-          <a:ln/>
-        </p:spPr>
-        <p:txBody>
-          <a:bodyPr wrap="square" rtlCol="0" anchor="ctr"/>
-          <a:lstStyle/>
-          <a:p>
-            <a:pPr indent="0" marL="0">
-              <a:lnSpc>
-                <a:spcPts val="2000"/>
-              </a:lnSpc>
-              <a:buNone/>
-            </a:pPr>
-            <a:r>
-              <a:rPr lang="en-US" sz="1300" dirty="0">
+              <a:t>🔒 安全命令重写网关 (Terminal Proxy)
+</a:t>
+            </a:r>
+            <a:pPr indent="0" marL="0">
+              <a:lnSpc>
+                <a:spcPts val="1800"/>
+              </a:lnSpc>
+              <a:buNone/>
+            </a:pPr>
+            <a:r>
+              <a:rPr lang="en-US" sz="1250" b="1" dirty="0">
                 <a:solidFill>
                   <a:srgbClr val="F8FAFC"/>
                 </a:solidFill>
@@ -4698,28 +4515,34 @@
                 <a:ea typeface="Microsoft YaHei" pitchFamily="34" charset="-122"/>
                 <a:cs typeface="Microsoft YaHei" pitchFamily="34" charset="-120"/>
               </a:rPr>
-              <a:t>• 多租户逻辑沙箱隔离：虽然系统为前台用户分配了 live kubectl 操作权，但底层使用正则重写引擎。对所有人类输入命令强制追加并替换 `-n &lt;current-namespace&gt;` 参数，彻底封锁跨命名空间（如越权操作系统级 kube-system 空间）的通道。</a:t>
-            </a:r>
-            <a:endParaRPr lang="en-US" sz="1300" dirty="0"/>
-          </a:p>
-          <a:p>
-            <a:pPr indent="0" marL="0">
-              <a:lnSpc>
-                <a:spcPts val="2000"/>
-              </a:lnSpc>
-              <a:buNone/>
-            </a:pPr>
-            <a:endParaRPr lang="en-US" sz="1300" dirty="0"/>
-          </a:p>
-          <a:p>
-            <a:pPr indent="0" marL="0">
-              <a:lnSpc>
-                <a:spcPts val="2000"/>
-              </a:lnSpc>
-              <a:buNone/>
-            </a:pPr>
-            <a:r>
-              <a:rPr lang="en-US" sz="1300" dirty="0">
+              <a:t>• 多租户逻辑沙箱隔离：</a:t>
+            </a:r>
+            <a:pPr indent="0" marL="0">
+              <a:lnSpc>
+                <a:spcPts val="1800"/>
+              </a:lnSpc>
+              <a:buNone/>
+            </a:pPr>
+            <a:r>
+              <a:rPr lang="en-US" sz="1250" dirty="0">
+                <a:solidFill>
+                  <a:srgbClr val="94A3B8"/>
+                </a:solidFill>
+                <a:latin typeface="Microsoft YaHei" pitchFamily="34" charset="0"/>
+                <a:ea typeface="Microsoft YaHei" pitchFamily="34" charset="-122"/>
+                <a:cs typeface="Microsoft YaHei" pitchFamily="34" charset="-120"/>
+              </a:rPr>
+              <a:t>对所有前台人类输入指令实施正则重写。强制替换并追加 `-n &lt;current-namespace&gt;` 参数，彻底封锁越权删除系统级命名空间的隐患。
+</a:t>
+            </a:r>
+            <a:pPr indent="0" marL="0">
+              <a:lnSpc>
+                <a:spcPts val="1800"/>
+              </a:lnSpc>
+              <a:buNone/>
+            </a:pPr>
+            <a:r>
+              <a:rPr lang="en-US" sz="1250" b="1" dirty="0">
                 <a:solidFill>
                   <a:srgbClr val="F8FAFC"/>
                 </a:solidFill>
@@ -4727,28 +4550,34 @@
                 <a:ea typeface="Microsoft YaHei" pitchFamily="34" charset="-122"/>
                 <a:cs typeface="Microsoft YaHei" pitchFamily="34" charset="-120"/>
               </a:rPr>
-              <a:t>• 静态白名单双重硬拦截：严格限制前台执行 `kubectl get`, `kubectl logs`, `kubectl describe`, `kubectl scale`, `kubectl rollout`, `kubectl exec` 6类核心观测命令。</a:t>
-            </a:r>
-            <a:endParaRPr lang="en-US" sz="1300" dirty="0"/>
-          </a:p>
-          <a:p>
-            <a:pPr indent="0" marL="0">
-              <a:lnSpc>
-                <a:spcPts val="2000"/>
-              </a:lnSpc>
-              <a:buNone/>
-            </a:pPr>
-            <a:endParaRPr lang="en-US" sz="1300" dirty="0"/>
-          </a:p>
-          <a:p>
-            <a:pPr indent="0" marL="0">
-              <a:lnSpc>
-                <a:spcPts val="2000"/>
-              </a:lnSpc>
-              <a:buNone/>
-            </a:pPr>
-            <a:r>
-              <a:rPr lang="en-US" sz="1300" dirty="0">
+              <a:t>• 静态白名单硬拦截：</a:t>
+            </a:r>
+            <a:pPr indent="0" marL="0">
+              <a:lnSpc>
+                <a:spcPts val="1800"/>
+              </a:lnSpc>
+              <a:buNone/>
+            </a:pPr>
+            <a:r>
+              <a:rPr lang="en-US" sz="1250" dirty="0">
+                <a:solidFill>
+                  <a:srgbClr val="94A3B8"/>
+                </a:solidFill>
+                <a:latin typeface="Microsoft YaHei" pitchFamily="34" charset="0"/>
+                <a:ea typeface="Microsoft YaHei" pitchFamily="34" charset="-122"/>
+                <a:cs typeface="Microsoft YaHei" pitchFamily="34" charset="-120"/>
+              </a:rPr>
+              <a:t>严格限制前台执行 `kubectl get`, `kubectl logs`, `kubectl describe`, `kubectl scale`, `kubectl rollout`, `kubectl exec` 等 6 类核心观测命令。
+</a:t>
+            </a:r>
+            <a:pPr indent="0" marL="0">
+              <a:lnSpc>
+                <a:spcPts val="1800"/>
+              </a:lnSpc>
+              <a:buNone/>
+            </a:pPr>
+            <a:r>
+              <a:rPr lang="en-US" sz="1250" b="1" dirty="0">
                 <a:solidFill>
                   <a:srgbClr val="F8FAFC"/>
                 </a:solidFill>
@@ -4756,9 +4585,26 @@
                 <a:ea typeface="Microsoft YaHei" pitchFamily="34" charset="-122"/>
                 <a:cs typeface="Microsoft YaHei" pitchFamily="34" charset="-120"/>
               </a:rPr>
-              <a:t>• 脚本逃逸与漏洞拦截：物理阻断分号、重定向、非安全管道符等恶意字符拼接，打造云原生安全的最佳实践。</a:t>
-            </a:r>
-            <a:endParaRPr lang="en-US" sz="1300" dirty="0"/>
+              <a:t>• 拼接逃逸过滤：</a:t>
+            </a:r>
+            <a:pPr indent="0" marL="0">
+              <a:lnSpc>
+                <a:spcPts val="1800"/>
+              </a:lnSpc>
+              <a:buNone/>
+            </a:pPr>
+            <a:r>
+              <a:rPr lang="en-US" sz="1250" dirty="0">
+                <a:solidFill>
+                  <a:srgbClr val="94A3B8"/>
+                </a:solidFill>
+                <a:latin typeface="Microsoft YaHei" pitchFamily="34" charset="0"/>
+                <a:ea typeface="Microsoft YaHei" pitchFamily="34" charset="-122"/>
+                <a:cs typeface="Microsoft YaHei" pitchFamily="34" charset="-120"/>
+              </a:rPr>
+              <a:t>物理阻断分号、后台挂起、多重命令拼接，在开放运维自主权的同时实现极高等级的网络防御。</a:t>
+            </a:r>
+            <a:endParaRPr lang="en-US" sz="1250" dirty="0"/>
           </a:p>
         </p:txBody>
       </p:sp>
@@ -4959,8 +4805,8 @@
         </p:nvSpPr>
         <p:spPr>
           <a:xfrm>
-            <a:off x="548640" y="1645920"/>
-            <a:ext cx="5212080" cy="4389120"/>
+            <a:off x="548640" y="1463040"/>
+            <a:ext cx="5303520" cy="4663440"/>
           </a:xfrm>
           <a:prstGeom prst="roundRect">
             <a:avLst/>
@@ -4979,8 +4825,8 @@
         </p:nvSpPr>
         <p:spPr>
           <a:xfrm>
-            <a:off x="822960" y="1828800"/>
-            <a:ext cx="4663440" cy="365760"/>
+            <a:off x="822960" y="1645920"/>
+            <a:ext cx="4754880" cy="4297680"/>
           </a:xfrm>
           <a:prstGeom prst="rect">
             <a:avLst/>
@@ -4993,6 +4839,9 @@
           <a:lstStyle/>
           <a:p>
             <a:pPr indent="0" marL="0">
+              <a:lnSpc>
+                <a:spcPts val="1800"/>
+              </a:lnSpc>
               <a:buNone/>
             </a:pPr>
             <a:r>
@@ -5004,41 +4853,17 @@
                 <a:ea typeface="Microsoft YaHei" pitchFamily="34" charset="-122"/>
                 <a:cs typeface="Microsoft YaHei" pitchFamily="34" charset="-120"/>
               </a:rPr>
-              <a:t>🔍 差异化快照剪枝算法 (Snapshot Pruning)</a:t>
-            </a:r>
-            <a:endParaRPr lang="en-US" sz="1800" dirty="0"/>
-          </a:p>
-        </p:txBody>
-      </p:sp>
-      <p:sp>
-        <p:nvSpPr>
-          <p:cNvPr id="9" name="Text 7"/>
-          <p:cNvSpPr/>
-          <p:nvPr/>
-        </p:nvSpPr>
-        <p:spPr>
-          <a:xfrm>
-            <a:off x="822960" y="2286000"/>
-            <a:ext cx="4663440" cy="3566160"/>
-          </a:xfrm>
-          <a:prstGeom prst="rect">
-            <a:avLst/>
-          </a:prstGeom>
-          <a:noFill/>
-          <a:ln/>
-        </p:spPr>
-        <p:txBody>
-          <a:bodyPr wrap="square" rtlCol="0" anchor="ctr"/>
-          <a:lstStyle/>
-          <a:p>
-            <a:pPr indent="0" marL="0">
-              <a:lnSpc>
-                <a:spcPts val="2000"/>
-              </a:lnSpc>
-              <a:buNone/>
-            </a:pPr>
-            <a:r>
-              <a:rPr lang="en-US" sz="1300" dirty="0">
+              <a:t>🔍 差异化快照剪枝算法 (Snapshot Pruning)
+</a:t>
+            </a:r>
+            <a:pPr indent="0" marL="0">
+              <a:lnSpc>
+                <a:spcPts val="1800"/>
+              </a:lnSpc>
+              <a:buNone/>
+            </a:pPr>
+            <a:r>
+              <a:rPr lang="en-US" sz="1250" b="1" dirty="0">
                 <a:solidFill>
                   <a:srgbClr val="F8FAFC"/>
                 </a:solidFill>
@@ -5046,28 +4871,34 @@
                 <a:ea typeface="Microsoft YaHei" pitchFamily="34" charset="-122"/>
                 <a:cs typeface="Microsoft YaHei" pitchFamily="34" charset="-120"/>
               </a:rPr>
-              <a:t>• 解决 SRE 日志巨量噪声：微服务运行时的资源数据极为庞杂，直接输入 LLM 极易导致模型在长上下文中迷失 (Lost in the Middle) 且 Token 开销巨大。</a:t>
-            </a:r>
-            <a:endParaRPr lang="en-US" sz="1300" dirty="0"/>
-          </a:p>
-          <a:p>
-            <a:pPr indent="0" marL="0">
-              <a:lnSpc>
-                <a:spcPts val="2000"/>
-              </a:lnSpc>
-              <a:buNone/>
-            </a:pPr>
-            <a:endParaRPr lang="en-US" sz="1300" dirty="0"/>
-          </a:p>
-          <a:p>
-            <a:pPr indent="0" marL="0">
-              <a:lnSpc>
-                <a:spcPts val="2000"/>
-              </a:lnSpc>
-              <a:buNone/>
-            </a:pPr>
-            <a:r>
-              <a:rPr lang="en-US" sz="1300" dirty="0">
+              <a:t>• 解决 SRE 日志巨量噪声：</a:t>
+            </a:r>
+            <a:pPr indent="0" marL="0">
+              <a:lnSpc>
+                <a:spcPts val="1800"/>
+              </a:lnSpc>
+              <a:buNone/>
+            </a:pPr>
+            <a:r>
+              <a:rPr lang="en-US" sz="1250" dirty="0">
+                <a:solidFill>
+                  <a:srgbClr val="94A3B8"/>
+                </a:solidFill>
+                <a:latin typeface="Microsoft YaHei" pitchFamily="34" charset="0"/>
+                <a:ea typeface="Microsoft YaHei" pitchFamily="34" charset="-122"/>
+                <a:cs typeface="Microsoft YaHei" pitchFamily="34" charset="-120"/>
+              </a:rPr>
+              <a:t>微服务运行时数据泛滥，长上下文极易导致 LLM 决策迷失 (Lost in the Middle) 并推高 Token 费用。
+</a:t>
+            </a:r>
+            <a:pPr indent="0" marL="0">
+              <a:lnSpc>
+                <a:spcPts val="1800"/>
+              </a:lnSpc>
+              <a:buNone/>
+            </a:pPr>
+            <a:r>
+              <a:rPr lang="en-US" sz="1250" b="1" dirty="0">
                 <a:solidFill>
                   <a:srgbClr val="F8FAFC"/>
                 </a:solidFill>
@@ -5075,28 +4906,34 @@
                 <a:ea typeface="Microsoft YaHei" pitchFamily="34" charset="-122"/>
                 <a:cs typeface="Microsoft YaHei" pitchFamily="34" charset="-120"/>
               </a:rPr>
-              <a:t>• 差异对比降噪 (Baseline Diffing)：系统自主实现快照剪枝。将当前时刻的 Pod、Deploy、Events 与系统健康时的“黄金基线 (Golden Baseline)”进行原子差异对比。自动剔除一切正常的组件和冗余 K8s 元数据。</a:t>
-            </a:r>
-            <a:endParaRPr lang="en-US" sz="1300" dirty="0"/>
-          </a:p>
-          <a:p>
-            <a:pPr indent="0" marL="0">
-              <a:lnSpc>
-                <a:spcPts val="2000"/>
-              </a:lnSpc>
-              <a:buNone/>
-            </a:pPr>
-            <a:endParaRPr lang="en-US" sz="1300" dirty="0"/>
-          </a:p>
-          <a:p>
-            <a:pPr indent="0" marL="0">
-              <a:lnSpc>
-                <a:spcPts val="2000"/>
-              </a:lnSpc>
-              <a:buNone/>
-            </a:pPr>
-            <a:r>
-              <a:rPr lang="en-US" sz="1300" dirty="0">
+              <a:t>• 黄金基线差异对比 (Baseline Diffing)：</a:t>
+            </a:r>
+            <a:pPr indent="0" marL="0">
+              <a:lnSpc>
+                <a:spcPts val="1800"/>
+              </a:lnSpc>
+              <a:buNone/>
+            </a:pPr>
+            <a:r>
+              <a:rPr lang="en-US" sz="1250" dirty="0">
+                <a:solidFill>
+                  <a:srgbClr val="94A3B8"/>
+                </a:solidFill>
+                <a:latin typeface="Microsoft YaHei" pitchFamily="34" charset="0"/>
+                <a:ea typeface="Microsoft YaHei" pitchFamily="34" charset="-122"/>
+                <a:cs typeface="Microsoft YaHei" pitchFamily="34" charset="-120"/>
+              </a:rPr>
+              <a:t>系统自主实现快照剪枝。将当前时刻的 Pod、Deploy、Events 与系统健康时的基线作原子差异对比。自动剔除一切正常的服务细节和长串 UUID。
+</a:t>
+            </a:r>
+            <a:pPr indent="0" marL="0">
+              <a:lnSpc>
+                <a:spcPts val="1800"/>
+              </a:lnSpc>
+              <a:buNone/>
+            </a:pPr>
+            <a:r>
+              <a:rPr lang="en-US" sz="1250" b="1" dirty="0">
                 <a:solidFill>
                   <a:srgbClr val="F8FAFC"/>
                 </a:solidFill>
@@ -5104,22 +4941,39 @@
                 <a:ea typeface="Microsoft YaHei" pitchFamily="34" charset="-122"/>
                 <a:cs typeface="Microsoft YaHei" pitchFamily="34" charset="-120"/>
               </a:rPr>
-              <a:t>• 高信噪比 Prompt 输入：实现 75% 以上的 Context 极限瘦身，提供极高确定性的 Prompt，将分析效率和准确度推升至工业级水准。</a:t>
-            </a:r>
-            <a:endParaRPr lang="en-US" sz="1300" dirty="0"/>
-          </a:p>
-        </p:txBody>
-      </p:sp>
-      <p:sp>
-        <p:nvSpPr>
-          <p:cNvPr id="10" name="Shape 8"/>
-          <p:cNvSpPr/>
-          <p:nvPr/>
-        </p:nvSpPr>
-        <p:spPr>
-          <a:xfrm>
-            <a:off x="6400800" y="1645920"/>
-            <a:ext cx="5212080" cy="4389120"/>
+              <a:t>• 极限瘦身 75% 以上：</a:t>
+            </a:r>
+            <a:pPr indent="0" marL="0">
+              <a:lnSpc>
+                <a:spcPts val="1800"/>
+              </a:lnSpc>
+              <a:buNone/>
+            </a:pPr>
+            <a:r>
+              <a:rPr lang="en-US" sz="1250" dirty="0">
+                <a:solidFill>
+                  <a:srgbClr val="94A3B8"/>
+                </a:solidFill>
+                <a:latin typeface="Microsoft YaHei" pitchFamily="34" charset="0"/>
+                <a:ea typeface="Microsoft YaHei" pitchFamily="34" charset="-122"/>
+                <a:cs typeface="Microsoft YaHei" pitchFamily="34" charset="-120"/>
+              </a:rPr>
+              <a:t>仅向 LLM 喂入高信噪比突发异常快照，将 AI 定位分析的确定性推升至工业级水准。</a:t>
+            </a:r>
+            <a:endParaRPr lang="en-US" sz="1250" dirty="0"/>
+          </a:p>
+        </p:txBody>
+      </p:sp>
+      <p:sp>
+        <p:nvSpPr>
+          <p:cNvPr id="9" name="Shape 7"/>
+          <p:cNvSpPr/>
+          <p:nvPr/>
+        </p:nvSpPr>
+        <p:spPr>
+          <a:xfrm>
+            <a:off x="6309360" y="1463040"/>
+            <a:ext cx="5303520" cy="4663440"/>
           </a:xfrm>
           <a:prstGeom prst="roundRect">
             <a:avLst/>
@@ -5132,14 +4986,14 @@
       </p:sp>
       <p:sp>
         <p:nvSpPr>
-          <p:cNvPr id="11" name="Text 9"/>
-          <p:cNvSpPr/>
-          <p:nvPr/>
-        </p:nvSpPr>
-        <p:spPr>
-          <a:xfrm>
-            <a:off x="6675120" y="1828800"/>
-            <a:ext cx="4663440" cy="365760"/>
+          <p:cNvPr id="10" name="Text 8"/>
+          <p:cNvSpPr/>
+          <p:nvPr/>
+        </p:nvSpPr>
+        <p:spPr>
+          <a:xfrm>
+            <a:off x="6583680" y="1645920"/>
+            <a:ext cx="4754880" cy="4297680"/>
           </a:xfrm>
           <a:prstGeom prst="rect">
             <a:avLst/>
@@ -5152,6 +5006,9 @@
           <a:lstStyle/>
           <a:p>
             <a:pPr indent="0" marL="0">
+              <a:lnSpc>
+                <a:spcPts val="1600"/>
+              </a:lnSpc>
               <a:buNone/>
             </a:pPr>
             <a:r>
@@ -5163,41 +5020,17 @@
                 <a:ea typeface="Microsoft YaHei" pitchFamily="34" charset="-122"/>
                 <a:cs typeface="Microsoft YaHei" pitchFamily="34" charset="-120"/>
               </a:rPr>
-              <a:t>🤖 OODA 循环闭环自愈 Agent</a:t>
-            </a:r>
-            <a:endParaRPr lang="en-US" sz="1800" dirty="0"/>
-          </a:p>
-        </p:txBody>
-      </p:sp>
-      <p:sp>
-        <p:nvSpPr>
-          <p:cNvPr id="12" name="Text 10"/>
-          <p:cNvSpPr/>
-          <p:nvPr/>
-        </p:nvSpPr>
-        <p:spPr>
-          <a:xfrm>
-            <a:off x="6675120" y="2286000"/>
-            <a:ext cx="4663440" cy="3566160"/>
-          </a:xfrm>
-          <a:prstGeom prst="rect">
-            <a:avLst/>
-          </a:prstGeom>
-          <a:noFill/>
-          <a:ln/>
-        </p:spPr>
-        <p:txBody>
-          <a:bodyPr wrap="square" rtlCol="0" anchor="ctr"/>
-          <a:lstStyle/>
-          <a:p>
-            <a:pPr indent="0" marL="0">
-              <a:lnSpc>
-                <a:spcPts val="1800"/>
-              </a:lnSpc>
-              <a:buNone/>
-            </a:pPr>
-            <a:r>
-              <a:rPr lang="en-US" sz="1250" dirty="0">
+              <a:t>🤖 OODA 循环闭环自愈 Agent
+</a:t>
+            </a:r>
+            <a:pPr indent="0" marL="0">
+              <a:lnSpc>
+                <a:spcPts val="1600"/>
+              </a:lnSpc>
+              <a:buNone/>
+            </a:pPr>
+            <a:r>
+              <a:rPr lang="en-US" sz="1200" b="1" dirty="0">
                 <a:solidFill>
                   <a:srgbClr val="F8FAFC"/>
                 </a:solidFill>
@@ -5205,19 +5038,88 @@
                 <a:ea typeface="Microsoft YaHei" pitchFamily="34" charset="-122"/>
                 <a:cs typeface="Microsoft YaHei" pitchFamily="34" charset="-120"/>
               </a:rPr>
-              <a:t>• OODA 理论闭环：</a:t>
-            </a:r>
-            <a:endParaRPr lang="en-US" sz="1250" dirty="0"/>
-          </a:p>
-          <a:p>
-            <a:pPr indent="0" marL="0">
-              <a:lnSpc>
-                <a:spcPts val="1800"/>
-              </a:lnSpc>
-              <a:buNone/>
-            </a:pPr>
-            <a:r>
-              <a:rPr lang="en-US" sz="1250" dirty="0">
+              <a:t>• OODA 理论完美闭环：</a:t>
+            </a:r>
+            <a:pPr indent="0" marL="0">
+              <a:lnSpc>
+                <a:spcPts val="1600"/>
+              </a:lnSpc>
+              <a:buNone/>
+            </a:pPr>
+            <a:r>
+              <a:rPr lang="en-US" sz="1200" dirty="0">
+                <a:solidFill>
+                  <a:srgbClr val="94A3B8"/>
+                </a:solidFill>
+                <a:latin typeface="Microsoft YaHei" pitchFamily="34" charset="0"/>
+                <a:ea typeface="Microsoft YaHei" pitchFamily="34" charset="-122"/>
+                <a:cs typeface="Microsoft YaHei" pitchFamily="34" charset="-120"/>
+              </a:rPr>
+              <a:t>  - Observe (观察)：每 5 秒拉取降噪后的高精度快照。
+</a:t>
+            </a:r>
+            <a:pPr indent="0" marL="0">
+              <a:lnSpc>
+                <a:spcPts val="1600"/>
+              </a:lnSpc>
+              <a:buNone/>
+            </a:pPr>
+            <a:r>
+              <a:rPr lang="en-US" sz="1200" dirty="0">
+                <a:solidFill>
+                  <a:srgbClr val="94A3B8"/>
+                </a:solidFill>
+                <a:latin typeface="Microsoft YaHei" pitchFamily="34" charset="0"/>
+                <a:ea typeface="Microsoft YaHei" pitchFamily="34" charset="-122"/>
+                <a:cs typeface="Microsoft YaHei" pitchFamily="34" charset="-120"/>
+              </a:rPr>
+              <a:t>  - Orient (调整)：拓扑分析，理清微服务故障扩散链。
+</a:t>
+            </a:r>
+            <a:pPr indent="0" marL="0">
+              <a:lnSpc>
+                <a:spcPts val="1600"/>
+              </a:lnSpc>
+              <a:buNone/>
+            </a:pPr>
+            <a:r>
+              <a:rPr lang="en-US" sz="1200" dirty="0">
+                <a:solidFill>
+                  <a:srgbClr val="94A3B8"/>
+                </a:solidFill>
+                <a:latin typeface="Microsoft YaHei" pitchFamily="34" charset="0"/>
+                <a:ea typeface="Microsoft YaHei" pitchFamily="34" charset="-122"/>
+                <a:cs typeface="Microsoft YaHei" pitchFamily="34" charset="-120"/>
+              </a:rPr>
+              <a:t>  - Decide (决策)：LLM 根据上下文智能决策修复脚本。
+</a:t>
+            </a:r>
+            <a:pPr indent="0" marL="0">
+              <a:lnSpc>
+                <a:spcPts val="1600"/>
+              </a:lnSpc>
+              <a:buNone/>
+            </a:pPr>
+            <a:r>
+              <a:rPr lang="en-US" sz="1200" dirty="0">
+                <a:solidFill>
+                  <a:srgbClr val="94A3B8"/>
+                </a:solidFill>
+                <a:latin typeface="Microsoft YaHei" pitchFamily="34" charset="0"/>
+                <a:ea typeface="Microsoft YaHei" pitchFamily="34" charset="-122"/>
+                <a:cs typeface="Microsoft YaHei" pitchFamily="34" charset="-120"/>
+              </a:rPr>
+              <a:t>  - Action (执行)：自动执行 kubectl 命令并在调谐环路中迭代检验修复结果，实现了闭环全自愈。
+</a:t>
+            </a:r>
+            <a:pPr indent="0" marL="0">
+              <a:lnSpc>
+                <a:spcPts val="1600"/>
+              </a:lnSpc>
+              <a:buNone/>
+            </a:pPr>
+            <a:r>
+              <a:rPr lang="en-US" sz="1200" b="1" dirty="0">
                 <a:solidFill>
                   <a:srgbClr val="F8FAFC"/>
                 </a:solidFill>
@@ -5225,98 +5127,26 @@
                 <a:ea typeface="Microsoft YaHei" pitchFamily="34" charset="-122"/>
                 <a:cs typeface="Microsoft YaHei" pitchFamily="34" charset="-120"/>
               </a:rPr>
-              <a:t>  - Observe (观察)：每 5 秒自动爬取高信噪比集群健康状态快照。</a:t>
-            </a:r>
-            <a:endParaRPr lang="en-US" sz="1250" dirty="0"/>
-          </a:p>
-          <a:p>
-            <a:pPr indent="0" marL="0">
-              <a:lnSpc>
-                <a:spcPts val="1800"/>
-              </a:lnSpc>
-              <a:buNone/>
-            </a:pPr>
-            <a:r>
-              <a:rPr lang="en-US" sz="1250" dirty="0">
-                <a:solidFill>
-                  <a:srgbClr val="F8FAFC"/>
-                </a:solidFill>
-                <a:latin typeface="Microsoft YaHei" pitchFamily="34" charset="0"/>
-                <a:ea typeface="Microsoft YaHei" pitchFamily="34" charset="-122"/>
-                <a:cs typeface="Microsoft YaHei" pitchFamily="34" charset="-120"/>
-              </a:rPr>
-              <a:t>  - Orient (调整)：识别微服务架构中的级联调用断裂处。</a:t>
-            </a:r>
-            <a:endParaRPr lang="en-US" sz="1250" dirty="0"/>
-          </a:p>
-          <a:p>
-            <a:pPr indent="0" marL="0">
-              <a:lnSpc>
-                <a:spcPts val="1800"/>
-              </a:lnSpc>
-              <a:buNone/>
-            </a:pPr>
-            <a:r>
-              <a:rPr lang="en-US" sz="1250" dirty="0">
-                <a:solidFill>
-                  <a:srgbClr val="F8FAFC"/>
-                </a:solidFill>
-                <a:latin typeface="Microsoft YaHei" pitchFamily="34" charset="0"/>
-                <a:ea typeface="Microsoft YaHei" pitchFamily="34" charset="-122"/>
-                <a:cs typeface="Microsoft YaHei" pitchFamily="34" charset="-120"/>
-              </a:rPr>
-              <a:t>  - Decide (决策)：LLM 推理出可能的根因，输出符合规范的修复指令。</a:t>
-            </a:r>
-            <a:endParaRPr lang="en-US" sz="1250" dirty="0"/>
-          </a:p>
-          <a:p>
-            <a:pPr indent="0" marL="0">
-              <a:lnSpc>
-                <a:spcPts val="1800"/>
-              </a:lnSpc>
-              <a:buNone/>
-            </a:pPr>
-            <a:r>
-              <a:rPr lang="en-US" sz="1250" dirty="0">
-                <a:solidFill>
-                  <a:srgbClr val="F8FAFC"/>
-                </a:solidFill>
-                <a:latin typeface="Microsoft YaHei" pitchFamily="34" charset="0"/>
-                <a:ea typeface="Microsoft YaHei" pitchFamily="34" charset="-122"/>
-                <a:cs typeface="Microsoft YaHei" pitchFamily="34" charset="-120"/>
-              </a:rPr>
-              <a:t>  - Action (执行)：自动下发 kubectl 修复指令，并在下一轮 Observe 中闭环检验修复成效，做到了完全无人工干预的“自愈决策闭环”。</a:t>
-            </a:r>
-            <a:endParaRPr lang="en-US" sz="1250" dirty="0"/>
-          </a:p>
-          <a:p>
-            <a:pPr indent="0" marL="0">
-              <a:lnSpc>
-                <a:spcPts val="1800"/>
-              </a:lnSpc>
-              <a:buNone/>
-            </a:pPr>
-            <a:endParaRPr lang="en-US" sz="1250" dirty="0"/>
-          </a:p>
-          <a:p>
-            <a:pPr indent="0" marL="0">
-              <a:lnSpc>
-                <a:spcPts val="1800"/>
-              </a:lnSpc>
-              <a:buNone/>
-            </a:pPr>
-            <a:r>
-              <a:rPr lang="en-US" sz="1250" dirty="0">
-                <a:solidFill>
-                  <a:srgbClr val="F8FAFC"/>
-                </a:solidFill>
-                <a:latin typeface="Microsoft YaHei" pitchFamily="34" charset="0"/>
-                <a:ea typeface="Microsoft YaHei" pitchFamily="34" charset="-122"/>
-                <a:cs typeface="Microsoft YaHei" pitchFamily="34" charset="-120"/>
-              </a:rPr>
-              <a:t>• 思维链 (CoT) 推演可视化：AI Agent 每次的怀疑对象、推理依据均实时输出在大屏上，变“黑盒分数”为“白盒推演”，极具教学展示性。</a:t>
-            </a:r>
-            <a:endParaRPr lang="en-US" sz="1250" dirty="0"/>
+              <a:t>• 推理链白盒可视化：</a:t>
+            </a:r>
+            <a:pPr indent="0" marL="0">
+              <a:lnSpc>
+                <a:spcPts val="1600"/>
+              </a:lnSpc>
+              <a:buNone/>
+            </a:pPr>
+            <a:r>
+              <a:rPr lang="en-US" sz="1200" dirty="0">
+                <a:solidFill>
+                  <a:srgbClr val="94A3B8"/>
+                </a:solidFill>
+                <a:latin typeface="Microsoft YaHei" pitchFamily="34" charset="0"/>
+                <a:ea typeface="Microsoft YaHei" pitchFamily="34" charset="-122"/>
+                <a:cs typeface="Microsoft YaHei" pitchFamily="34" charset="-120"/>
+              </a:rPr>
+              <a:t>AI 每次的怀疑对象与思考逻辑（CoT）实时推送到大屏，将盲盒打分提升为高价值人机协同教学。</a:t>
+            </a:r>
+            <a:endParaRPr lang="en-US" sz="1200" dirty="0"/>
           </a:p>
         </p:txBody>
       </p:sp>
@@ -5518,7 +5348,7 @@
         <p:spPr>
           <a:xfrm>
             <a:off x="548640" y="1280160"/>
-            <a:ext cx="10972800" cy="365760"/>
+            <a:ext cx="10972800" cy="274320"/>
           </a:xfrm>
           <a:prstGeom prst="rect">
             <a:avLst/>
@@ -5556,8 +5386,8 @@
         </p:nvSpPr>
         <p:spPr>
           <a:xfrm>
-            <a:off x="548640" y="1737360"/>
-            <a:ext cx="5212080" cy="2103120"/>
+            <a:off x="548640" y="1645920"/>
+            <a:ext cx="5303520" cy="2103120"/>
           </a:xfrm>
           <a:prstGeom prst="roundRect">
             <a:avLst/>
@@ -5576,8 +5406,8 @@
         </p:nvSpPr>
         <p:spPr>
           <a:xfrm>
-            <a:off x="822960" y="1920240"/>
-            <a:ext cx="4663440" cy="274320"/>
+            <a:off x="822960" y="1828800"/>
+            <a:ext cx="4754880" cy="1737360"/>
           </a:xfrm>
           <a:prstGeom prst="rect">
             <a:avLst/>
@@ -5590,6 +5420,9 @@
           <a:lstStyle/>
           <a:p>
             <a:pPr indent="0" marL="0">
+              <a:lnSpc>
+                <a:spcPts val="1800"/>
+              </a:lnSpc>
               <a:buNone/>
             </a:pPr>
             <a:r>
@@ -5601,33 +5434,9 @@
                 <a:ea typeface="Microsoft YaHei" pitchFamily="34" charset="-122"/>
                 <a:cs typeface="Microsoft YaHei" pitchFamily="34" charset="-120"/>
               </a:rPr>
-              <a:t>⏱️ Speed (速度维度 - 权重 50%)</a:t>
-            </a:r>
-            <a:endParaRPr lang="en-US" sz="1600" dirty="0"/>
-          </a:p>
-        </p:txBody>
-      </p:sp>
-      <p:sp>
-        <p:nvSpPr>
-          <p:cNvPr id="10" name="Text 8"/>
-          <p:cNvSpPr/>
-          <p:nvPr/>
-        </p:nvSpPr>
-        <p:spPr>
-          <a:xfrm>
-            <a:off x="822960" y="2286000"/>
-            <a:ext cx="4663440" cy="1371600"/>
-          </a:xfrm>
-          <a:prstGeom prst="rect">
-            <a:avLst/>
-          </a:prstGeom>
-          <a:noFill/>
-          <a:ln/>
-        </p:spPr>
-        <p:txBody>
-          <a:bodyPr wrap="square" rtlCol="0" anchor="ctr"/>
-          <a:lstStyle/>
-          <a:p>
+              <a:t>⏱️ Speed (速度维度 - 权重 50%)
+</a:t>
+            </a:r>
             <a:pPr indent="0" marL="0">
               <a:lnSpc>
                 <a:spcPts val="1800"/>
@@ -5635,30 +5444,30 @@
               <a:buNone/>
             </a:pPr>
             <a:r>
-              <a:rPr lang="en-US" sz="1300" dirty="0">
-                <a:solidFill>
-                  <a:srgbClr val="F8FAFC"/>
-                </a:solidFill>
-                <a:latin typeface="Microsoft YaHei" pitchFamily="34" charset="0"/>
-                <a:ea typeface="Microsoft YaHei" pitchFamily="34" charset="-122"/>
-                <a:cs typeface="Microsoft YaHei" pitchFamily="34" charset="-120"/>
-              </a:rPr>
-              <a:t>依据最终抢修完成的耗时呈线性衰减。完成越快得分越高，超时未完成为 0 分。高度激发应急演练的时间压力实感。</a:t>
-            </a:r>
-            <a:endParaRPr lang="en-US" sz="1300" dirty="0"/>
-          </a:p>
-        </p:txBody>
-      </p:sp>
-      <p:sp>
-        <p:nvSpPr>
-          <p:cNvPr id="11" name="Shape 9"/>
-          <p:cNvSpPr/>
-          <p:nvPr/>
-        </p:nvSpPr>
-        <p:spPr>
-          <a:xfrm>
-            <a:off x="6400800" y="1737360"/>
-            <a:ext cx="5212080" cy="2103120"/>
+              <a:rPr lang="en-US" sz="1250" dirty="0">
+                <a:solidFill>
+                  <a:srgbClr val="94A3B8"/>
+                </a:solidFill>
+                <a:latin typeface="Microsoft YaHei" pitchFamily="34" charset="0"/>
+                <a:ea typeface="Microsoft YaHei" pitchFamily="34" charset="-122"/>
+                <a:cs typeface="Microsoft YaHei" pitchFamily="34" charset="-120"/>
+              </a:rPr>
+              <a:t>依据最终抢修完成的耗时呈线性数学衰减。自愈越快，速度得分越高；超时未完成为 0 分，高度量化应急时效实感。</a:t>
+            </a:r>
+            <a:endParaRPr lang="en-US" sz="1250" dirty="0"/>
+          </a:p>
+        </p:txBody>
+      </p:sp>
+      <p:sp>
+        <p:nvSpPr>
+          <p:cNvPr id="10" name="Shape 8"/>
+          <p:cNvSpPr/>
+          <p:nvPr/>
+        </p:nvSpPr>
+        <p:spPr>
+          <a:xfrm>
+            <a:off x="6309360" y="1645920"/>
+            <a:ext cx="5303520" cy="2103120"/>
           </a:xfrm>
           <a:prstGeom prst="roundRect">
             <a:avLst/>
@@ -5671,14 +5480,14 @@
       </p:sp>
       <p:sp>
         <p:nvSpPr>
-          <p:cNvPr id="12" name="Text 10"/>
-          <p:cNvSpPr/>
-          <p:nvPr/>
-        </p:nvSpPr>
-        <p:spPr>
-          <a:xfrm>
-            <a:off x="6675120" y="1920240"/>
-            <a:ext cx="4663440" cy="274320"/>
+          <p:cNvPr id="11" name="Text 9"/>
+          <p:cNvSpPr/>
+          <p:nvPr/>
+        </p:nvSpPr>
+        <p:spPr>
+          <a:xfrm>
+            <a:off x="6583680" y="1828800"/>
+            <a:ext cx="4754880" cy="1737360"/>
           </a:xfrm>
           <a:prstGeom prst="rect">
             <a:avLst/>
@@ -5691,6 +5500,9 @@
           <a:lstStyle/>
           <a:p>
             <a:pPr indent="0" marL="0">
+              <a:lnSpc>
+                <a:spcPts val="1800"/>
+              </a:lnSpc>
               <a:buNone/>
             </a:pPr>
             <a:r>
@@ -5702,33 +5514,9 @@
                 <a:ea typeface="Microsoft YaHei" pitchFamily="34" charset="-122"/>
                 <a:cs typeface="Microsoft YaHei" pitchFamily="34" charset="-120"/>
               </a:rPr>
-              <a:t>🎯 Accuracy (诊断准确度 - 权重 20%)</a:t>
-            </a:r>
-            <a:endParaRPr lang="en-US" sz="1600" dirty="0"/>
-          </a:p>
-        </p:txBody>
-      </p:sp>
-      <p:sp>
-        <p:nvSpPr>
-          <p:cNvPr id="13" name="Text 11"/>
-          <p:cNvSpPr/>
-          <p:nvPr/>
-        </p:nvSpPr>
-        <p:spPr>
-          <a:xfrm>
-            <a:off x="6675120" y="2286000"/>
-            <a:ext cx="4663440" cy="1371600"/>
-          </a:xfrm>
-          <a:prstGeom prst="rect">
-            <a:avLst/>
-          </a:prstGeom>
-          <a:noFill/>
-          <a:ln/>
-        </p:spPr>
-        <p:txBody>
-          <a:bodyPr wrap="square" rtlCol="0" anchor="ctr"/>
-          <a:lstStyle/>
-          <a:p>
+              <a:t>🎯 Accuracy (根因准确度 - 权重 20%)
+</a:t>
+            </a:r>
             <a:pPr indent="0" marL="0">
               <a:lnSpc>
                 <a:spcPts val="1800"/>
@@ -5736,30 +5524,30 @@
               <a:buNone/>
             </a:pPr>
             <a:r>
-              <a:rPr lang="en-US" sz="1300" dirty="0">
-                <a:solidFill>
-                  <a:srgbClr val="F8FAFC"/>
-                </a:solidFill>
-                <a:latin typeface="Microsoft YaHei" pitchFamily="34" charset="0"/>
-                <a:ea typeface="Microsoft YaHei" pitchFamily="34" charset="-122"/>
-                <a:cs typeface="Microsoft YaHei" pitchFamily="34" charset="-120"/>
-              </a:rPr>
-              <a:t>评分引擎针对用户在终端敲击的指令链路以及 AI 输出的怀疑根因，深度匹配其是否真正捕获了底层的核心故障模式，防范盲目无脑调试。</a:t>
-            </a:r>
-            <a:endParaRPr lang="en-US" sz="1300" dirty="0"/>
-          </a:p>
-        </p:txBody>
-      </p:sp>
-      <p:sp>
-        <p:nvSpPr>
-          <p:cNvPr id="14" name="Shape 12"/>
+              <a:rPr lang="en-US" sz="1250" dirty="0">
+                <a:solidFill>
+                  <a:srgbClr val="94A3B8"/>
+                </a:solidFill>
+                <a:latin typeface="Microsoft YaHei" pitchFamily="34" charset="0"/>
+                <a:ea typeface="Microsoft YaHei" pitchFamily="34" charset="-122"/>
+                <a:cs typeface="Microsoft YaHei" pitchFamily="34" charset="-120"/>
+              </a:rPr>
+              <a:t>评分引擎针对用户在终端敲击的指令历史与 AI 生成的诊断日志进行匹配，准确判定是否真正捕获了核心故障元，阻断盲目无序调试。</a:t>
+            </a:r>
+            <a:endParaRPr lang="en-US" sz="1250" dirty="0"/>
+          </a:p>
+        </p:txBody>
+      </p:sp>
+      <p:sp>
+        <p:nvSpPr>
+          <p:cNvPr id="12" name="Shape 10"/>
           <p:cNvSpPr/>
           <p:nvPr/>
         </p:nvSpPr>
         <p:spPr>
           <a:xfrm>
             <a:off x="548640" y="4023360"/>
-            <a:ext cx="5212080" cy="2103120"/>
+            <a:ext cx="5303520" cy="2103120"/>
           </a:xfrm>
           <a:prstGeom prst="roundRect">
             <a:avLst/>
@@ -5772,14 +5560,14 @@
       </p:sp>
       <p:sp>
         <p:nvSpPr>
-          <p:cNvPr id="15" name="Text 13"/>
+          <p:cNvPr id="13" name="Text 11"/>
           <p:cNvSpPr/>
           <p:nvPr/>
         </p:nvSpPr>
         <p:spPr>
           <a:xfrm>
             <a:off x="822960" y="4206240"/>
-            <a:ext cx="4663440" cy="274320"/>
+            <a:ext cx="4754880" cy="1737360"/>
           </a:xfrm>
           <a:prstGeom prst="rect">
             <a:avLst/>
@@ -5792,6 +5580,9 @@
           <a:lstStyle/>
           <a:p>
             <a:pPr indent="0" marL="0">
+              <a:lnSpc>
+                <a:spcPts val="1800"/>
+              </a:lnSpc>
               <a:buNone/>
             </a:pPr>
             <a:r>
@@ -5803,33 +5594,9 @@
                 <a:ea typeface="Microsoft YaHei" pitchFamily="34" charset="-122"/>
                 <a:cs typeface="Microsoft YaHei" pitchFamily="34" charset="-120"/>
               </a:rPr>
-              <a:t>💸 Cost (开销预算度 - 权重 15%)</a:t>
-            </a:r>
-            <a:endParaRPr lang="en-US" sz="1600" dirty="0"/>
-          </a:p>
-        </p:txBody>
-      </p:sp>
-      <p:sp>
-        <p:nvSpPr>
-          <p:cNvPr id="16" name="Text 14"/>
-          <p:cNvSpPr/>
-          <p:nvPr/>
-        </p:nvSpPr>
-        <p:spPr>
-          <a:xfrm>
-            <a:off x="822960" y="4572000"/>
-            <a:ext cx="4663440" cy="1371600"/>
-          </a:xfrm>
-          <a:prstGeom prst="rect">
-            <a:avLst/>
-          </a:prstGeom>
-          <a:noFill/>
-          <a:ln/>
-        </p:spPr>
-        <p:txBody>
-          <a:bodyPr wrap="square" rtlCol="0" anchor="ctr"/>
-          <a:lstStyle/>
-          <a:p>
+              <a:t>💸 Cost (开销预算度 - 权重 15%)
+</a:t>
+            </a:r>
             <a:pPr indent="0" marL="0">
               <a:lnSpc>
                 <a:spcPts val="1800"/>
@@ -5837,30 +5604,30 @@
               <a:buNone/>
             </a:pPr>
             <a:r>
-              <a:rPr lang="en-US" sz="1300" dirty="0">
-                <a:solidFill>
-                  <a:srgbClr val="F8FAFC"/>
-                </a:solidFill>
-                <a:latin typeface="Microsoft YaHei" pitchFamily="34" charset="0"/>
-                <a:ea typeface="Microsoft YaHei" pitchFamily="34" charset="-122"/>
-                <a:cs typeface="Microsoft YaHei" pitchFamily="34" charset="-120"/>
-              </a:rPr>
-              <a:t>引入虚拟资金预算机制。人类每敲击一次更改状态的操作，或者 AI 每调用一次大模型都会扣除预算，惩罚高开销盲目排障，倡导精准打击。</a:t>
-            </a:r>
-            <a:endParaRPr lang="en-US" sz="1300" dirty="0"/>
-          </a:p>
-        </p:txBody>
-      </p:sp>
-      <p:sp>
-        <p:nvSpPr>
-          <p:cNvPr id="17" name="Shape 15"/>
-          <p:cNvSpPr/>
-          <p:nvPr/>
-        </p:nvSpPr>
-        <p:spPr>
-          <a:xfrm>
-            <a:off x="6400800" y="4023360"/>
-            <a:ext cx="5212080" cy="2103120"/>
+              <a:rPr lang="en-US" sz="1250" dirty="0">
+                <a:solidFill>
+                  <a:srgbClr val="94A3B8"/>
+                </a:solidFill>
+                <a:latin typeface="Microsoft YaHei" pitchFamily="34" charset="0"/>
+                <a:ea typeface="Microsoft YaHei" pitchFamily="34" charset="-122"/>
+                <a:cs typeface="Microsoft YaHei" pitchFamily="34" charset="-120"/>
+              </a:rPr>
+              <a:t>引入虚拟资金预算机制。人类每敲入更改状态指令，或者 AI 每轮交互调用均会扣除预算。惩罚盲目暴利运维，倡导一击即中。</a:t>
+            </a:r>
+            <a:endParaRPr lang="en-US" sz="1250" dirty="0"/>
+          </a:p>
+        </p:txBody>
+      </p:sp>
+      <p:sp>
+        <p:nvSpPr>
+          <p:cNvPr id="14" name="Shape 12"/>
+          <p:cNvSpPr/>
+          <p:nvPr/>
+        </p:nvSpPr>
+        <p:spPr>
+          <a:xfrm>
+            <a:off x="6309360" y="4023360"/>
+            <a:ext cx="5303520" cy="2103120"/>
           </a:xfrm>
           <a:prstGeom prst="roundRect">
             <a:avLst/>
@@ -5873,14 +5640,14 @@
       </p:sp>
       <p:sp>
         <p:nvSpPr>
-          <p:cNvPr id="18" name="Text 16"/>
-          <p:cNvSpPr/>
-          <p:nvPr/>
-        </p:nvSpPr>
-        <p:spPr>
-          <a:xfrm>
-            <a:off x="6675120" y="4206240"/>
-            <a:ext cx="4663440" cy="274320"/>
+          <p:cNvPr id="15" name="Text 13"/>
+          <p:cNvSpPr/>
+          <p:nvPr/>
+        </p:nvSpPr>
+        <p:spPr>
+          <a:xfrm>
+            <a:off x="6583680" y="4206240"/>
+            <a:ext cx="4754880" cy="1737360"/>
           </a:xfrm>
           <a:prstGeom prst="rect">
             <a:avLst/>
@@ -5893,6 +5660,9 @@
           <a:lstStyle/>
           <a:p>
             <a:pPr indent="0" marL="0">
+              <a:lnSpc>
+                <a:spcPts val="1800"/>
+              </a:lnSpc>
               <a:buNone/>
             </a:pPr>
             <a:r>
@@ -5904,33 +5674,9 @@
                 <a:ea typeface="Microsoft YaHei" pitchFamily="34" charset="-122"/>
                 <a:cs typeface="Microsoft YaHei" pitchFamily="34" charset="-120"/>
               </a:rPr>
-              <a:t>📋 Standard (操作规范度 - 权重 15%)</a:t>
-            </a:r>
-            <a:endParaRPr lang="en-US" sz="1600" dirty="0"/>
-          </a:p>
-        </p:txBody>
-      </p:sp>
-      <p:sp>
-        <p:nvSpPr>
-          <p:cNvPr id="19" name="Text 17"/>
-          <p:cNvSpPr/>
-          <p:nvPr/>
-        </p:nvSpPr>
-        <p:spPr>
-          <a:xfrm>
-            <a:off x="6675120" y="4572000"/>
-            <a:ext cx="4663440" cy="1371600"/>
-          </a:xfrm>
-          <a:prstGeom prst="rect">
-            <a:avLst/>
-          </a:prstGeom>
-          <a:noFill/>
-          <a:ln/>
-        </p:spPr>
-        <p:txBody>
-          <a:bodyPr wrap="square" rtlCol="0" anchor="ctr"/>
-          <a:lstStyle/>
-          <a:p>
+              <a:t>📋 Standard (操作规范度 - 权重 15%)
+</a:t>
+            </a:r>
             <a:pPr indent="0" marL="0">
               <a:lnSpc>
                 <a:spcPts val="1800"/>
@@ -5938,17 +5684,17 @@
               <a:buNone/>
             </a:pPr>
             <a:r>
-              <a:rPr lang="en-US" sz="1300" dirty="0">
-                <a:solidFill>
-                  <a:srgbClr val="F8FAFC"/>
-                </a:solidFill>
-                <a:latin typeface="Microsoft YaHei" pitchFamily="34" charset="0"/>
-                <a:ea typeface="Microsoft YaHei" pitchFamily="34" charset="-122"/>
-                <a:cs typeface="Microsoft YaHei" pitchFamily="34" charset="-120"/>
-              </a:rPr>
-              <a:t>系统全量追踪并匹配指令的健全度。排查语法错误、无效命令或冗余调阅。高分倡导以极其专业的姿态书写生产级运维脚本。</a:t>
-            </a:r>
-            <a:endParaRPr lang="en-US" sz="1300" dirty="0"/>
+              <a:rPr lang="en-US" sz="1250" dirty="0">
+                <a:solidFill>
+                  <a:srgbClr val="94A3B8"/>
+                </a:solidFill>
+                <a:latin typeface="Microsoft YaHei" pitchFamily="34" charset="0"/>
+                <a:ea typeface="Microsoft YaHei" pitchFamily="34" charset="-122"/>
+                <a:cs typeface="Microsoft YaHei" pitchFamily="34" charset="-120"/>
+              </a:rPr>
+              <a:t>全面监控输入的语法错误、冗余指令和无意义获取。以极其严谨的标准规范日常操作作风，培养高水平 SRE 极客底色。</a:t>
+            </a:r>
+            <a:endParaRPr lang="en-US" sz="1250" dirty="0"/>
           </a:p>
         </p:txBody>
       </p:sp>
@@ -6149,8 +5895,8 @@
         </p:nvSpPr>
         <p:spPr>
           <a:xfrm>
-            <a:off x="548640" y="1645920"/>
-            <a:ext cx="5212080" cy="4389120"/>
+            <a:off x="548640" y="1463040"/>
+            <a:ext cx="5303520" cy="4663440"/>
           </a:xfrm>
           <a:prstGeom prst="roundRect">
             <a:avLst/>
@@ -6169,8 +5915,8 @@
         </p:nvSpPr>
         <p:spPr>
           <a:xfrm>
-            <a:off x="822960" y="1828800"/>
-            <a:ext cx="4663440" cy="365760"/>
+            <a:off x="822960" y="1645920"/>
+            <a:ext cx="4754880" cy="4297680"/>
           </a:xfrm>
           <a:prstGeom prst="rect">
             <a:avLst/>
@@ -6183,6 +5929,9 @@
           <a:lstStyle/>
           <a:p>
             <a:pPr indent="0" marL="0">
+              <a:lnSpc>
+                <a:spcPts val="1600"/>
+              </a:lnSpc>
               <a:buNone/>
             </a:pPr>
             <a:r>
@@ -6194,173 +5943,130 @@
                 <a:ea typeface="Microsoft YaHei" pitchFamily="34" charset="-122"/>
                 <a:cs typeface="Microsoft YaHei" pitchFamily="34" charset="-120"/>
               </a:rPr>
-              <a:t>🚀 物理靶场注入实测表现</a:t>
-            </a:r>
-            <a:endParaRPr lang="en-US" sz="1800" dirty="0"/>
-          </a:p>
-        </p:txBody>
-      </p:sp>
-      <p:sp>
-        <p:nvSpPr>
-          <p:cNvPr id="9" name="Text 7"/>
-          <p:cNvSpPr/>
-          <p:nvPr/>
-        </p:nvSpPr>
-        <p:spPr>
-          <a:xfrm>
-            <a:off x="822960" y="2286000"/>
-            <a:ext cx="4663440" cy="3566160"/>
-          </a:xfrm>
-          <a:prstGeom prst="rect">
-            <a:avLst/>
-          </a:prstGeom>
-          <a:noFill/>
-          <a:ln/>
-        </p:spPr>
-        <p:txBody>
-          <a:bodyPr wrap="square" rtlCol="0" anchor="ctr"/>
-          <a:lstStyle/>
-          <a:p>
-            <a:pPr indent="0" marL="0">
-              <a:lnSpc>
-                <a:spcPts val="1800"/>
+              <a:t>🚀 物理靶场真实注入实测
+</a:t>
+            </a:r>
+            <a:pPr indent="0" marL="0">
+              <a:lnSpc>
+                <a:spcPts val="1600"/>
+              </a:lnSpc>
+              <a:buNone/>
+            </a:pPr>
+            <a:r>
+              <a:rPr lang="en-US" sz="1250" b="1" dirty="0">
+                <a:solidFill>
+                  <a:srgbClr val="F8FAFC"/>
+                </a:solidFill>
+                <a:latin typeface="Microsoft YaHei" pitchFamily="34" charset="0"/>
+                <a:ea typeface="Microsoft YaHei" pitchFamily="34" charset="-122"/>
+                <a:cs typeface="Microsoft YaHei" pitchFamily="34" charset="-120"/>
+              </a:rPr>
+              <a:t>• 简单模式 (Easy Mode)：
+</a:t>
+            </a:r>
+            <a:pPr indent="0" marL="0">
+              <a:lnSpc>
+                <a:spcPts val="1600"/>
               </a:lnSpc>
               <a:buNone/>
             </a:pPr>
             <a:r>
               <a:rPr lang="en-US" sz="1250" dirty="0">
                 <a:solidFill>
+                  <a:srgbClr val="94A3B8"/>
+                </a:solidFill>
+                <a:latin typeface="Microsoft YaHei" pitchFamily="34" charset="0"/>
+                <a:ea typeface="Microsoft YaHei" pitchFamily="34" charset="-122"/>
+                <a:cs typeface="Microsoft YaHei" pitchFamily="34" charset="-120"/>
+              </a:rPr>
+              <a:t>  - 注入 order-service 磁盘满故障，产生 64MB 临时大文件。
+</a:t>
+            </a:r>
+            <a:pPr indent="0" marL="0">
+              <a:lnSpc>
+                <a:spcPts val="1600"/>
+              </a:lnSpc>
+              <a:buNone/>
+            </a:pPr>
+            <a:r>
+              <a:rPr lang="en-US" sz="1250" dirty="0">
+                <a:solidFill>
+                  <a:srgbClr val="94A3B8"/>
+                </a:solidFill>
+                <a:latin typeface="Microsoft YaHei" pitchFamily="34" charset="0"/>
+                <a:ea typeface="Microsoft YaHei" pitchFamily="34" charset="-122"/>
+                <a:cs typeface="Microsoft YaHei" pitchFamily="34" charset="-120"/>
+              </a:rPr>
+              <a:t>  - 人类利用终端精准捕获大文件路径并极速删除，集群立即无感自愈。
+</a:t>
+            </a:r>
+            <a:pPr indent="0" marL="0">
+              <a:lnSpc>
+                <a:spcPts val="1600"/>
+              </a:lnSpc>
+              <a:buNone/>
+            </a:pPr>
+            <a:r>
+              <a:rPr lang="en-US" sz="1250" b="1" dirty="0">
+                <a:solidFill>
                   <a:srgbClr val="F8FAFC"/>
                 </a:solidFill>
                 <a:latin typeface="Microsoft YaHei" pitchFamily="34" charset="0"/>
                 <a:ea typeface="Microsoft YaHei" pitchFamily="34" charset="-122"/>
                 <a:cs typeface="Microsoft YaHei" pitchFamily="34" charset="-120"/>
               </a:rPr>
-              <a:t>• 简单模式 (Easy Mode)：</a:t>
+              <a:t>• 困难模式 (Hard Mode)：
+</a:t>
+            </a:r>
+            <a:pPr indent="0" marL="0">
+              <a:lnSpc>
+                <a:spcPts val="1600"/>
+              </a:lnSpc>
+              <a:buNone/>
+            </a:pPr>
+            <a:r>
+              <a:rPr lang="en-US" sz="1250" dirty="0">
+                <a:solidFill>
+                  <a:srgbClr val="94A3B8"/>
+                </a:solidFill>
+                <a:latin typeface="Microsoft YaHei" pitchFamily="34" charset="0"/>
+                <a:ea typeface="Microsoft YaHei" pitchFamily="34" charset="-122"/>
+                <a:cs typeface="Microsoft YaHei" pitchFamily="34" charset="-120"/>
+              </a:rPr>
+              <a:t>  - 并发注入 product-service 缩零与 order-service PID 1 终结崩溃。
+</a:t>
+            </a:r>
+            <a:pPr indent="0" marL="0">
+              <a:lnSpc>
+                <a:spcPts val="1600"/>
+              </a:lnSpc>
+              <a:buNone/>
+            </a:pPr>
+            <a:r>
+              <a:rPr lang="en-US" sz="1250" dirty="0">
+                <a:solidFill>
+                  <a:srgbClr val="94A3B8"/>
+                </a:solidFill>
+                <a:latin typeface="Microsoft YaHei" pitchFamily="34" charset="0"/>
+                <a:ea typeface="Microsoft YaHei" pitchFamily="34" charset="-122"/>
+                <a:cs typeface="Microsoft YaHei" pitchFamily="34" charset="-120"/>
+              </a:rPr>
+              <a:t>  - AI 利用 OODA 基线差异分析，20 秒内推荐并下发 `kubectl scale` 重构 product-service，展现了卓越的自动化应急响应力。</a:t>
             </a:r>
             <a:endParaRPr lang="en-US" sz="1250" dirty="0"/>
           </a:p>
-          <a:p>
-            <a:pPr indent="0" marL="0">
-              <a:lnSpc>
-                <a:spcPts val="1800"/>
-              </a:lnSpc>
-              <a:buNone/>
-            </a:pPr>
-            <a:r>
-              <a:rPr lang="en-US" sz="1250" dirty="0">
-                <a:solidFill>
-                  <a:srgbClr val="F8FAFC"/>
-                </a:solidFill>
-                <a:latin typeface="Microsoft YaHei" pitchFamily="34" charset="0"/>
-                <a:ea typeface="Microsoft YaHei" pitchFamily="34" charset="-122"/>
-                <a:cs typeface="Microsoft YaHei" pitchFamily="34" charset="-120"/>
-              </a:rPr>
-              <a:t>  - 故障注入：向 order-service 注入 disk-full，在容器中创建 64MB 临时大文件。</a:t>
-            </a:r>
-            <a:endParaRPr lang="en-US" sz="1250" dirty="0"/>
-          </a:p>
-          <a:p>
-            <a:pPr indent="0" marL="0">
-              <a:lnSpc>
-                <a:spcPts val="1800"/>
-              </a:lnSpc>
-              <a:buNone/>
-            </a:pPr>
-            <a:r>
-              <a:rPr lang="en-US" sz="1250" dirty="0">
-                <a:solidFill>
-                  <a:srgbClr val="F8FAFC"/>
-                </a:solidFill>
-                <a:latin typeface="Microsoft YaHei" pitchFamily="34" charset="0"/>
-                <a:ea typeface="Microsoft YaHei" pitchFamily="34" charset="-122"/>
-                <a:cs typeface="Microsoft YaHei" pitchFamily="34" charset="-120"/>
-              </a:rPr>
-              <a:t>  - 排障情况：通过 `kubectl exec ... ls -lh /tmp` 精准检测并执行 `rm` 删除，健康度成功归 100%。</a:t>
-            </a:r>
-            <a:endParaRPr lang="en-US" sz="1250" dirty="0"/>
-          </a:p>
-          <a:p>
-            <a:pPr indent="0" marL="0">
-              <a:lnSpc>
-                <a:spcPts val="1800"/>
-              </a:lnSpc>
-              <a:buNone/>
-            </a:pPr>
-            <a:endParaRPr lang="en-US" sz="1250" dirty="0"/>
-          </a:p>
-          <a:p>
-            <a:pPr indent="0" marL="0">
-              <a:lnSpc>
-                <a:spcPts val="1800"/>
-              </a:lnSpc>
-              <a:buNone/>
-            </a:pPr>
-            <a:r>
-              <a:rPr lang="en-US" sz="1250" dirty="0">
-                <a:solidFill>
-                  <a:srgbClr val="F8FAFC"/>
-                </a:solidFill>
-                <a:latin typeface="Microsoft YaHei" pitchFamily="34" charset="0"/>
-                <a:ea typeface="Microsoft YaHei" pitchFamily="34" charset="-122"/>
-                <a:cs typeface="Microsoft YaHei" pitchFamily="34" charset="-120"/>
-              </a:rPr>
-              <a:t>• 困难模式 (Hard Mode)：</a:t>
-            </a:r>
-            <a:endParaRPr lang="en-US" sz="1250" dirty="0"/>
-          </a:p>
-          <a:p>
-            <a:pPr indent="0" marL="0">
-              <a:lnSpc>
-                <a:spcPts val="1800"/>
-              </a:lnSpc>
-              <a:buNone/>
-            </a:pPr>
-            <a:r>
-              <a:rPr lang="en-US" sz="1250" dirty="0">
-                <a:solidFill>
-                  <a:srgbClr val="F8FAFC"/>
-                </a:solidFill>
-                <a:latin typeface="Microsoft YaHei" pitchFamily="34" charset="0"/>
-                <a:ea typeface="Microsoft YaHei" pitchFamily="34" charset="-122"/>
-                <a:cs typeface="Microsoft YaHei" pitchFamily="34" charset="-120"/>
-              </a:rPr>
-              <a:t>  - 故障注入：`product-service` 缩容到 0 且同时对 `order-service` 执行 `kill 1` 主进程终结崩溃。</a:t>
-            </a:r>
-            <a:endParaRPr lang="en-US" sz="1250" dirty="0"/>
-          </a:p>
-          <a:p>
-            <a:pPr indent="0" marL="0">
-              <a:lnSpc>
-                <a:spcPts val="1800"/>
-              </a:lnSpc>
-              <a:buNone/>
-            </a:pPr>
-            <a:r>
-              <a:rPr lang="en-US" sz="1250" dirty="0">
-                <a:solidFill>
-                  <a:srgbClr val="F8FAFC"/>
-                </a:solidFill>
-                <a:latin typeface="Microsoft YaHei" pitchFamily="34" charset="0"/>
-                <a:ea typeface="Microsoft YaHei" pitchFamily="34" charset="-122"/>
-                <a:cs typeface="Microsoft YaHei" pitchFamily="34" charset="-120"/>
-              </a:rPr>
-              <a:t>  - AI 自动诊断决策：AI 差异化快照精准切中 product-service 无 Pod 现状，智能匹配 `kubectl scale ... --replicas=2` 瞬间拉起，多故障在 30 秒内得到全面自愈。</a:t>
-            </a:r>
-            <a:endParaRPr lang="en-US" sz="1250" dirty="0"/>
-          </a:p>
-        </p:txBody>
-      </p:sp>
-      <p:sp>
-        <p:nvSpPr>
-          <p:cNvPr id="10" name="Shape 8"/>
-          <p:cNvSpPr/>
-          <p:nvPr/>
-        </p:nvSpPr>
-        <p:spPr>
-          <a:xfrm>
-            <a:off x="6400800" y="1645920"/>
-            <a:ext cx="5212080" cy="4389120"/>
+        </p:txBody>
+      </p:sp>
+      <p:sp>
+        <p:nvSpPr>
+          <p:cNvPr id="9" name="Shape 7"/>
+          <p:cNvSpPr/>
+          <p:nvPr/>
+        </p:nvSpPr>
+        <p:spPr>
+          <a:xfrm>
+            <a:off x="6309360" y="1463040"/>
+            <a:ext cx="5303520" cy="4663440"/>
           </a:xfrm>
           <a:prstGeom prst="roundRect">
             <a:avLst/>
@@ -6373,14 +6079,14 @@
       </p:sp>
       <p:sp>
         <p:nvSpPr>
-          <p:cNvPr id="11" name="Text 9"/>
-          <p:cNvSpPr/>
-          <p:nvPr/>
-        </p:nvSpPr>
-        <p:spPr>
-          <a:xfrm>
-            <a:off x="6675120" y="1828800"/>
-            <a:ext cx="4663440" cy="365760"/>
+          <p:cNvPr id="10" name="Text 8"/>
+          <p:cNvSpPr/>
+          <p:nvPr/>
+        </p:nvSpPr>
+        <p:spPr>
+          <a:xfrm>
+            <a:off x="6583680" y="1645920"/>
+            <a:ext cx="4754880" cy="4297680"/>
           </a:xfrm>
           <a:prstGeom prst="rect">
             <a:avLst/>
@@ -6393,6 +6099,9 @@
           <a:lstStyle/>
           <a:p>
             <a:pPr indent="0" marL="0">
+              <a:lnSpc>
+                <a:spcPts val="1400"/>
+              </a:lnSpc>
               <a:buNone/>
             </a:pPr>
             <a:r>
@@ -6404,41 +6113,17 @@
                 <a:ea typeface="Microsoft YaHei" pitchFamily="34" charset="-122"/>
                 <a:cs typeface="Microsoft YaHei" pitchFamily="34" charset="-120"/>
               </a:rPr>
-              <a:t>🧪 健全的自动化测试组件</a:t>
-            </a:r>
-            <a:endParaRPr lang="en-US" sz="1800" dirty="0"/>
-          </a:p>
-        </p:txBody>
-      </p:sp>
-      <p:sp>
-        <p:nvSpPr>
-          <p:cNvPr id="12" name="Text 10"/>
-          <p:cNvSpPr/>
-          <p:nvPr/>
-        </p:nvSpPr>
-        <p:spPr>
-          <a:xfrm>
-            <a:off x="6675120" y="2286000"/>
-            <a:ext cx="4663440" cy="3566160"/>
-          </a:xfrm>
-          <a:prstGeom prst="rect">
-            <a:avLst/>
-          </a:prstGeom>
-          <a:noFill/>
-          <a:ln/>
-        </p:spPr>
-        <p:txBody>
-          <a:bodyPr wrap="square" rtlCol="0" anchor="ctr"/>
-          <a:lstStyle/>
-          <a:p>
-            <a:pPr indent="0" marL="0">
-              <a:lnSpc>
-                <a:spcPts val="1600"/>
-              </a:lnSpc>
-              <a:buNone/>
-            </a:pPr>
-            <a:r>
-              <a:rPr lang="en-US" sz="1250" dirty="0">
+              <a:t>🧪 健全的自动化测试组件
+</a:t>
+            </a:r>
+            <a:pPr indent="0" marL="0">
+              <a:lnSpc>
+                <a:spcPts val="1400"/>
+              </a:lnSpc>
+              <a:buNone/>
+            </a:pPr>
+            <a:r>
+              <a:rPr lang="en-US" sz="1200" b="1" dirty="0">
                 <a:solidFill>
                   <a:srgbClr val="F8FAFC"/>
                 </a:solidFill>
@@ -6446,28 +6131,107 @@
                 <a:ea typeface="Microsoft YaHei" pitchFamily="34" charset="-122"/>
                 <a:cs typeface="Microsoft YaHei" pitchFamily="34" charset="-120"/>
               </a:rPr>
-              <a:t>项目引入了基于 Jest 框架的工业级端到端与集成自动化测试：</a:t>
-            </a:r>
-            <a:endParaRPr lang="en-US" sz="1250" dirty="0"/>
-          </a:p>
-          <a:p>
-            <a:pPr indent="0" marL="0">
-              <a:lnSpc>
-                <a:spcPts val="1600"/>
-              </a:lnSpc>
-              <a:buNone/>
-            </a:pPr>
-            <a:endParaRPr lang="en-US" sz="1250" dirty="0"/>
-          </a:p>
-          <a:p>
-            <a:pPr indent="0" marL="0">
-              <a:lnSpc>
-                <a:spcPts val="1600"/>
-              </a:lnSpc>
-              <a:buNone/>
-            </a:pPr>
-            <a:r>
-              <a:rPr lang="en-US" sz="1250" dirty="0">
+              <a:t>项目引入了基于 Jest 框架的工业级自动化测试覆盖：
+</a:t>
+            </a:r>
+            <a:pPr indent="0" marL="0">
+              <a:lnSpc>
+                <a:spcPts val="1400"/>
+              </a:lnSpc>
+              <a:buNone/>
+            </a:pPr>
+            <a:r>
+              <a:rPr lang="en-US" sz="1200" dirty="0">
+                <a:solidFill>
+                  <a:srgbClr val="34D399"/>
+                </a:solidFill>
+                <a:latin typeface="Microsoft YaHei" pitchFamily="34" charset="0"/>
+                <a:ea typeface="Microsoft YaHei" pitchFamily="34" charset="-122"/>
+                <a:cs typeface="Microsoft YaHei" pitchFamily="34" charset="-120"/>
+              </a:rPr>
+              <a:t>✔ PASS  __tests__/scorer.test.js
+</a:t>
+            </a:r>
+            <a:pPr indent="0" marL="0">
+              <a:lnSpc>
+                <a:spcPts val="1400"/>
+              </a:lnSpc>
+              <a:buNone/>
+            </a:pPr>
+            <a:r>
+              <a:rPr lang="en-US" sz="1200" dirty="0">
+                <a:solidFill>
+                  <a:srgbClr val="34D399"/>
+                </a:solidFill>
+                <a:latin typeface="Microsoft YaHei" pitchFamily="34" charset="0"/>
+                <a:ea typeface="Microsoft YaHei" pitchFamily="34" charset="-122"/>
+                <a:cs typeface="Microsoft YaHei" pitchFamily="34" charset="-120"/>
+              </a:rPr>
+              <a:t>✔ PASS  __tests__/chaos-injector.test.js
+</a:t>
+            </a:r>
+            <a:pPr indent="0" marL="0">
+              <a:lnSpc>
+                <a:spcPts val="1400"/>
+              </a:lnSpc>
+              <a:buNone/>
+            </a:pPr>
+            <a:r>
+              <a:rPr lang="en-US" sz="1200" dirty="0">
+                <a:solidFill>
+                  <a:srgbClr val="34D399"/>
+                </a:solidFill>
+                <a:latin typeface="Microsoft YaHei" pitchFamily="34" charset="0"/>
+                <a:ea typeface="Microsoft YaHei" pitchFamily="34" charset="-122"/>
+                <a:cs typeface="Microsoft YaHei" pitchFamily="34" charset="-120"/>
+              </a:rPr>
+              <a:t>✔ PASS  __tests__/terminal-proxy.test.js
+</a:t>
+            </a:r>
+            <a:pPr indent="0" marL="0">
+              <a:lnSpc>
+                <a:spcPts val="1400"/>
+              </a:lnSpc>
+              <a:buNone/>
+            </a:pPr>
+            <a:r>
+              <a:rPr lang="en-US" sz="1200" dirty="0">
+                <a:solidFill>
+                  <a:srgbClr val="34D399"/>
+                </a:solidFill>
+                <a:latin typeface="Microsoft YaHei" pitchFamily="34" charset="0"/>
+                <a:ea typeface="Microsoft YaHei" pitchFamily="34" charset="-122"/>
+                <a:cs typeface="Microsoft YaHei" pitchFamily="34" charset="-120"/>
+              </a:rPr>
+              <a:t>✔ PASS  __tests__/ai-engine.test.js
+</a:t>
+            </a:r>
+            <a:pPr indent="0" marL="0">
+              <a:lnSpc>
+                <a:spcPts val="1400"/>
+              </a:lnSpc>
+              <a:buNone/>
+            </a:pPr>
+            <a:r>
+              <a:rPr lang="en-US" sz="1200" dirty="0">
+                <a:solidFill>
+                  <a:srgbClr val="34D399"/>
+                </a:solidFill>
+                <a:latin typeface="Microsoft YaHei" pitchFamily="34" charset="0"/>
+                <a:ea typeface="Microsoft YaHei" pitchFamily="34" charset="-122"/>
+                <a:cs typeface="Microsoft YaHei" pitchFamily="34" charset="-120"/>
+              </a:rPr>
+              <a:t>✔ PASS  __tests__/integration.test.js
+</a:t>
+            </a:r>
+            <a:pPr indent="0" marL="0">
+              <a:lnSpc>
+                <a:spcPts val="1400"/>
+              </a:lnSpc>
+              <a:buNone/>
+            </a:pPr>
+            <a:r>
+              <a:rPr lang="en-US" sz="1200" b="1" dirty="0">
                 <a:solidFill>
                   <a:srgbClr val="F8FAFC"/>
                 </a:solidFill>
@@ -6475,19 +6239,34 @@
                 <a:ea typeface="Microsoft YaHei" pitchFamily="34" charset="-122"/>
                 <a:cs typeface="Microsoft YaHei" pitchFamily="34" charset="-120"/>
               </a:rPr>
-              <a:t>✔ PASS  __tests__/scorer.test.js</a:t>
-            </a:r>
-            <a:endParaRPr lang="en-US" sz="1250" dirty="0"/>
-          </a:p>
-          <a:p>
-            <a:pPr indent="0" marL="0">
-              <a:lnSpc>
-                <a:spcPts val="1600"/>
-              </a:lnSpc>
-              <a:buNone/>
-            </a:pPr>
-            <a:r>
-              <a:rPr lang="en-US" sz="1250" dirty="0">
+              <a:t>• 累计通过：</a:t>
+            </a:r>
+            <a:pPr indent="0" marL="0">
+              <a:lnSpc>
+                <a:spcPts val="1400"/>
+              </a:lnSpc>
+              <a:buNone/>
+            </a:pPr>
+            <a:r>
+              <a:rPr lang="en-US" sz="1200" dirty="0">
+                <a:solidFill>
+                  <a:srgbClr val="94A3B8"/>
+                </a:solidFill>
+                <a:latin typeface="Microsoft YaHei" pitchFamily="34" charset="0"/>
+                <a:ea typeface="Microsoft YaHei" pitchFamily="34" charset="-122"/>
+                <a:cs typeface="Microsoft YaHei" pitchFamily="34" charset="-120"/>
+              </a:rPr>
+              <a:t>108 个底层核心单元/集成测试用例。
+</a:t>
+            </a:r>
+            <a:pPr indent="0" marL="0">
+              <a:lnSpc>
+                <a:spcPts val="1400"/>
+              </a:lnSpc>
+              <a:buNone/>
+            </a:pPr>
+            <a:r>
+              <a:rPr lang="en-US" sz="1200" b="1" dirty="0">
                 <a:solidFill>
                   <a:srgbClr val="F8FAFC"/>
                 </a:solidFill>
@@ -6495,178 +6274,26 @@
                 <a:ea typeface="Microsoft YaHei" pitchFamily="34" charset="-122"/>
                 <a:cs typeface="Microsoft YaHei" pitchFamily="34" charset="-120"/>
               </a:rPr>
-              <a:t>✔ PASS  __tests__/chaos-injector.test.js</a:t>
-            </a:r>
-            <a:endParaRPr lang="en-US" sz="1250" dirty="0"/>
-          </a:p>
-          <a:p>
-            <a:pPr indent="0" marL="0">
-              <a:lnSpc>
-                <a:spcPts val="1600"/>
-              </a:lnSpc>
-              <a:buNone/>
-            </a:pPr>
-            <a:r>
-              <a:rPr lang="en-US" sz="1250" dirty="0">
-                <a:solidFill>
-                  <a:srgbClr val="F8FAFC"/>
-                </a:solidFill>
-                <a:latin typeface="Microsoft YaHei" pitchFamily="34" charset="0"/>
-                <a:ea typeface="Microsoft YaHei" pitchFamily="34" charset="-122"/>
-                <a:cs typeface="Microsoft YaHei" pitchFamily="34" charset="-120"/>
-              </a:rPr>
-              <a:t>✔ PASS  __tests__/terminal-proxy.test.js</a:t>
-            </a:r>
-            <a:endParaRPr lang="en-US" sz="1250" dirty="0"/>
-          </a:p>
-          <a:p>
-            <a:pPr indent="0" marL="0">
-              <a:lnSpc>
-                <a:spcPts val="1600"/>
-              </a:lnSpc>
-              <a:buNone/>
-            </a:pPr>
-            <a:r>
-              <a:rPr lang="en-US" sz="1250" dirty="0">
-                <a:solidFill>
-                  <a:srgbClr val="F8FAFC"/>
-                </a:solidFill>
-                <a:latin typeface="Microsoft YaHei" pitchFamily="34" charset="0"/>
-                <a:ea typeface="Microsoft YaHei" pitchFamily="34" charset="-122"/>
-                <a:cs typeface="Microsoft YaHei" pitchFamily="34" charset="-120"/>
-              </a:rPr>
-              <a:t>✔ PASS  __tests__/cost-calculator.test.js</a:t>
-            </a:r>
-            <a:endParaRPr lang="en-US" sz="1250" dirty="0"/>
-          </a:p>
-          <a:p>
-            <a:pPr indent="0" marL="0">
-              <a:lnSpc>
-                <a:spcPts val="1600"/>
-              </a:lnSpc>
-              <a:buNone/>
-            </a:pPr>
-            <a:r>
-              <a:rPr lang="en-US" sz="1250" dirty="0">
-                <a:solidFill>
-                  <a:srgbClr val="F8FAFC"/>
-                </a:solidFill>
-                <a:latin typeface="Microsoft YaHei" pitchFamily="34" charset="0"/>
-                <a:ea typeface="Microsoft YaHei" pitchFamily="34" charset="-122"/>
-                <a:cs typeface="Microsoft YaHei" pitchFamily="34" charset="-120"/>
-              </a:rPr>
-              <a:t>✔ PASS  __tests__/ai-engine.test.js</a:t>
-            </a:r>
-            <a:endParaRPr lang="en-US" sz="1250" dirty="0"/>
-          </a:p>
-          <a:p>
-            <a:pPr indent="0" marL="0">
-              <a:lnSpc>
-                <a:spcPts val="1600"/>
-              </a:lnSpc>
-              <a:buNone/>
-            </a:pPr>
-            <a:r>
-              <a:rPr lang="en-US" sz="1250" dirty="0">
-                <a:solidFill>
-                  <a:srgbClr val="F8FAFC"/>
-                </a:solidFill>
-                <a:latin typeface="Microsoft YaHei" pitchFamily="34" charset="0"/>
-                <a:ea typeface="Microsoft YaHei" pitchFamily="34" charset="-122"/>
-                <a:cs typeface="Microsoft YaHei" pitchFamily="34" charset="-120"/>
-              </a:rPr>
-              <a:t>✔ PASS  __tests__/integration.test.js</a:t>
-            </a:r>
-            <a:endParaRPr lang="en-US" sz="1250" dirty="0"/>
-          </a:p>
-          <a:p>
-            <a:pPr indent="0" marL="0">
-              <a:lnSpc>
-                <a:spcPts val="1600"/>
-              </a:lnSpc>
-              <a:buNone/>
-            </a:pPr>
-            <a:r>
-              <a:rPr lang="en-US" sz="1250" dirty="0">
-                <a:solidFill>
-                  <a:srgbClr val="F8FAFC"/>
-                </a:solidFill>
-                <a:latin typeface="Microsoft YaHei" pitchFamily="34" charset="0"/>
-                <a:ea typeface="Microsoft YaHei" pitchFamily="34" charset="-122"/>
-                <a:cs typeface="Microsoft YaHei" pitchFamily="34" charset="-120"/>
-              </a:rPr>
-              <a:t>✔ PASS  __tests__/k8s-client.test.js</a:t>
-            </a:r>
-            <a:endParaRPr lang="en-US" sz="1250" dirty="0"/>
-          </a:p>
-          <a:p>
-            <a:pPr indent="0" marL="0">
-              <a:lnSpc>
-                <a:spcPts val="1600"/>
-              </a:lnSpc>
-              <a:buNone/>
-            </a:pPr>
-            <a:r>
-              <a:rPr lang="en-US" sz="1250" dirty="0">
-                <a:solidFill>
-                  <a:srgbClr val="F8FAFC"/>
-                </a:solidFill>
-                <a:latin typeface="Microsoft YaHei" pitchFamily="34" charset="0"/>
-                <a:ea typeface="Microsoft YaHei" pitchFamily="34" charset="-122"/>
-                <a:cs typeface="Microsoft YaHei" pitchFamily="34" charset="-120"/>
-              </a:rPr>
-              <a:t>✔ PASS  __tests__/state-machine.test.js</a:t>
-            </a:r>
-            <a:endParaRPr lang="en-US" sz="1250" dirty="0"/>
-          </a:p>
-          <a:p>
-            <a:pPr indent="0" marL="0">
-              <a:lnSpc>
-                <a:spcPts val="1600"/>
-              </a:lnSpc>
-              <a:buNone/>
-            </a:pPr>
-            <a:endParaRPr lang="en-US" sz="1250" dirty="0"/>
-          </a:p>
-          <a:p>
-            <a:pPr indent="0" marL="0">
-              <a:lnSpc>
-                <a:spcPts val="1600"/>
-              </a:lnSpc>
-              <a:buNone/>
-            </a:pPr>
-            <a:r>
-              <a:rPr lang="en-US" sz="1250" dirty="0">
-                <a:solidFill>
-                  <a:srgbClr val="F8FAFC"/>
-                </a:solidFill>
-                <a:latin typeface="Microsoft YaHei" pitchFamily="34" charset="0"/>
-                <a:ea typeface="Microsoft YaHei" pitchFamily="34" charset="-122"/>
-                <a:cs typeface="Microsoft YaHei" pitchFamily="34" charset="-120"/>
-              </a:rPr>
-              <a:t>• 累计通过：**108 个核心自动化单元/集成测试用例**。</a:t>
-            </a:r>
-            <a:endParaRPr lang="en-US" sz="1250" dirty="0"/>
-          </a:p>
-          <a:p>
-            <a:pPr indent="0" marL="0">
-              <a:lnSpc>
-                <a:spcPts val="1600"/>
-              </a:lnSpc>
-              <a:buNone/>
-            </a:pPr>
-            <a:r>
-              <a:rPr lang="en-US" sz="1250" dirty="0">
-                <a:solidFill>
-                  <a:srgbClr val="F8FAFC"/>
-                </a:solidFill>
-                <a:latin typeface="Microsoft YaHei" pitchFamily="34" charset="0"/>
-                <a:ea typeface="Microsoft YaHei" pitchFamily="34" charset="-122"/>
-                <a:cs typeface="Microsoft YaHei" pitchFamily="34" charset="-120"/>
-              </a:rPr>
-              <a:t>• 覆盖：状态机扭转、快照裁剪算法、危险字符过滤、资金预算扣除等所有底层引擎，健壮度达到了工程级出厂水准。</a:t>
-            </a:r>
-            <a:endParaRPr lang="en-US" sz="1250" dirty="0"/>
+              <a:t>• 高抗覆盖：</a:t>
+            </a:r>
+            <a:pPr indent="0" marL="0">
+              <a:lnSpc>
+                <a:spcPts val="1400"/>
+              </a:lnSpc>
+              <a:buNone/>
+            </a:pPr>
+            <a:r>
+              <a:rPr lang="en-US" sz="1200" dirty="0">
+                <a:solidFill>
+                  <a:srgbClr val="94A3B8"/>
+                </a:solidFill>
+                <a:latin typeface="Microsoft YaHei" pitchFamily="34" charset="0"/>
+                <a:ea typeface="Microsoft YaHei" pitchFamily="34" charset="-122"/>
+                <a:cs typeface="Microsoft YaHei" pitchFamily="34" charset="-120"/>
+              </a:rPr>
+              <a:t>状态机扭转、快照裁剪算法、危险字符过滤、资金预算扣除等，质量达到了极高标准。</a:t>
+            </a:r>
+            <a:endParaRPr lang="en-US" sz="1200" dirty="0"/>
           </a:p>
         </p:txBody>
       </p:sp>
@@ -6867,8 +6494,8 @@
         </p:nvSpPr>
         <p:spPr>
           <a:xfrm>
-            <a:off x="548640" y="1645920"/>
-            <a:ext cx="5212080" cy="4389120"/>
+            <a:off x="548640" y="1463040"/>
+            <a:ext cx="5303520" cy="4663440"/>
           </a:xfrm>
           <a:prstGeom prst="roundRect">
             <a:avLst/>
@@ -6887,8 +6514,8 @@
         </p:nvSpPr>
         <p:spPr>
           <a:xfrm>
-            <a:off x="822960" y="1828800"/>
-            <a:ext cx="4663440" cy="365760"/>
+            <a:off x="822960" y="1645920"/>
+            <a:ext cx="4754880" cy="4297680"/>
           </a:xfrm>
           <a:prstGeom prst="rect">
             <a:avLst/>
@@ -6901,6 +6528,9 @@
           <a:lstStyle/>
           <a:p>
             <a:pPr indent="0" marL="0">
+              <a:lnSpc>
+                <a:spcPts val="1600"/>
+              </a:lnSpc>
               <a:buNone/>
             </a:pPr>
             <a:r>
@@ -6912,41 +6542,17 @@
                 <a:ea typeface="Microsoft YaHei" pitchFamily="34" charset="-122"/>
                 <a:cs typeface="Microsoft YaHei" pitchFamily="34" charset="-120"/>
               </a:rPr>
-              <a:t>🌟 核心收获与心得体会</a:t>
-            </a:r>
-            <a:endParaRPr lang="en-US" sz="1800" dirty="0"/>
-          </a:p>
-        </p:txBody>
-      </p:sp>
-      <p:sp>
-        <p:nvSpPr>
-          <p:cNvPr id="9" name="Text 7"/>
-          <p:cNvSpPr/>
-          <p:nvPr/>
-        </p:nvSpPr>
-        <p:spPr>
-          <a:xfrm>
-            <a:off x="822960" y="2286000"/>
-            <a:ext cx="4663440" cy="3566160"/>
-          </a:xfrm>
-          <a:prstGeom prst="rect">
-            <a:avLst/>
-          </a:prstGeom>
-          <a:noFill/>
-          <a:ln/>
-        </p:spPr>
-        <p:txBody>
-          <a:bodyPr wrap="square" rtlCol="0" anchor="ctr"/>
-          <a:lstStyle/>
-          <a:p>
-            <a:pPr indent="0" marL="0">
-              <a:lnSpc>
-                <a:spcPts val="1800"/>
-              </a:lnSpc>
-              <a:buNone/>
-            </a:pPr>
-            <a:r>
-              <a:rPr lang="en-US" sz="1300" dirty="0">
+              <a:t>🌟 核心收获与心得体会
+</a:t>
+            </a:r>
+            <a:pPr indent="0" marL="0">
+              <a:lnSpc>
+                <a:spcPts val="1600"/>
+              </a:lnSpc>
+              <a:buNone/>
+            </a:pPr>
+            <a:r>
+              <a:rPr lang="en-US" sz="1250" b="1" dirty="0">
                 <a:solidFill>
                   <a:srgbClr val="F8FAFC"/>
                 </a:solidFill>
@@ -6954,28 +6560,34 @@
                 <a:ea typeface="Microsoft YaHei" pitchFamily="34" charset="-122"/>
                 <a:cs typeface="Microsoft YaHei" pitchFamily="34" charset="-120"/>
               </a:rPr>
-              <a:t>• 深化云原生弹性设计思维：“Design for Failure”（面向故障设计）是云计算高可用架构的核心原则。通过混沌演练游戏，切实感受到健康检查、调谐环、副本管理机制的不可或缺。</a:t>
-            </a:r>
-            <a:endParaRPr lang="en-US" sz="1300" dirty="0"/>
-          </a:p>
-          <a:p>
-            <a:pPr indent="0" marL="0">
-              <a:lnSpc>
-                <a:spcPts val="1800"/>
-              </a:lnSpc>
-              <a:buNone/>
-            </a:pPr>
-            <a:endParaRPr lang="en-US" sz="1300" dirty="0"/>
-          </a:p>
-          <a:p>
-            <a:pPr indent="0" marL="0">
-              <a:lnSpc>
-                <a:spcPts val="1800"/>
-              </a:lnSpc>
-              <a:buNone/>
-            </a:pPr>
-            <a:r>
-              <a:rPr lang="en-US" sz="1300" dirty="0">
+              <a:t>• 深化云原生弹性设计思维：</a:t>
+            </a:r>
+            <a:pPr indent="0" marL="0">
+              <a:lnSpc>
+                <a:spcPts val="1600"/>
+              </a:lnSpc>
+              <a:buNone/>
+            </a:pPr>
+            <a:r>
+              <a:rPr lang="en-US" sz="1250" dirty="0">
+                <a:solidFill>
+                  <a:srgbClr val="94A3B8"/>
+                </a:solidFill>
+                <a:latin typeface="Microsoft YaHei" pitchFamily="34" charset="0"/>
+                <a:ea typeface="Microsoft YaHei" pitchFamily="34" charset="-122"/>
+                <a:cs typeface="Microsoft YaHei" pitchFamily="34" charset="-120"/>
+              </a:rPr>
+              <a:t>“Design for Failure”（面向故障设计）是云计算高可用架构的核心原则。通过混沌工程的主动破坏，切实感受到就绪探针、重启策略和自愈环对服务韧性的巨大保障。
+</a:t>
+            </a:r>
+            <a:pPr indent="0" marL="0">
+              <a:lnSpc>
+                <a:spcPts val="1600"/>
+              </a:lnSpc>
+              <a:buNone/>
+            </a:pPr>
+            <a:r>
+              <a:rPr lang="en-US" sz="1250" b="1" dirty="0">
                 <a:solidFill>
                   <a:srgbClr val="F8FAFC"/>
                 </a:solidFill>
@@ -6983,28 +6595,34 @@
                 <a:ea typeface="Microsoft YaHei" pitchFamily="34" charset="-122"/>
                 <a:cs typeface="Microsoft YaHei" pitchFamily="34" charset="-120"/>
               </a:rPr>
-              <a:t>• 掌握大模型云端落地范式：在大模型应用开发中，纯写 Prompt 是远远不够的。通过 Snapshot 剪枝降噪的 RAG 实操，深入体会了业务语境中“高信噪比上下文”对智能体决策的决定性意义。</a:t>
-            </a:r>
-            <a:endParaRPr lang="en-US" sz="1300" dirty="0"/>
-          </a:p>
-          <a:p>
-            <a:pPr indent="0" marL="0">
-              <a:lnSpc>
-                <a:spcPts val="1800"/>
-              </a:lnSpc>
-              <a:buNone/>
-            </a:pPr>
-            <a:endParaRPr lang="en-US" sz="1300" dirty="0"/>
-          </a:p>
-          <a:p>
-            <a:pPr indent="0" marL="0">
-              <a:lnSpc>
-                <a:spcPts val="1800"/>
-              </a:lnSpc>
-              <a:buNone/>
-            </a:pPr>
-            <a:r>
-              <a:rPr lang="en-US" sz="1300" dirty="0">
+              <a:t>• 掌握大模型云端落地范式：</a:t>
+            </a:r>
+            <a:pPr indent="0" marL="0">
+              <a:lnSpc>
+                <a:spcPts val="1600"/>
+              </a:lnSpc>
+              <a:buNone/>
+            </a:pPr>
+            <a:r>
+              <a:rPr lang="en-US" sz="1250" dirty="0">
+                <a:solidFill>
+                  <a:srgbClr val="94A3B8"/>
+                </a:solidFill>
+                <a:latin typeface="Microsoft YaHei" pitchFamily="34" charset="0"/>
+                <a:ea typeface="Microsoft YaHei" pitchFamily="34" charset="-122"/>
+                <a:cs typeface="Microsoft YaHei" pitchFamily="34" charset="-120"/>
+              </a:rPr>
+              <a:t>在 SRE 真实场景中，利用基线差异剪枝实现 75% 裁剪，是防止大模型幻觉与偏航的底层基石。
+</a:t>
+            </a:r>
+            <a:pPr indent="0" marL="0">
+              <a:lnSpc>
+                <a:spcPts val="1600"/>
+              </a:lnSpc>
+              <a:buNone/>
+            </a:pPr>
+            <a:r>
+              <a:rPr lang="en-US" sz="1250" b="1" dirty="0">
                 <a:solidFill>
                   <a:srgbClr val="F8FAFC"/>
                 </a:solidFill>
@@ -7012,22 +6630,39 @@
                 <a:ea typeface="Microsoft YaHei" pitchFamily="34" charset="-122"/>
                 <a:cs typeface="Microsoft YaHei" pitchFamily="34" charset="-120"/>
               </a:rPr>
-              <a:t>• 人机协同演进认知：AI Agent 在结构化可观测数据分析、标准化指令推荐及常规故障处理（自愈）方面具有卓越的爆发速度。</a:t>
-            </a:r>
-            <a:endParaRPr lang="en-US" sz="1300" dirty="0"/>
-          </a:p>
-        </p:txBody>
-      </p:sp>
-      <p:sp>
-        <p:nvSpPr>
-          <p:cNvPr id="10" name="Shape 8"/>
-          <p:cNvSpPr/>
-          <p:nvPr/>
-        </p:nvSpPr>
-        <p:spPr>
-          <a:xfrm>
-            <a:off x="6400800" y="1645920"/>
-            <a:ext cx="5212080" cy="4389120"/>
+              <a:t>• 见证人机协同巨大潜力：</a:t>
+            </a:r>
+            <a:pPr indent="0" marL="0">
+              <a:lnSpc>
+                <a:spcPts val="1600"/>
+              </a:lnSpc>
+              <a:buNone/>
+            </a:pPr>
+            <a:r>
+              <a:rPr lang="en-US" sz="1250" dirty="0">
+                <a:solidFill>
+                  <a:srgbClr val="94A3B8"/>
+                </a:solidFill>
+                <a:latin typeface="Microsoft YaHei" pitchFamily="34" charset="0"/>
+                <a:ea typeface="Microsoft YaHei" pitchFamily="34" charset="-122"/>
+                <a:cs typeface="Microsoft YaHei" pitchFamily="34" charset="-120"/>
+              </a:rPr>
+              <a:t>AI 在结构化状态判断与经典自愈指令执行上具备极速的优势，展现了强大的 AIOps 潜能。</a:t>
+            </a:r>
+            <a:endParaRPr lang="en-US" sz="1250" dirty="0"/>
+          </a:p>
+        </p:txBody>
+      </p:sp>
+      <p:sp>
+        <p:nvSpPr>
+          <p:cNvPr id="9" name="Shape 7"/>
+          <p:cNvSpPr/>
+          <p:nvPr/>
+        </p:nvSpPr>
+        <p:spPr>
+          <a:xfrm>
+            <a:off x="6309360" y="1463040"/>
+            <a:ext cx="5303520" cy="4663440"/>
           </a:xfrm>
           <a:prstGeom prst="roundRect">
             <a:avLst/>
@@ -7040,14 +6675,14 @@
       </p:sp>
       <p:sp>
         <p:nvSpPr>
-          <p:cNvPr id="11" name="Text 9"/>
-          <p:cNvSpPr/>
-          <p:nvPr/>
-        </p:nvSpPr>
-        <p:spPr>
-          <a:xfrm>
-            <a:off x="6675120" y="1828800"/>
-            <a:ext cx="4663440" cy="365760"/>
+          <p:cNvPr id="10" name="Text 8"/>
+          <p:cNvSpPr/>
+          <p:nvPr/>
+        </p:nvSpPr>
+        <p:spPr>
+          <a:xfrm>
+            <a:off x="6583680" y="1645920"/>
+            <a:ext cx="4754880" cy="4297680"/>
           </a:xfrm>
           <a:prstGeom prst="rect">
             <a:avLst/>
@@ -7060,6 +6695,9 @@
           <a:lstStyle/>
           <a:p>
             <a:pPr indent="0" marL="0">
+              <a:lnSpc>
+                <a:spcPts val="1600"/>
+              </a:lnSpc>
               <a:buNone/>
             </a:pPr>
             <a:r>
@@ -7071,41 +6709,17 @@
                 <a:ea typeface="Microsoft YaHei" pitchFamily="34" charset="-122"/>
                 <a:cs typeface="Microsoft YaHei" pitchFamily="34" charset="-120"/>
               </a:rPr>
-              <a:t>🚀 未来演进方向</a:t>
-            </a:r>
-            <a:endParaRPr lang="en-US" sz="1800" dirty="0"/>
-          </a:p>
-        </p:txBody>
-      </p:sp>
-      <p:sp>
-        <p:nvSpPr>
-          <p:cNvPr id="12" name="Text 10"/>
-          <p:cNvSpPr/>
-          <p:nvPr/>
-        </p:nvSpPr>
-        <p:spPr>
-          <a:xfrm>
-            <a:off x="6675120" y="2286000"/>
-            <a:ext cx="4663440" cy="3566160"/>
-          </a:xfrm>
-          <a:prstGeom prst="rect">
-            <a:avLst/>
-          </a:prstGeom>
-          <a:noFill/>
-          <a:ln/>
-        </p:spPr>
-        <p:txBody>
-          <a:bodyPr wrap="square" rtlCol="0" anchor="ctr"/>
-          <a:lstStyle/>
-          <a:p>
-            <a:pPr indent="0" marL="0">
-              <a:lnSpc>
-                <a:spcPts val="1800"/>
-              </a:lnSpc>
-              <a:buNone/>
-            </a:pPr>
-            <a:r>
-              <a:rPr lang="en-US" sz="1300" dirty="0">
+              <a:t>🚀 未来演进方向
+</a:t>
+            </a:r>
+            <a:pPr indent="0" marL="0">
+              <a:lnSpc>
+                <a:spcPts val="1600"/>
+              </a:lnSpc>
+              <a:buNone/>
+            </a:pPr>
+            <a:r>
+              <a:rPr lang="en-US" sz="1250" b="1" dirty="0">
                 <a:solidFill>
                   <a:srgbClr val="F8FAFC"/>
                 </a:solidFill>
@@ -7113,28 +6727,34 @@
                 <a:ea typeface="Microsoft YaHei" pitchFamily="34" charset="-122"/>
                 <a:cs typeface="Microsoft YaHei" pitchFamily="34" charset="-120"/>
               </a:rPr>
-              <a:t>• 引入云原生更细颗粒度监控：目前主要采集 Events 和容器状态。下一步拟深入结合 Prometheus / OpenTelemetry 暴露的数据指标，进行多维度的图谱分析，提供更为细致的可观测性指标。</a:t>
-            </a:r>
-            <a:endParaRPr lang="en-US" sz="1300" dirty="0"/>
-          </a:p>
-          <a:p>
-            <a:pPr indent="0" marL="0">
-              <a:lnSpc>
-                <a:spcPts val="1800"/>
-              </a:lnSpc>
-              <a:buNone/>
-            </a:pPr>
-            <a:endParaRPr lang="en-US" sz="1300" dirty="0"/>
-          </a:p>
-          <a:p>
-            <a:pPr indent="0" marL="0">
-              <a:lnSpc>
-                <a:spcPts val="1800"/>
-              </a:lnSpc>
-              <a:buNone/>
-            </a:pPr>
-            <a:r>
-              <a:rPr lang="en-US" sz="1300" dirty="0">
+              <a:t>• 融入细粒度全链路可观测性指标：</a:t>
+            </a:r>
+            <a:pPr indent="0" marL="0">
+              <a:lnSpc>
+                <a:spcPts val="1600"/>
+              </a:lnSpc>
+              <a:buNone/>
+            </a:pPr>
+            <a:r>
+              <a:rPr lang="en-US" sz="1250" dirty="0">
+                <a:solidFill>
+                  <a:srgbClr val="94A3B8"/>
+                </a:solidFill>
+                <a:latin typeface="Microsoft YaHei" pitchFamily="34" charset="0"/>
+                <a:ea typeface="Microsoft YaHei" pitchFamily="34" charset="-122"/>
+                <a:cs typeface="Microsoft YaHei" pitchFamily="34" charset="-120"/>
+              </a:rPr>
+              <a:t>拟进一步集成 Prometheus 与 OpenTelemetry，将系统时序指标以图谱的形式喂入大模型，支持精准性能调优决策。
+</a:t>
+            </a:r>
+            <a:pPr indent="0" marL="0">
+              <a:lnSpc>
+                <a:spcPts val="1600"/>
+              </a:lnSpc>
+              <a:buNone/>
+            </a:pPr>
+            <a:r>
+              <a:rPr lang="en-US" sz="1250" b="1" dirty="0">
                 <a:solidFill>
                   <a:srgbClr val="F8FAFC"/>
                 </a:solidFill>
@@ -7142,28 +6762,34 @@
                 <a:ea typeface="Microsoft YaHei" pitchFamily="34" charset="-122"/>
                 <a:cs typeface="Microsoft YaHei" pitchFamily="34" charset="-120"/>
               </a:rPr>
-              <a:t>• AI Agent 自主强化学习演练：设计一个支持主动对抗的“博弈 Agent”，实现一边进行自动破坏，另一边进行自愈对抗的“左右互搏”云端混沌竞技盘，进一步推高自愈极限。</a:t>
-            </a:r>
-            <a:endParaRPr lang="en-US" sz="1300" dirty="0"/>
-          </a:p>
-          <a:p>
-            <a:pPr indent="0" marL="0">
-              <a:lnSpc>
-                <a:spcPts val="1800"/>
-              </a:lnSpc>
-              <a:buNone/>
-            </a:pPr>
-            <a:endParaRPr lang="en-US" sz="1300" dirty="0"/>
-          </a:p>
-          <a:p>
-            <a:pPr indent="0" marL="0">
-              <a:lnSpc>
-                <a:spcPts val="1800"/>
-              </a:lnSpc>
-              <a:buNone/>
-            </a:pPr>
-            <a:r>
-              <a:rPr lang="en-US" sz="1300" dirty="0">
+              <a:t>• 智能体左右互搏对抗：</a:t>
+            </a:r>
+            <a:pPr indent="0" marL="0">
+              <a:lnSpc>
+                <a:spcPts val="1600"/>
+              </a:lnSpc>
+              <a:buNone/>
+            </a:pPr>
+            <a:r>
+              <a:rPr lang="en-US" sz="1250" dirty="0">
+                <a:solidFill>
+                  <a:srgbClr val="94A3B8"/>
+                </a:solidFill>
+                <a:latin typeface="Microsoft YaHei" pitchFamily="34" charset="0"/>
+                <a:ea typeface="Microsoft YaHei" pitchFamily="34" charset="-122"/>
+                <a:cs typeface="Microsoft YaHei" pitchFamily="34" charset="-120"/>
+              </a:rPr>
+              <a:t>构建一边主动注入多样故障，另一边实时监控修复的“双智能体自进化对抗沙箱”，持续寻找微服务弹性的极限边界。
+</a:t>
+            </a:r>
+            <a:pPr indent="0" marL="0">
+              <a:lnSpc>
+                <a:spcPts val="1600"/>
+              </a:lnSpc>
+              <a:buNone/>
+            </a:pPr>
+            <a:r>
+              <a:rPr lang="en-US" sz="1250" b="1" dirty="0">
                 <a:solidFill>
                   <a:srgbClr val="F8FAFC"/>
                 </a:solidFill>
@@ -7171,9 +6797,26 @@
                 <a:ea typeface="Microsoft YaHei" pitchFamily="34" charset="-122"/>
                 <a:cs typeface="Microsoft YaHei" pitchFamily="34" charset="-120"/>
               </a:rPr>
-              <a:t>• 向分布式多集群沙箱挺进：将单集群 Namespace 拓扑演进为多云、异构多集群网络下的混沌消防演习靶场，承载更大规模的微服务雪崩实操。</a:t>
-            </a:r>
-            <a:endParaRPr lang="en-US" sz="1300" dirty="0"/>
+              <a:t>• 分布式多集群消防演练：</a:t>
+            </a:r>
+            <a:pPr indent="0" marL="0">
+              <a:lnSpc>
+                <a:spcPts val="1600"/>
+              </a:lnSpc>
+              <a:buNone/>
+            </a:pPr>
+            <a:r>
+              <a:rPr lang="en-US" sz="1250" dirty="0">
+                <a:solidFill>
+                  <a:srgbClr val="94A3B8"/>
+                </a:solidFill>
+                <a:latin typeface="Microsoft YaHei" pitchFamily="34" charset="0"/>
+                <a:ea typeface="Microsoft YaHei" pitchFamily="34" charset="-122"/>
+                <a:cs typeface="Microsoft YaHei" pitchFamily="34" charset="-120"/>
+              </a:rPr>
+              <a:t>拟将单集群扩展为多云混合异构分布式靶场，实现跨广域网络雪崩环境的超大规模混沌演练。</a:t>
+            </a:r>
+            <a:endParaRPr lang="en-US" sz="1250" dirty="0"/>
           </a:p>
         </p:txBody>
       </p:sp>

</xml_diff>